<commit_message>
adding units and cleaning slides
</commit_message>
<xml_diff>
--- a/Project-3/individual-models/data/presentation.pptx
+++ b/Project-3/individual-models/data/presentation.pptx
@@ -16,6 +16,7 @@
     <p:sldId id="264" r:id="rId10"/>
     <p:sldId id="265" r:id="rId11"/>
     <p:sldId id="266" r:id="rId12"/>
+    <p:sldId id="267" r:id="rId13"/>
   </p:sldIdLst>
   <p:sldSz cx="9144000" cy="5143500" type="screen16x9"/>
   <p:notesSz cx="6858000" cy="9144000"/>
@@ -3200,7 +3201,7 @@
             </a:pPr>
             <a:r>
               <a:rPr/>
-              <a:t>Technical Lead</a:t>
+              <a:t>Project Manager</a:t>
             </a:r>
           </a:p>
         </p:txBody>
@@ -3247,6 +3248,53 @@
             </a:pPr>
             <a:r>
               <a:rPr/>
+              <a:t>Technical Lead</a:t>
+            </a:r>
+          </a:p>
+        </p:txBody>
+      </p:sp>
+    </p:spTree>
+  </p:cSld>
+</p:sld>
+</file>
+
+<file path=ppt/slides/slide12.xml><?xml version="1.0" encoding="utf-8"?>
+<p:sld xmlns:a="http://schemas.openxmlformats.org/drawingml/2006/main" xmlns:r="http://schemas.openxmlformats.org/officeDocument/2006/relationships" xmlns:p="http://schemas.openxmlformats.org/presentationml/2006/main">
+  <p:cSld>
+    <p:spTree>
+      <p:nvGrpSpPr>
+        <p:cNvPr id="1" name=""/>
+        <p:cNvGrpSpPr/>
+        <p:nvPr/>
+      </p:nvGrpSpPr>
+      <p:grpSpPr>
+        <a:xfrm>
+          <a:off x="0" y="0"/>
+          <a:ext cx="0" cy="0"/>
+          <a:chOff x="0" y="0"/>
+          <a:chExt cx="0" cy="0"/>
+        </a:xfrm>
+      </p:grpSpPr>
+      <p:sp>
+        <p:nvSpPr>
+          <p:cNvPr id="2" name="Title 1"/>
+          <p:cNvSpPr>
+            <a:spLocks noGrp="1"/>
+          </p:cNvSpPr>
+          <p:nvPr>
+            <p:ph type="title"/>
+          </p:nvPr>
+        </p:nvSpPr>
+        <p:spPr/>
+        <p:txBody>
+          <a:bodyPr/>
+          <a:lstStyle/>
+          <a:p>
+            <a:pPr lvl="0" indent="0" marL="0">
+              <a:buNone/>
+            </a:pPr>
+            <a:r>
+              <a:rPr/>
               <a:t>Quality Assurance</a:t>
             </a:r>
           </a:p>
@@ -3374,20 +3422,6 @@
               <a:t>DO_BH (Diameter at Breast Height [Outside Bark]): Diameter of the tree stem measured at breast height (4.5 feet or 1.37 meters above ground) including bark. This is the standard foresty measurement “DBH (outside bark)” and is the primary size variable used in nearly all allometric biomass models. This is measured in inches.</a:t>
             </a:r>
           </a:p>
-          <a:p>
-            <a:pPr lvl="0"/>
-            <a:r>
-              <a:rPr/>
-              <a:t>HT_TOT (Total Tree Height): The total height of the tree measured from ground level to the top of the crown. Used as a second size metric in volume and biomass modeling.This is measured in feet.</a:t>
-            </a:r>
-          </a:p>
-          <a:p>
-            <a:pPr lvl="0"/>
-            <a:r>
-              <a:rPr/>
-              <a:t>NEED UNITS (likely KG) STILL TT_DW_CRM (Total Tree Dry Biomass): The total above-ground dry weight of the tree (includes stem wood, stem bark, branches, folliage). This value comes from destructive sampling: the tree was felled, seperated into componenets, oven-dried, and weighed. This variable serves as the response variable (“target”) from biomass prediction.</a:t>
-            </a:r>
-          </a:p>
         </p:txBody>
       </p:sp>
     </p:spTree>
@@ -3396,6 +3430,83 @@
 </file>
 
 <file path=ppt/slides/slide4.xml><?xml version="1.0" encoding="utf-8"?>
+<p:sld xmlns:a="http://schemas.openxmlformats.org/drawingml/2006/main" xmlns:r="http://schemas.openxmlformats.org/officeDocument/2006/relationships" xmlns:p="http://schemas.openxmlformats.org/presentationml/2006/main">
+  <p:cSld>
+    <p:spTree>
+      <p:nvGrpSpPr>
+        <p:cNvPr id="1" name=""/>
+        <p:cNvGrpSpPr/>
+        <p:nvPr/>
+      </p:nvGrpSpPr>
+      <p:grpSpPr>
+        <a:xfrm>
+          <a:off x="0" y="0"/>
+          <a:ext cx="0" cy="0"/>
+          <a:chOff x="0" y="0"/>
+          <a:chExt cx="0" cy="0"/>
+        </a:xfrm>
+      </p:grpSpPr>
+      <p:sp>
+        <p:nvSpPr>
+          <p:cNvPr id="2" name="Title 1"/>
+          <p:cNvSpPr>
+            <a:spLocks noGrp="1"/>
+          </p:cNvSpPr>
+          <p:nvPr>
+            <p:ph type="title"/>
+          </p:nvPr>
+        </p:nvSpPr>
+        <p:spPr/>
+        <p:txBody>
+          <a:bodyPr/>
+          <a:lstStyle/>
+          <a:p>
+            <a:pPr lvl="0" indent="0" marL="0">
+              <a:buNone/>
+            </a:pPr>
+            <a:r>
+              <a:rPr/>
+              <a:t>Data Dictionary Continued</a:t>
+            </a:r>
+          </a:p>
+        </p:txBody>
+      </p:sp>
+      <p:sp>
+        <p:nvSpPr>
+          <p:cNvPr id="3" name="Content Placeholder 2"/>
+          <p:cNvSpPr>
+            <a:spLocks noGrp="1"/>
+          </p:cNvSpPr>
+          <p:nvPr>
+            <p:ph idx="1"/>
+          </p:nvPr>
+        </p:nvSpPr>
+        <p:spPr/>
+        <p:txBody>
+          <a:bodyPr/>
+          <a:lstStyle/>
+          <a:p>
+            <a:pPr lvl="0"/>
+            <a:r>
+              <a:rPr/>
+              <a:t>HT_TOT (Total Tree Height): The total height of the tree measured from ground level to the top of the crown. Used as a second size metric in volume and biomass modeling.This is measured in feet.</a:t>
+            </a:r>
+          </a:p>
+          <a:p>
+            <a:pPr lvl="0"/>
+            <a:r>
+              <a:rPr/>
+              <a:t>NEED UNITS (likely KG) STILL TT_DW_CRM (Total Tree Dry Biomass): The total above-ground dry weight of the tree (includes stem wood, stem bark, branches, folliage). This value comes from destructive sampling: the tree was felled, seperated into componenets, oven-dried, and weighed. This variable serves as the response variable (“target”) from biomass prediction.</a:t>
+            </a:r>
+          </a:p>
+        </p:txBody>
+      </p:sp>
+    </p:spTree>
+  </p:cSld>
+</p:sld>
+</file>
+
+<file path=ppt/slides/slide5.xml><?xml version="1.0" encoding="utf-8"?>
 <p:sld xmlns:a="http://schemas.openxmlformats.org/drawingml/2006/main" xmlns:r="http://schemas.openxmlformats.org/officeDocument/2006/relationships" xmlns:p="http://schemas.openxmlformats.org/presentationml/2006/main">
   <p:cSld>
     <p:spTree>
@@ -3472,7 +3583,7 @@
 </p:sld>
 </file>
 
-<file path=ppt/slides/slide5.xml><?xml version="1.0" encoding="utf-8"?>
+<file path=ppt/slides/slide6.xml><?xml version="1.0" encoding="utf-8"?>
 <p:sld xmlns:a="http://schemas.openxmlformats.org/drawingml/2006/main" xmlns:r="http://schemas.openxmlformats.org/officeDocument/2006/relationships" xmlns:p="http://schemas.openxmlformats.org/presentationml/2006/main">
   <p:cSld>
     <p:spTree>
@@ -3549,7 +3660,7 @@
 </p:sld>
 </file>
 
-<file path=ppt/slides/slide6.xml><?xml version="1.0" encoding="utf-8"?>
+<file path=ppt/slides/slide7.xml><?xml version="1.0" encoding="utf-8"?>
 <p:sld xmlns:a="http://schemas.openxmlformats.org/drawingml/2006/main" xmlns:r="http://schemas.openxmlformats.org/officeDocument/2006/relationships" xmlns:p="http://schemas.openxmlformats.org/presentationml/2006/main">
   <p:cSld>
     <p:spTree>
@@ -3626,7 +3737,7 @@
 </p:sld>
 </file>
 
-<file path=ppt/slides/slide7.xml><?xml version="1.0" encoding="utf-8"?>
+<file path=ppt/slides/slide8.xml><?xml version="1.0" encoding="utf-8"?>
 <p:sld xmlns:a="http://schemas.openxmlformats.org/drawingml/2006/main" xmlns:r="http://schemas.openxmlformats.org/officeDocument/2006/relationships" xmlns:p="http://schemas.openxmlformats.org/presentationml/2006/main">
   <p:cSld>
     <p:spTree>
@@ -3703,53 +3814,6 @@
 </p:sld>
 </file>
 
-<file path=ppt/slides/slide8.xml><?xml version="1.0" encoding="utf-8"?>
-<p:sld xmlns:a="http://schemas.openxmlformats.org/drawingml/2006/main" xmlns:r="http://schemas.openxmlformats.org/officeDocument/2006/relationships" xmlns:p="http://schemas.openxmlformats.org/presentationml/2006/main">
-  <p:cSld>
-    <p:spTree>
-      <p:nvGrpSpPr>
-        <p:cNvPr id="1" name=""/>
-        <p:cNvGrpSpPr/>
-        <p:nvPr/>
-      </p:nvGrpSpPr>
-      <p:grpSpPr>
-        <a:xfrm>
-          <a:off x="0" y="0"/>
-          <a:ext cx="0" cy="0"/>
-          <a:chOff x="0" y="0"/>
-          <a:chExt cx="0" cy="0"/>
-        </a:xfrm>
-      </p:grpSpPr>
-      <p:sp>
-        <p:nvSpPr>
-          <p:cNvPr id="2" name="Title 1"/>
-          <p:cNvSpPr>
-            <a:spLocks noGrp="1"/>
-          </p:cNvSpPr>
-          <p:nvPr>
-            <p:ph type="title"/>
-          </p:nvPr>
-        </p:nvSpPr>
-        <p:spPr/>
-        <p:txBody>
-          <a:bodyPr/>
-          <a:lstStyle/>
-          <a:p>
-            <a:pPr lvl="0" indent="0" marL="0">
-              <a:buNone/>
-            </a:pPr>
-            <a:r>
-              <a:rPr/>
-              <a:t>Domain Expert 3 (Explain the inputs and settings for the best model)</a:t>
-            </a:r>
-          </a:p>
-        </p:txBody>
-      </p:sp>
-    </p:spTree>
-  </p:cSld>
-</p:sld>
-</file>
-
 <file path=ppt/slides/slide9.xml><?xml version="1.0" encoding="utf-8"?>
 <p:sld xmlns:a="http://schemas.openxmlformats.org/drawingml/2006/main" xmlns:r="http://schemas.openxmlformats.org/officeDocument/2006/relationships" xmlns:p="http://schemas.openxmlformats.org/presentationml/2006/main">
   <p:cSld>
@@ -3787,7 +3851,7 @@
             </a:pPr>
             <a:r>
               <a:rPr/>
-              <a:t>Project Manager</a:t>
+              <a:t>Domain Expert 3 (Explain the inputs and settings for the best model)</a:t>
             </a:r>
           </a:p>
         </p:txBody>

</xml_diff>

<commit_message>
modifying github pages deployment to have new link
</commit_message>
<xml_diff>
--- a/Project-3/individual-models/data/presentation.pptx
+++ b/Project-3/individual-models/data/presentation.pptx
@@ -16,6 +16,9 @@
     <p:sldId id="264" r:id="rId10"/>
     <p:sldId id="265" r:id="rId11"/>
     <p:sldId id="266" r:id="rId12"/>
+    <p:sldId id="267" r:id="rId13"/>
+    <p:sldId id="268" r:id="rId14"/>
+    <p:sldId id="269" r:id="rId15"/>
   </p:sldIdLst>
   <p:sldSz cx="9144000" cy="5143500" type="screen16x9"/>
   <p:notesSz cx="6858000" cy="9144000"/>
@@ -3200,7 +3203,7 @@
             </a:pPr>
             <a:r>
               <a:rPr/>
-              <a:t>Technical Lead</a:t>
+              <a:t>Project Manager</a:t>
             </a:r>
           </a:p>
         </p:txBody>
@@ -3247,6 +3250,1481 @@
             </a:pPr>
             <a:r>
               <a:rPr/>
+              <a:t>Technical Lead</a:t>
+            </a:r>
+          </a:p>
+        </p:txBody>
+      </p:sp>
+      <p:graphicFrame>
+        <p:nvGraphicFramePr>
+          <p:cNvPr id="6" name="Content Placeholder 5"/>
+          <p:cNvGraphicFramePr>
+            <a:graphicFrameLocks noGrp="1"/>
+          </p:cNvGraphicFramePr>
+          <p:nvPr>
+            <p:ph idx="1"/>
+          </p:nvPr>
+        </p:nvGraphicFramePr>
+        <p:xfrm>
+          <a:off x="457200" y="1193800"/>
+          <a:ext cx="8229600" cy="3390900"/>
+        </p:xfrm>
+        <a:graphic>
+          <a:graphicData uri="http://schemas.openxmlformats.org/drawingml/2006/table">
+            <a:tbl>
+              <a:tblPr firstRow="1" bandRow="1">
+                <a:tableStyleId>{5C22544A-7EE6-4342-B048-85BDC9FD1C3A}</a:tableStyleId>
+              </a:tblPr>
+              <a:tblGrid>
+                <a:gridCol w="1638300"/>
+                <a:gridCol w="1638300"/>
+                <a:gridCol w="1638300"/>
+                <a:gridCol w="1638300"/>
+                <a:gridCol w="1638300"/>
+              </a:tblGrid>
+              <a:tr h="0">
+                <a:tc>
+                  <a:txBody>
+                    <a:bodyPr/>
+                    <a:lstStyle/>
+                    <a:p>
+                      <a:endParaRPr/>
+                    </a:p>
+                  </a:txBody>
+                  <a:tcPr/>
+                </a:tc>
+                <a:tc>
+                  <a:txBody>
+                    <a:bodyPr/>
+                    <a:lstStyle/>
+                    <a:p>
+                      <a:pPr lvl="0" indent="0" marL="0">
+                        <a:buNone/>
+                      </a:pPr>
+                      <a:r>
+                        <a:rPr/>
+                        <a:t>SPCD</a:t>
+                      </a:r>
+                    </a:p>
+                  </a:txBody>
+                  <a:tcPr/>
+                </a:tc>
+                <a:tc>
+                  <a:txBody>
+                    <a:bodyPr/>
+                    <a:lstStyle/>
+                    <a:p>
+                      <a:pPr lvl="0" indent="0" marL="0">
+                        <a:buNone/>
+                      </a:pPr>
+                      <a:r>
+                        <a:rPr/>
+                        <a:t>DO_BH</a:t>
+                      </a:r>
+                    </a:p>
+                  </a:txBody>
+                  <a:tcPr/>
+                </a:tc>
+                <a:tc>
+                  <a:txBody>
+                    <a:bodyPr/>
+                    <a:lstStyle/>
+                    <a:p>
+                      <a:pPr lvl="0" indent="0" marL="0">
+                        <a:buNone/>
+                      </a:pPr>
+                      <a:r>
+                        <a:rPr/>
+                        <a:t>HT_TOT</a:t>
+                      </a:r>
+                    </a:p>
+                  </a:txBody>
+                  <a:tcPr/>
+                </a:tc>
+                <a:tc>
+                  <a:txBody>
+                    <a:bodyPr/>
+                    <a:lstStyle/>
+                    <a:p>
+                      <a:pPr lvl="0" indent="0" marL="0">
+                        <a:buNone/>
+                      </a:pPr>
+                      <a:r>
+                        <a:rPr/>
+                        <a:t>TT_DW_CRM</a:t>
+                      </a:r>
+                    </a:p>
+                  </a:txBody>
+                  <a:tcPr/>
+                </a:tc>
+              </a:tr>
+              <a:tr h="0">
+                <a:tc>
+                  <a:txBody>
+                    <a:bodyPr/>
+                    <a:lstStyle/>
+                    <a:p>
+                      <a:pPr lvl="0" indent="0" marL="0">
+                        <a:buNone/>
+                      </a:pPr>
+                      <a:r>
+                        <a:rPr/>
+                        <a:t>0</a:t>
+                      </a:r>
+                    </a:p>
+                  </a:txBody>
+                </a:tc>
+                <a:tc>
+                  <a:txBody>
+                    <a:bodyPr/>
+                    <a:lstStyle/>
+                    <a:p>
+                      <a:pPr lvl="0" indent="0" marL="0">
+                        <a:buNone/>
+                      </a:pPr>
+                      <a:r>
+                        <a:rPr/>
+                        <a:t>12</a:t>
+                      </a:r>
+                    </a:p>
+                  </a:txBody>
+                </a:tc>
+                <a:tc>
+                  <a:txBody>
+                    <a:bodyPr/>
+                    <a:lstStyle/>
+                    <a:p>
+                      <a:pPr lvl="0" indent="0" marL="0">
+                        <a:buNone/>
+                      </a:pPr>
+                      <a:r>
+                        <a:rPr/>
+                        <a:t>7.5</a:t>
+                      </a:r>
+                    </a:p>
+                  </a:txBody>
+                </a:tc>
+                <a:tc>
+                  <a:txBody>
+                    <a:bodyPr/>
+                    <a:lstStyle/>
+                    <a:p>
+                      <a:pPr lvl="0" indent="0" marL="0">
+                        <a:buNone/>
+                      </a:pPr>
+                      <a:r>
+                        <a:rPr/>
+                        <a:t>45.2</a:t>
+                      </a:r>
+                    </a:p>
+                  </a:txBody>
+                </a:tc>
+                <a:tc>
+                  <a:txBody>
+                    <a:bodyPr/>
+                    <a:lstStyle/>
+                    <a:p>
+                      <a:pPr lvl="0" indent="0" marL="0">
+                        <a:buNone/>
+                      </a:pPr>
+                      <a:r>
+                        <a:rPr/>
+                        <a:t>178.86</a:t>
+                      </a:r>
+                    </a:p>
+                  </a:txBody>
+                </a:tc>
+              </a:tr>
+              <a:tr h="0">
+                <a:tc>
+                  <a:txBody>
+                    <a:bodyPr/>
+                    <a:lstStyle/>
+                    <a:p>
+                      <a:pPr lvl="0" indent="0" marL="0">
+                        <a:buNone/>
+                      </a:pPr>
+                      <a:r>
+                        <a:rPr/>
+                        <a:t>1</a:t>
+                      </a:r>
+                    </a:p>
+                  </a:txBody>
+                </a:tc>
+                <a:tc>
+                  <a:txBody>
+                    <a:bodyPr/>
+                    <a:lstStyle/>
+                    <a:p>
+                      <a:pPr lvl="0" indent="0" marL="0">
+                        <a:buNone/>
+                      </a:pPr>
+                      <a:r>
+                        <a:rPr/>
+                        <a:t>12</a:t>
+                      </a:r>
+                    </a:p>
+                  </a:txBody>
+                </a:tc>
+                <a:tc>
+                  <a:txBody>
+                    <a:bodyPr/>
+                    <a:lstStyle/>
+                    <a:p>
+                      <a:pPr lvl="0" indent="0" marL="0">
+                        <a:buNone/>
+                      </a:pPr>
+                      <a:r>
+                        <a:rPr/>
+                        <a:t>9.3</a:t>
+                      </a:r>
+                    </a:p>
+                  </a:txBody>
+                </a:tc>
+                <a:tc>
+                  <a:txBody>
+                    <a:bodyPr/>
+                    <a:lstStyle/>
+                    <a:p>
+                      <a:pPr lvl="0" indent="0" marL="0">
+                        <a:buNone/>
+                      </a:pPr>
+                      <a:r>
+                        <a:rPr/>
+                        <a:t>62.7</a:t>
+                      </a:r>
+                    </a:p>
+                  </a:txBody>
+                </a:tc>
+                <a:tc>
+                  <a:txBody>
+                    <a:bodyPr/>
+                    <a:lstStyle/>
+                    <a:p>
+                      <a:pPr lvl="0" indent="0" marL="0">
+                        <a:buNone/>
+                      </a:pPr>
+                      <a:r>
+                        <a:rPr/>
+                        <a:t>323.46</a:t>
+                      </a:r>
+                    </a:p>
+                  </a:txBody>
+                </a:tc>
+              </a:tr>
+              <a:tr h="0">
+                <a:tc>
+                  <a:txBody>
+                    <a:bodyPr/>
+                    <a:lstStyle/>
+                    <a:p>
+                      <a:pPr lvl="0" indent="0" marL="0">
+                        <a:buNone/>
+                      </a:pPr>
+                      <a:r>
+                        <a:rPr/>
+                        <a:t>2</a:t>
+                      </a:r>
+                    </a:p>
+                  </a:txBody>
+                </a:tc>
+                <a:tc>
+                  <a:txBody>
+                    <a:bodyPr/>
+                    <a:lstStyle/>
+                    <a:p>
+                      <a:pPr lvl="0" indent="0" marL="0">
+                        <a:buNone/>
+                      </a:pPr>
+                      <a:r>
+                        <a:rPr/>
+                        <a:t>12</a:t>
+                      </a:r>
+                    </a:p>
+                  </a:txBody>
+                </a:tc>
+                <a:tc>
+                  <a:txBody>
+                    <a:bodyPr/>
+                    <a:lstStyle/>
+                    <a:p>
+                      <a:pPr lvl="0" indent="0" marL="0">
+                        <a:buNone/>
+                      </a:pPr>
+                      <a:r>
+                        <a:rPr/>
+                        <a:t>9.7</a:t>
+                      </a:r>
+                    </a:p>
+                  </a:txBody>
+                </a:tc>
+                <a:tc>
+                  <a:txBody>
+                    <a:bodyPr/>
+                    <a:lstStyle/>
+                    <a:p>
+                      <a:pPr lvl="0" indent="0" marL="0">
+                        <a:buNone/>
+                      </a:pPr>
+                      <a:r>
+                        <a:rPr/>
+                        <a:t>56.7</a:t>
+                      </a:r>
+                    </a:p>
+                  </a:txBody>
+                </a:tc>
+                <a:tc>
+                  <a:txBody>
+                    <a:bodyPr/>
+                    <a:lstStyle/>
+                    <a:p>
+                      <a:pPr lvl="0" indent="0" marL="0">
+                        <a:buNone/>
+                      </a:pPr>
+                      <a:r>
+                        <a:rPr/>
+                        <a:t>342.47</a:t>
+                      </a:r>
+                    </a:p>
+                  </a:txBody>
+                </a:tc>
+              </a:tr>
+              <a:tr h="0">
+                <a:tc>
+                  <a:txBody>
+                    <a:bodyPr/>
+                    <a:lstStyle/>
+                    <a:p>
+                      <a:pPr lvl="0" indent="0" marL="0">
+                        <a:buNone/>
+                      </a:pPr>
+                      <a:r>
+                        <a:rPr/>
+                        <a:t>3</a:t>
+                      </a:r>
+                    </a:p>
+                  </a:txBody>
+                </a:tc>
+                <a:tc>
+                  <a:txBody>
+                    <a:bodyPr/>
+                    <a:lstStyle/>
+                    <a:p>
+                      <a:pPr lvl="0" indent="0" marL="0">
+                        <a:buNone/>
+                      </a:pPr>
+                      <a:r>
+                        <a:rPr/>
+                        <a:t>12</a:t>
+                      </a:r>
+                    </a:p>
+                  </a:txBody>
+                </a:tc>
+                <a:tc>
+                  <a:txBody>
+                    <a:bodyPr/>
+                    <a:lstStyle/>
+                    <a:p>
+                      <a:pPr lvl="0" indent="0" marL="0">
+                        <a:buNone/>
+                      </a:pPr>
+                      <a:r>
+                        <a:rPr/>
+                        <a:t>11.4</a:t>
+                      </a:r>
+                    </a:p>
+                  </a:txBody>
+                </a:tc>
+                <a:tc>
+                  <a:txBody>
+                    <a:bodyPr/>
+                    <a:lstStyle/>
+                    <a:p>
+                      <a:pPr lvl="0" indent="0" marL="0">
+                        <a:buNone/>
+                      </a:pPr>
+                      <a:r>
+                        <a:rPr/>
+                        <a:t>66.1</a:t>
+                      </a:r>
+                    </a:p>
+                  </a:txBody>
+                </a:tc>
+                <a:tc>
+                  <a:txBody>
+                    <a:bodyPr/>
+                    <a:lstStyle/>
+                    <a:p>
+                      <a:pPr lvl="0" indent="0" marL="0">
+                        <a:buNone/>
+                      </a:pPr>
+                      <a:r>
+                        <a:rPr/>
+                        <a:t>499.35</a:t>
+                      </a:r>
+                    </a:p>
+                  </a:txBody>
+                </a:tc>
+              </a:tr>
+              <a:tr h="0">
+                <a:tc>
+                  <a:txBody>
+                    <a:bodyPr/>
+                    <a:lstStyle/>
+                    <a:p>
+                      <a:pPr lvl="0" indent="0" marL="0">
+                        <a:buNone/>
+                      </a:pPr>
+                      <a:r>
+                        <a:rPr/>
+                        <a:t>4</a:t>
+                      </a:r>
+                    </a:p>
+                  </a:txBody>
+                </a:tc>
+                <a:tc>
+                  <a:txBody>
+                    <a:bodyPr/>
+                    <a:lstStyle/>
+                    <a:p>
+                      <a:pPr lvl="0" indent="0" marL="0">
+                        <a:buNone/>
+                      </a:pPr>
+                      <a:r>
+                        <a:rPr/>
+                        <a:t>12</a:t>
+                      </a:r>
+                    </a:p>
+                  </a:txBody>
+                </a:tc>
+                <a:tc>
+                  <a:txBody>
+                    <a:bodyPr/>
+                    <a:lstStyle/>
+                    <a:p>
+                      <a:pPr lvl="0" indent="0" marL="0">
+                        <a:buNone/>
+                      </a:pPr>
+                      <a:r>
+                        <a:rPr/>
+                        <a:t>6.4</a:t>
+                      </a:r>
+                    </a:p>
+                  </a:txBody>
+                </a:tc>
+                <a:tc>
+                  <a:txBody>
+                    <a:bodyPr/>
+                    <a:lstStyle/>
+                    <a:p>
+                      <a:pPr lvl="0" indent="0" marL="0">
+                        <a:buNone/>
+                      </a:pPr>
+                      <a:r>
+                        <a:rPr/>
+                        <a:t>51.8</a:t>
+                      </a:r>
+                    </a:p>
+                  </a:txBody>
+                </a:tc>
+                <a:tc>
+                  <a:txBody>
+                    <a:bodyPr/>
+                    <a:lstStyle/>
+                    <a:p>
+                      <a:pPr lvl="0" indent="0" marL="0">
+                        <a:buNone/>
+                      </a:pPr>
+                      <a:r>
+                        <a:rPr/>
+                        <a:t>113.92</a:t>
+                      </a:r>
+                    </a:p>
+                  </a:txBody>
+                </a:tc>
+              </a:tr>
+            </a:tbl>
+          </a:graphicData>
+        </a:graphic>
+      </p:graphicFrame>
+    </p:spTree>
+  </p:cSld>
+</p:sld>
+</file>
+
+<file path=ppt/slides/slide12.xml><?xml version="1.0" encoding="utf-8"?>
+<p:sld xmlns:a="http://schemas.openxmlformats.org/drawingml/2006/main" xmlns:r="http://schemas.openxmlformats.org/officeDocument/2006/relationships" xmlns:p="http://schemas.openxmlformats.org/presentationml/2006/main">
+  <p:cSld>
+    <p:spTree>
+      <p:nvGrpSpPr>
+        <p:cNvPr id="1" name=""/>
+        <p:cNvGrpSpPr/>
+        <p:nvPr/>
+      </p:nvGrpSpPr>
+      <p:grpSpPr>
+        <a:xfrm>
+          <a:off x="0" y="0"/>
+          <a:ext cx="0" cy="0"/>
+          <a:chOff x="0" y="0"/>
+          <a:chExt cx="0" cy="0"/>
+        </a:xfrm>
+      </p:grpSpPr>
+      <p:graphicFrame>
+        <p:nvGraphicFramePr>
+          <p:cNvPr id="6" name="Content Placeholder 5"/>
+          <p:cNvGraphicFramePr>
+            <a:graphicFrameLocks noGrp="1"/>
+          </p:cNvGraphicFramePr>
+          <p:nvPr>
+            <p:ph idx="1"/>
+          </p:nvPr>
+        </p:nvGraphicFramePr>
+        <p:xfrm>
+          <a:off x="457200" y="1193800"/>
+          <a:ext cx="8229600" cy="3390900"/>
+        </p:xfrm>
+        <a:graphic>
+          <a:graphicData uri="http://schemas.openxmlformats.org/drawingml/2006/table">
+            <a:tbl>
+              <a:tblPr firstRow="1" bandRow="1">
+                <a:tableStyleId>{5C22544A-7EE6-4342-B048-85BDC9FD1C3A}</a:tableStyleId>
+              </a:tblPr>
+              <a:tblGrid>
+                <a:gridCol w="2743200"/>
+                <a:gridCol w="2743200"/>
+                <a:gridCol w="2743200"/>
+              </a:tblGrid>
+              <a:tr h="0">
+                <a:tc>
+                  <a:txBody>
+                    <a:bodyPr/>
+                    <a:lstStyle/>
+                    <a:p>
+                      <a:endParaRPr/>
+                    </a:p>
+                  </a:txBody>
+                  <a:tcPr/>
+                </a:tc>
+                <a:tc>
+                  <a:txBody>
+                    <a:bodyPr/>
+                    <a:lstStyle/>
+                    <a:p>
+                      <a:pPr lvl="0" indent="0" marL="0">
+                        <a:buNone/>
+                      </a:pPr>
+                      <a:r>
+                        <a:rPr/>
+                        <a:t>SPCD</a:t>
+                      </a:r>
+                    </a:p>
+                  </a:txBody>
+                  <a:tcPr/>
+                </a:tc>
+                <a:tc>
+                  <a:txBody>
+                    <a:bodyPr/>
+                    <a:lstStyle/>
+                    <a:p>
+                      <a:pPr lvl="0" indent="0" marL="0">
+                        <a:buNone/>
+                      </a:pPr>
+                      <a:r>
+                        <a:rPr/>
+                        <a:t>COMMON_NAME</a:t>
+                      </a:r>
+                    </a:p>
+                  </a:txBody>
+                  <a:tcPr/>
+                </a:tc>
+              </a:tr>
+              <a:tr h="0">
+                <a:tc>
+                  <a:txBody>
+                    <a:bodyPr/>
+                    <a:lstStyle/>
+                    <a:p>
+                      <a:pPr lvl="0" indent="0" marL="0">
+                        <a:buNone/>
+                      </a:pPr>
+                      <a:r>
+                        <a:rPr/>
+                        <a:t>0</a:t>
+                      </a:r>
+                    </a:p>
+                  </a:txBody>
+                </a:tc>
+                <a:tc>
+                  <a:txBody>
+                    <a:bodyPr/>
+                    <a:lstStyle/>
+                    <a:p>
+                      <a:pPr lvl="0" indent="0" marL="0">
+                        <a:buNone/>
+                      </a:pPr>
+                      <a:r>
+                        <a:rPr/>
+                        <a:t>10</a:t>
+                      </a:r>
+                    </a:p>
+                  </a:txBody>
+                </a:tc>
+                <a:tc>
+                  <a:txBody>
+                    <a:bodyPr/>
+                    <a:lstStyle/>
+                    <a:p>
+                      <a:pPr lvl="0" indent="0" marL="0">
+                        <a:buNone/>
+                      </a:pPr>
+                      <a:r>
+                        <a:rPr/>
+                        <a:t>fir spp.</a:t>
+                      </a:r>
+                    </a:p>
+                  </a:txBody>
+                </a:tc>
+              </a:tr>
+              <a:tr h="0">
+                <a:tc>
+                  <a:txBody>
+                    <a:bodyPr/>
+                    <a:lstStyle/>
+                    <a:p>
+                      <a:pPr lvl="0" indent="0" marL="0">
+                        <a:buNone/>
+                      </a:pPr>
+                      <a:r>
+                        <a:rPr/>
+                        <a:t>1</a:t>
+                      </a:r>
+                    </a:p>
+                  </a:txBody>
+                </a:tc>
+                <a:tc>
+                  <a:txBody>
+                    <a:bodyPr/>
+                    <a:lstStyle/>
+                    <a:p>
+                      <a:pPr lvl="0" indent="0" marL="0">
+                        <a:buNone/>
+                      </a:pPr>
+                      <a:r>
+                        <a:rPr/>
+                        <a:t>11</a:t>
+                      </a:r>
+                    </a:p>
+                  </a:txBody>
+                </a:tc>
+                <a:tc>
+                  <a:txBody>
+                    <a:bodyPr/>
+                    <a:lstStyle/>
+                    <a:p>
+                      <a:pPr lvl="0" indent="0" marL="0">
+                        <a:buNone/>
+                      </a:pPr>
+                      <a:r>
+                        <a:rPr/>
+                        <a:t>Pacific silver fir</a:t>
+                      </a:r>
+                    </a:p>
+                  </a:txBody>
+                </a:tc>
+              </a:tr>
+              <a:tr h="0">
+                <a:tc>
+                  <a:txBody>
+                    <a:bodyPr/>
+                    <a:lstStyle/>
+                    <a:p>
+                      <a:pPr lvl="0" indent="0" marL="0">
+                        <a:buNone/>
+                      </a:pPr>
+                      <a:r>
+                        <a:rPr/>
+                        <a:t>2</a:t>
+                      </a:r>
+                    </a:p>
+                  </a:txBody>
+                </a:tc>
+                <a:tc>
+                  <a:txBody>
+                    <a:bodyPr/>
+                    <a:lstStyle/>
+                    <a:p>
+                      <a:pPr lvl="0" indent="0" marL="0">
+                        <a:buNone/>
+                      </a:pPr>
+                      <a:r>
+                        <a:rPr/>
+                        <a:t>12</a:t>
+                      </a:r>
+                    </a:p>
+                  </a:txBody>
+                </a:tc>
+                <a:tc>
+                  <a:txBody>
+                    <a:bodyPr/>
+                    <a:lstStyle/>
+                    <a:p>
+                      <a:pPr lvl="0" indent="0" marL="0">
+                        <a:buNone/>
+                      </a:pPr>
+                      <a:r>
+                        <a:rPr/>
+                        <a:t>balsam fir</a:t>
+                      </a:r>
+                    </a:p>
+                  </a:txBody>
+                </a:tc>
+              </a:tr>
+              <a:tr h="0">
+                <a:tc>
+                  <a:txBody>
+                    <a:bodyPr/>
+                    <a:lstStyle/>
+                    <a:p>
+                      <a:pPr lvl="0" indent="0" marL="0">
+                        <a:buNone/>
+                      </a:pPr>
+                      <a:r>
+                        <a:rPr/>
+                        <a:t>3</a:t>
+                      </a:r>
+                    </a:p>
+                  </a:txBody>
+                </a:tc>
+                <a:tc>
+                  <a:txBody>
+                    <a:bodyPr/>
+                    <a:lstStyle/>
+                    <a:p>
+                      <a:pPr lvl="0" indent="0" marL="0">
+                        <a:buNone/>
+                      </a:pPr>
+                      <a:r>
+                        <a:rPr/>
+                        <a:t>14</a:t>
+                      </a:r>
+                    </a:p>
+                  </a:txBody>
+                </a:tc>
+                <a:tc>
+                  <a:txBody>
+                    <a:bodyPr/>
+                    <a:lstStyle/>
+                    <a:p>
+                      <a:pPr lvl="0" indent="0" marL="0">
+                        <a:buNone/>
+                      </a:pPr>
+                      <a:r>
+                        <a:rPr/>
+                        <a:t>Santa Lucia or bristlecone fir</a:t>
+                      </a:r>
+                    </a:p>
+                  </a:txBody>
+                </a:tc>
+              </a:tr>
+              <a:tr h="0">
+                <a:tc>
+                  <a:txBody>
+                    <a:bodyPr/>
+                    <a:lstStyle/>
+                    <a:p>
+                      <a:pPr lvl="0" indent="0" marL="0">
+                        <a:buNone/>
+                      </a:pPr>
+                      <a:r>
+                        <a:rPr/>
+                        <a:t>4</a:t>
+                      </a:r>
+                    </a:p>
+                  </a:txBody>
+                </a:tc>
+                <a:tc>
+                  <a:txBody>
+                    <a:bodyPr/>
+                    <a:lstStyle/>
+                    <a:p>
+                      <a:pPr lvl="0" indent="0" marL="0">
+                        <a:buNone/>
+                      </a:pPr>
+                      <a:r>
+                        <a:rPr/>
+                        <a:t>15</a:t>
+                      </a:r>
+                    </a:p>
+                  </a:txBody>
+                </a:tc>
+                <a:tc>
+                  <a:txBody>
+                    <a:bodyPr/>
+                    <a:lstStyle/>
+                    <a:p>
+                      <a:pPr lvl="0" indent="0" marL="0">
+                        <a:buNone/>
+                      </a:pPr>
+                      <a:r>
+                        <a:rPr/>
+                        <a:t>white fir</a:t>
+                      </a:r>
+                    </a:p>
+                  </a:txBody>
+                </a:tc>
+              </a:tr>
+            </a:tbl>
+          </a:graphicData>
+        </a:graphic>
+      </p:graphicFrame>
+    </p:spTree>
+  </p:cSld>
+</p:sld>
+</file>
+
+<file path=ppt/slides/slide13.xml><?xml version="1.0" encoding="utf-8"?>
+<p:sld xmlns:a="http://schemas.openxmlformats.org/drawingml/2006/main" xmlns:r="http://schemas.openxmlformats.org/officeDocument/2006/relationships" xmlns:p="http://schemas.openxmlformats.org/presentationml/2006/main">
+  <p:cSld>
+    <p:spTree>
+      <p:nvGrpSpPr>
+        <p:cNvPr id="1" name=""/>
+        <p:cNvGrpSpPr/>
+        <p:nvPr/>
+      </p:nvGrpSpPr>
+      <p:grpSpPr>
+        <a:xfrm>
+          <a:off x="0" y="0"/>
+          <a:ext cx="0" cy="0"/>
+          <a:chOff x="0" y="0"/>
+          <a:chExt cx="0" cy="0"/>
+        </a:xfrm>
+      </p:grpSpPr>
+      <p:graphicFrame>
+        <p:nvGraphicFramePr>
+          <p:cNvPr id="6" name="Content Placeholder 5"/>
+          <p:cNvGraphicFramePr>
+            <a:graphicFrameLocks noGrp="1"/>
+          </p:cNvGraphicFramePr>
+          <p:nvPr>
+            <p:ph idx="1"/>
+          </p:nvPr>
+        </p:nvGraphicFramePr>
+        <p:xfrm>
+          <a:off x="457200" y="1193800"/>
+          <a:ext cx="8229600" cy="3390900"/>
+        </p:xfrm>
+        <a:graphic>
+          <a:graphicData uri="http://schemas.openxmlformats.org/drawingml/2006/table">
+            <a:tbl>
+              <a:tblPr firstRow="1" bandRow="1">
+                <a:tableStyleId>{5C22544A-7EE6-4342-B048-85BDC9FD1C3A}</a:tableStyleId>
+              </a:tblPr>
+              <a:tblGrid>
+                <a:gridCol w="1371600"/>
+                <a:gridCol w="1371600"/>
+                <a:gridCol w="1371600"/>
+                <a:gridCol w="1371600"/>
+                <a:gridCol w="1371600"/>
+                <a:gridCol w="1371600"/>
+              </a:tblGrid>
+              <a:tr h="0">
+                <a:tc>
+                  <a:txBody>
+                    <a:bodyPr/>
+                    <a:lstStyle/>
+                    <a:p>
+                      <a:endParaRPr/>
+                    </a:p>
+                  </a:txBody>
+                  <a:tcPr/>
+                </a:tc>
+                <a:tc>
+                  <a:txBody>
+                    <a:bodyPr/>
+                    <a:lstStyle/>
+                    <a:p>
+                      <a:pPr lvl="0" indent="0" marL="0">
+                        <a:buNone/>
+                      </a:pPr>
+                      <a:r>
+                        <a:rPr/>
+                        <a:t>SPCD</a:t>
+                      </a:r>
+                    </a:p>
+                  </a:txBody>
+                  <a:tcPr/>
+                </a:tc>
+                <a:tc>
+                  <a:txBody>
+                    <a:bodyPr/>
+                    <a:lstStyle/>
+                    <a:p>
+                      <a:pPr lvl="0" indent="0" marL="0">
+                        <a:buNone/>
+                      </a:pPr>
+                      <a:r>
+                        <a:rPr/>
+                        <a:t>DO_BH</a:t>
+                      </a:r>
+                    </a:p>
+                  </a:txBody>
+                  <a:tcPr/>
+                </a:tc>
+                <a:tc>
+                  <a:txBody>
+                    <a:bodyPr/>
+                    <a:lstStyle/>
+                    <a:p>
+                      <a:pPr lvl="0" indent="0" marL="0">
+                        <a:buNone/>
+                      </a:pPr>
+                      <a:r>
+                        <a:rPr/>
+                        <a:t>HT_TOT</a:t>
+                      </a:r>
+                    </a:p>
+                  </a:txBody>
+                  <a:tcPr/>
+                </a:tc>
+                <a:tc>
+                  <a:txBody>
+                    <a:bodyPr/>
+                    <a:lstStyle/>
+                    <a:p>
+                      <a:pPr lvl="0" indent="0" marL="0">
+                        <a:buNone/>
+                      </a:pPr>
+                      <a:r>
+                        <a:rPr/>
+                        <a:t>TT_DW_CRM</a:t>
+                      </a:r>
+                    </a:p>
+                  </a:txBody>
+                  <a:tcPr/>
+                </a:tc>
+                <a:tc>
+                  <a:txBody>
+                    <a:bodyPr/>
+                    <a:lstStyle/>
+                    <a:p>
+                      <a:pPr lvl="0" indent="0" marL="0">
+                        <a:buNone/>
+                      </a:pPr>
+                      <a:r>
+                        <a:rPr/>
+                        <a:t>COMMON_NAME</a:t>
+                      </a:r>
+                    </a:p>
+                  </a:txBody>
+                  <a:tcPr/>
+                </a:tc>
+              </a:tr>
+              <a:tr h="0">
+                <a:tc>
+                  <a:txBody>
+                    <a:bodyPr/>
+                    <a:lstStyle/>
+                    <a:p>
+                      <a:pPr lvl="0" indent="0" marL="0">
+                        <a:buNone/>
+                      </a:pPr>
+                      <a:r>
+                        <a:rPr/>
+                        <a:t>0</a:t>
+                      </a:r>
+                    </a:p>
+                  </a:txBody>
+                </a:tc>
+                <a:tc>
+                  <a:txBody>
+                    <a:bodyPr/>
+                    <a:lstStyle/>
+                    <a:p>
+                      <a:pPr lvl="0" indent="0" marL="0">
+                        <a:buNone/>
+                      </a:pPr>
+                      <a:r>
+                        <a:rPr/>
+                        <a:t>12</a:t>
+                      </a:r>
+                    </a:p>
+                  </a:txBody>
+                </a:tc>
+                <a:tc>
+                  <a:txBody>
+                    <a:bodyPr/>
+                    <a:lstStyle/>
+                    <a:p>
+                      <a:pPr lvl="0" indent="0" marL="0">
+                        <a:buNone/>
+                      </a:pPr>
+                      <a:r>
+                        <a:rPr/>
+                        <a:t>7.5</a:t>
+                      </a:r>
+                    </a:p>
+                  </a:txBody>
+                </a:tc>
+                <a:tc>
+                  <a:txBody>
+                    <a:bodyPr/>
+                    <a:lstStyle/>
+                    <a:p>
+                      <a:pPr lvl="0" indent="0" marL="0">
+                        <a:buNone/>
+                      </a:pPr>
+                      <a:r>
+                        <a:rPr/>
+                        <a:t>45.2</a:t>
+                      </a:r>
+                    </a:p>
+                  </a:txBody>
+                </a:tc>
+                <a:tc>
+                  <a:txBody>
+                    <a:bodyPr/>
+                    <a:lstStyle/>
+                    <a:p>
+                      <a:pPr lvl="0" indent="0" marL="0">
+                        <a:buNone/>
+                      </a:pPr>
+                      <a:r>
+                        <a:rPr/>
+                        <a:t>178.86</a:t>
+                      </a:r>
+                    </a:p>
+                  </a:txBody>
+                </a:tc>
+                <a:tc>
+                  <a:txBody>
+                    <a:bodyPr/>
+                    <a:lstStyle/>
+                    <a:p>
+                      <a:pPr lvl="0" indent="0" marL="0">
+                        <a:buNone/>
+                      </a:pPr>
+                      <a:r>
+                        <a:rPr/>
+                        <a:t>balsam fir</a:t>
+                      </a:r>
+                    </a:p>
+                  </a:txBody>
+                </a:tc>
+              </a:tr>
+              <a:tr h="0">
+                <a:tc>
+                  <a:txBody>
+                    <a:bodyPr/>
+                    <a:lstStyle/>
+                    <a:p>
+                      <a:pPr lvl="0" indent="0" marL="0">
+                        <a:buNone/>
+                      </a:pPr>
+                      <a:r>
+                        <a:rPr/>
+                        <a:t>1</a:t>
+                      </a:r>
+                    </a:p>
+                  </a:txBody>
+                </a:tc>
+                <a:tc>
+                  <a:txBody>
+                    <a:bodyPr/>
+                    <a:lstStyle/>
+                    <a:p>
+                      <a:pPr lvl="0" indent="0" marL="0">
+                        <a:buNone/>
+                      </a:pPr>
+                      <a:r>
+                        <a:rPr/>
+                        <a:t>12</a:t>
+                      </a:r>
+                    </a:p>
+                  </a:txBody>
+                </a:tc>
+                <a:tc>
+                  <a:txBody>
+                    <a:bodyPr/>
+                    <a:lstStyle/>
+                    <a:p>
+                      <a:pPr lvl="0" indent="0" marL="0">
+                        <a:buNone/>
+                      </a:pPr>
+                      <a:r>
+                        <a:rPr/>
+                        <a:t>9.3</a:t>
+                      </a:r>
+                    </a:p>
+                  </a:txBody>
+                </a:tc>
+                <a:tc>
+                  <a:txBody>
+                    <a:bodyPr/>
+                    <a:lstStyle/>
+                    <a:p>
+                      <a:pPr lvl="0" indent="0" marL="0">
+                        <a:buNone/>
+                      </a:pPr>
+                      <a:r>
+                        <a:rPr/>
+                        <a:t>62.7</a:t>
+                      </a:r>
+                    </a:p>
+                  </a:txBody>
+                </a:tc>
+                <a:tc>
+                  <a:txBody>
+                    <a:bodyPr/>
+                    <a:lstStyle/>
+                    <a:p>
+                      <a:pPr lvl="0" indent="0" marL="0">
+                        <a:buNone/>
+                      </a:pPr>
+                      <a:r>
+                        <a:rPr/>
+                        <a:t>323.46</a:t>
+                      </a:r>
+                    </a:p>
+                  </a:txBody>
+                </a:tc>
+                <a:tc>
+                  <a:txBody>
+                    <a:bodyPr/>
+                    <a:lstStyle/>
+                    <a:p>
+                      <a:pPr lvl="0" indent="0" marL="0">
+                        <a:buNone/>
+                      </a:pPr>
+                      <a:r>
+                        <a:rPr/>
+                        <a:t>balsam fir</a:t>
+                      </a:r>
+                    </a:p>
+                  </a:txBody>
+                </a:tc>
+              </a:tr>
+              <a:tr h="0">
+                <a:tc>
+                  <a:txBody>
+                    <a:bodyPr/>
+                    <a:lstStyle/>
+                    <a:p>
+                      <a:pPr lvl="0" indent="0" marL="0">
+                        <a:buNone/>
+                      </a:pPr>
+                      <a:r>
+                        <a:rPr/>
+                        <a:t>2</a:t>
+                      </a:r>
+                    </a:p>
+                  </a:txBody>
+                </a:tc>
+                <a:tc>
+                  <a:txBody>
+                    <a:bodyPr/>
+                    <a:lstStyle/>
+                    <a:p>
+                      <a:pPr lvl="0" indent="0" marL="0">
+                        <a:buNone/>
+                      </a:pPr>
+                      <a:r>
+                        <a:rPr/>
+                        <a:t>12</a:t>
+                      </a:r>
+                    </a:p>
+                  </a:txBody>
+                </a:tc>
+                <a:tc>
+                  <a:txBody>
+                    <a:bodyPr/>
+                    <a:lstStyle/>
+                    <a:p>
+                      <a:pPr lvl="0" indent="0" marL="0">
+                        <a:buNone/>
+                      </a:pPr>
+                      <a:r>
+                        <a:rPr/>
+                        <a:t>9.7</a:t>
+                      </a:r>
+                    </a:p>
+                  </a:txBody>
+                </a:tc>
+                <a:tc>
+                  <a:txBody>
+                    <a:bodyPr/>
+                    <a:lstStyle/>
+                    <a:p>
+                      <a:pPr lvl="0" indent="0" marL="0">
+                        <a:buNone/>
+                      </a:pPr>
+                      <a:r>
+                        <a:rPr/>
+                        <a:t>56.7</a:t>
+                      </a:r>
+                    </a:p>
+                  </a:txBody>
+                </a:tc>
+                <a:tc>
+                  <a:txBody>
+                    <a:bodyPr/>
+                    <a:lstStyle/>
+                    <a:p>
+                      <a:pPr lvl="0" indent="0" marL="0">
+                        <a:buNone/>
+                      </a:pPr>
+                      <a:r>
+                        <a:rPr/>
+                        <a:t>342.47</a:t>
+                      </a:r>
+                    </a:p>
+                  </a:txBody>
+                </a:tc>
+                <a:tc>
+                  <a:txBody>
+                    <a:bodyPr/>
+                    <a:lstStyle/>
+                    <a:p>
+                      <a:pPr lvl="0" indent="0" marL="0">
+                        <a:buNone/>
+                      </a:pPr>
+                      <a:r>
+                        <a:rPr/>
+                        <a:t>balsam fir</a:t>
+                      </a:r>
+                    </a:p>
+                  </a:txBody>
+                </a:tc>
+              </a:tr>
+              <a:tr h="0">
+                <a:tc>
+                  <a:txBody>
+                    <a:bodyPr/>
+                    <a:lstStyle/>
+                    <a:p>
+                      <a:pPr lvl="0" indent="0" marL="0">
+                        <a:buNone/>
+                      </a:pPr>
+                      <a:r>
+                        <a:rPr/>
+                        <a:t>3</a:t>
+                      </a:r>
+                    </a:p>
+                  </a:txBody>
+                </a:tc>
+                <a:tc>
+                  <a:txBody>
+                    <a:bodyPr/>
+                    <a:lstStyle/>
+                    <a:p>
+                      <a:pPr lvl="0" indent="0" marL="0">
+                        <a:buNone/>
+                      </a:pPr>
+                      <a:r>
+                        <a:rPr/>
+                        <a:t>12</a:t>
+                      </a:r>
+                    </a:p>
+                  </a:txBody>
+                </a:tc>
+                <a:tc>
+                  <a:txBody>
+                    <a:bodyPr/>
+                    <a:lstStyle/>
+                    <a:p>
+                      <a:pPr lvl="0" indent="0" marL="0">
+                        <a:buNone/>
+                      </a:pPr>
+                      <a:r>
+                        <a:rPr/>
+                        <a:t>11.4</a:t>
+                      </a:r>
+                    </a:p>
+                  </a:txBody>
+                </a:tc>
+                <a:tc>
+                  <a:txBody>
+                    <a:bodyPr/>
+                    <a:lstStyle/>
+                    <a:p>
+                      <a:pPr lvl="0" indent="0" marL="0">
+                        <a:buNone/>
+                      </a:pPr>
+                      <a:r>
+                        <a:rPr/>
+                        <a:t>66.1</a:t>
+                      </a:r>
+                    </a:p>
+                  </a:txBody>
+                </a:tc>
+                <a:tc>
+                  <a:txBody>
+                    <a:bodyPr/>
+                    <a:lstStyle/>
+                    <a:p>
+                      <a:pPr lvl="0" indent="0" marL="0">
+                        <a:buNone/>
+                      </a:pPr>
+                      <a:r>
+                        <a:rPr/>
+                        <a:t>499.35</a:t>
+                      </a:r>
+                    </a:p>
+                  </a:txBody>
+                </a:tc>
+                <a:tc>
+                  <a:txBody>
+                    <a:bodyPr/>
+                    <a:lstStyle/>
+                    <a:p>
+                      <a:pPr lvl="0" indent="0" marL="0">
+                        <a:buNone/>
+                      </a:pPr>
+                      <a:r>
+                        <a:rPr/>
+                        <a:t>balsam fir</a:t>
+                      </a:r>
+                    </a:p>
+                  </a:txBody>
+                </a:tc>
+              </a:tr>
+              <a:tr h="0">
+                <a:tc>
+                  <a:txBody>
+                    <a:bodyPr/>
+                    <a:lstStyle/>
+                    <a:p>
+                      <a:pPr lvl="0" indent="0" marL="0">
+                        <a:buNone/>
+                      </a:pPr>
+                      <a:r>
+                        <a:rPr/>
+                        <a:t>4</a:t>
+                      </a:r>
+                    </a:p>
+                  </a:txBody>
+                </a:tc>
+                <a:tc>
+                  <a:txBody>
+                    <a:bodyPr/>
+                    <a:lstStyle/>
+                    <a:p>
+                      <a:pPr lvl="0" indent="0" marL="0">
+                        <a:buNone/>
+                      </a:pPr>
+                      <a:r>
+                        <a:rPr/>
+                        <a:t>12</a:t>
+                      </a:r>
+                    </a:p>
+                  </a:txBody>
+                </a:tc>
+                <a:tc>
+                  <a:txBody>
+                    <a:bodyPr/>
+                    <a:lstStyle/>
+                    <a:p>
+                      <a:pPr lvl="0" indent="0" marL="0">
+                        <a:buNone/>
+                      </a:pPr>
+                      <a:r>
+                        <a:rPr/>
+                        <a:t>6.4</a:t>
+                      </a:r>
+                    </a:p>
+                  </a:txBody>
+                </a:tc>
+                <a:tc>
+                  <a:txBody>
+                    <a:bodyPr/>
+                    <a:lstStyle/>
+                    <a:p>
+                      <a:pPr lvl="0" indent="0" marL="0">
+                        <a:buNone/>
+                      </a:pPr>
+                      <a:r>
+                        <a:rPr/>
+                        <a:t>51.8</a:t>
+                      </a:r>
+                    </a:p>
+                  </a:txBody>
+                </a:tc>
+                <a:tc>
+                  <a:txBody>
+                    <a:bodyPr/>
+                    <a:lstStyle/>
+                    <a:p>
+                      <a:pPr lvl="0" indent="0" marL="0">
+                        <a:buNone/>
+                      </a:pPr>
+                      <a:r>
+                        <a:rPr/>
+                        <a:t>113.92</a:t>
+                      </a:r>
+                    </a:p>
+                  </a:txBody>
+                </a:tc>
+                <a:tc>
+                  <a:txBody>
+                    <a:bodyPr/>
+                    <a:lstStyle/>
+                    <a:p>
+                      <a:pPr lvl="0" indent="0" marL="0">
+                        <a:buNone/>
+                      </a:pPr>
+                      <a:r>
+                        <a:rPr/>
+                        <a:t>balsam fir</a:t>
+                      </a:r>
+                    </a:p>
+                  </a:txBody>
+                </a:tc>
+              </a:tr>
+            </a:tbl>
+          </a:graphicData>
+        </a:graphic>
+      </p:graphicFrame>
+    </p:spTree>
+  </p:cSld>
+</p:sld>
+</file>
+
+<file path=ppt/slides/slide14.xml><?xml version="1.0" encoding="utf-8"?>
+<p:sld xmlns:a="http://schemas.openxmlformats.org/drawingml/2006/main" xmlns:r="http://schemas.openxmlformats.org/officeDocument/2006/relationships" xmlns:p="http://schemas.openxmlformats.org/presentationml/2006/main">
+  <p:cSld>
+    <p:spTree>
+      <p:nvGrpSpPr>
+        <p:cNvPr id="1" name=""/>
+        <p:cNvGrpSpPr/>
+        <p:nvPr/>
+      </p:nvGrpSpPr>
+      <p:grpSpPr>
+        <a:xfrm>
+          <a:off x="0" y="0"/>
+          <a:ext cx="0" cy="0"/>
+          <a:chOff x="0" y="0"/>
+          <a:chExt cx="0" cy="0"/>
+        </a:xfrm>
+      </p:grpSpPr>
+      <p:sp>
+        <p:nvSpPr>
+          <p:cNvPr id="2" name="Title 1"/>
+          <p:cNvSpPr>
+            <a:spLocks noGrp="1"/>
+          </p:cNvSpPr>
+          <p:nvPr>
+            <p:ph type="title"/>
+          </p:nvPr>
+        </p:nvSpPr>
+        <p:spPr/>
+        <p:txBody>
+          <a:bodyPr/>
+          <a:lstStyle/>
+          <a:p>
+            <a:pPr lvl="0" indent="0" marL="0">
+              <a:buNone/>
+            </a:pPr>
+            <a:r>
+              <a:rPr/>
               <a:t>Quality Assurance</a:t>
             </a:r>
           </a:p>
@@ -3276,12 +4754,12 @@
       </p:grpSpPr>
       <p:sp>
         <p:nvSpPr>
-          <p:cNvPr id="2" name="Title 1"/>
-          <p:cNvSpPr>
-            <a:spLocks noGrp="1"/>
-          </p:cNvSpPr>
-          <p:nvPr>
-            <p:ph type="title"/>
+          <p:cNvPr id="3" name="Content Placeholder 2"/>
+          <p:cNvSpPr>
+            <a:spLocks noGrp="1"/>
+          </p:cNvSpPr>
+          <p:nvPr>
+            <p:ph idx="1"/>
           </p:nvPr>
         </p:nvSpPr>
         <p:spPr/>
@@ -3294,7 +4772,7 @@
             </a:pPr>
             <a:r>
               <a:rPr/>
-              <a:t>Redwood Analytics Project 3</a:t>
+              <a:t>#Redwood Analytics Project 3</a:t>
             </a:r>
           </a:p>
         </p:txBody>
@@ -3374,20 +4852,6 @@
               <a:t>DO_BH (Diameter at Breast Height [Outside Bark]): Diameter of the tree stem measured at breast height (4.5 feet or 1.37 meters above ground) including bark. This is the standard foresty measurement “DBH (outside bark)” and is the primary size variable used in nearly all allometric biomass models. This is measured in inches.</a:t>
             </a:r>
           </a:p>
-          <a:p>
-            <a:pPr lvl="0"/>
-            <a:r>
-              <a:rPr/>
-              <a:t>HT_TOT (Total Tree Height): The total height of the tree measured from ground level to the top of the crown. Used as a second size metric in volume and biomass modeling.This is measured in feet.</a:t>
-            </a:r>
-          </a:p>
-          <a:p>
-            <a:pPr lvl="0"/>
-            <a:r>
-              <a:rPr/>
-              <a:t>NEED UNITS (likely KG) STILL TT_DW_CRM (Total Tree Dry Biomass): The total above-ground dry weight of the tree (includes stem wood, stem bark, branches, folliage). This value comes from destructive sampling: the tree was felled, seperated into componenets, oven-dried, and weighed. This variable serves as the response variable (“target”) from biomass prediction.</a:t>
-            </a:r>
-          </a:p>
         </p:txBody>
       </p:sp>
     </p:spTree>
@@ -3396,6 +4860,85 @@
 </file>
 
 <file path=ppt/slides/slide4.xml><?xml version="1.0" encoding="utf-8"?>
+<p:sld xmlns:a="http://schemas.openxmlformats.org/drawingml/2006/main" xmlns:r="http://schemas.openxmlformats.org/officeDocument/2006/relationships" xmlns:p="http://schemas.openxmlformats.org/presentationml/2006/main">
+  <p:cSld>
+    <p:spTree>
+      <p:nvGrpSpPr>
+        <p:cNvPr id="1" name=""/>
+        <p:cNvGrpSpPr/>
+        <p:nvPr/>
+      </p:nvGrpSpPr>
+      <p:grpSpPr>
+        <a:xfrm>
+          <a:off x="0" y="0"/>
+          <a:ext cx="0" cy="0"/>
+          <a:chOff x="0" y="0"/>
+          <a:chExt cx="0" cy="0"/>
+        </a:xfrm>
+      </p:grpSpPr>
+      <p:sp>
+        <p:nvSpPr>
+          <p:cNvPr id="2" name="Title 1"/>
+          <p:cNvSpPr>
+            <a:spLocks noGrp="1"/>
+          </p:cNvSpPr>
+          <p:nvPr>
+            <p:ph type="title"/>
+          </p:nvPr>
+        </p:nvSpPr>
+        <p:spPr/>
+        <p:txBody>
+          <a:bodyPr/>
+          <a:lstStyle/>
+          <a:p>
+            <a:pPr lvl="0" indent="0" marL="0">
+              <a:buNone/>
+            </a:pPr>
+            <a:r>
+              <a:rPr/>
+              <a:t>Data Dictionary Continued</a:t>
+            </a:r>
+          </a:p>
+        </p:txBody>
+      </p:sp>
+      <p:sp>
+        <p:nvSpPr>
+          <p:cNvPr id="3" name="Content Placeholder 2"/>
+          <p:cNvSpPr>
+            <a:spLocks noGrp="1"/>
+          </p:cNvSpPr>
+          <p:nvPr>
+            <p:ph idx="1"/>
+          </p:nvPr>
+        </p:nvSpPr>
+        <p:spPr/>
+        <p:txBody>
+          <a:bodyPr/>
+          <a:lstStyle/>
+          <a:p>
+            <a:pPr lvl="0"/>
+            <a:r>
+              <a:rPr/>
+              <a:t>HT_TOT (Total Tree Height): The total height of the tree measured from ground level to the top of the crown. Used as a second size metric in volume and biomass modeling.This is measured in feet.</a:t>
+            </a:r>
+          </a:p>
+          <a:p>
+            <a:pPr lvl="0" indent="0" marL="0">
+              <a:buNone/>
+            </a:pPr>
+            <a:r>
+              <a:rPr/>
+              <a:t>-TT_DW_CRM (Total Tree Dry Biomass): The total above-ground dry weight of the tree (includes stem wood, stem bark, branches, folliage). This value comes from destructive sampling: the tree was felled, seperated into componenets, oven-dried, and weighed. This variable serves as the response variable (“target”) from biomass prediction. This is measured in kilograms.</a:t>
+            </a:r>
+          </a:p>
+        </p:txBody>
+      </p:sp>
+    </p:spTree>
+  </p:cSld>
+</p:sld>
+</file>
+
+<file path=ppt/slides/slide5.xml><?xml version="1.0" encoding="utf-8"?>
 <p:sld xmlns:a="http://schemas.openxmlformats.org/drawingml/2006/main" xmlns:r="http://schemas.openxmlformats.org/officeDocument/2006/relationships" xmlns:p="http://schemas.openxmlformats.org/presentationml/2006/main">
   <p:cSld>
     <p:spTree>
@@ -3472,7 +5015,7 @@
 </p:sld>
 </file>
 
-<file path=ppt/slides/slide5.xml><?xml version="1.0" encoding="utf-8"?>
+<file path=ppt/slides/slide6.xml><?xml version="1.0" encoding="utf-8"?>
 <p:sld xmlns:a="http://schemas.openxmlformats.org/drawingml/2006/main" xmlns:r="http://schemas.openxmlformats.org/officeDocument/2006/relationships" xmlns:p="http://schemas.openxmlformats.org/presentationml/2006/main">
   <p:cSld>
     <p:spTree>
@@ -3549,7 +5092,7 @@
 </p:sld>
 </file>
 
-<file path=ppt/slides/slide6.xml><?xml version="1.0" encoding="utf-8"?>
+<file path=ppt/slides/slide7.xml><?xml version="1.0" encoding="utf-8"?>
 <p:sld xmlns:a="http://schemas.openxmlformats.org/drawingml/2006/main" xmlns:r="http://schemas.openxmlformats.org/officeDocument/2006/relationships" xmlns:p="http://schemas.openxmlformats.org/presentationml/2006/main">
   <p:cSld>
     <p:spTree>
@@ -3626,7 +5169,7 @@
 </p:sld>
 </file>
 
-<file path=ppt/slides/slide7.xml><?xml version="1.0" encoding="utf-8"?>
+<file path=ppt/slides/slide8.xml><?xml version="1.0" encoding="utf-8"?>
 <p:sld xmlns:a="http://schemas.openxmlformats.org/drawingml/2006/main" xmlns:r="http://schemas.openxmlformats.org/officeDocument/2006/relationships" xmlns:p="http://schemas.openxmlformats.org/presentationml/2006/main">
   <p:cSld>
     <p:spTree>
@@ -3703,53 +5246,6 @@
 </p:sld>
 </file>
 
-<file path=ppt/slides/slide8.xml><?xml version="1.0" encoding="utf-8"?>
-<p:sld xmlns:a="http://schemas.openxmlformats.org/drawingml/2006/main" xmlns:r="http://schemas.openxmlformats.org/officeDocument/2006/relationships" xmlns:p="http://schemas.openxmlformats.org/presentationml/2006/main">
-  <p:cSld>
-    <p:spTree>
-      <p:nvGrpSpPr>
-        <p:cNvPr id="1" name=""/>
-        <p:cNvGrpSpPr/>
-        <p:nvPr/>
-      </p:nvGrpSpPr>
-      <p:grpSpPr>
-        <a:xfrm>
-          <a:off x="0" y="0"/>
-          <a:ext cx="0" cy="0"/>
-          <a:chOff x="0" y="0"/>
-          <a:chExt cx="0" cy="0"/>
-        </a:xfrm>
-      </p:grpSpPr>
-      <p:sp>
-        <p:nvSpPr>
-          <p:cNvPr id="2" name="Title 1"/>
-          <p:cNvSpPr>
-            <a:spLocks noGrp="1"/>
-          </p:cNvSpPr>
-          <p:nvPr>
-            <p:ph type="title"/>
-          </p:nvPr>
-        </p:nvSpPr>
-        <p:spPr/>
-        <p:txBody>
-          <a:bodyPr/>
-          <a:lstStyle/>
-          <a:p>
-            <a:pPr lvl="0" indent="0" marL="0">
-              <a:buNone/>
-            </a:pPr>
-            <a:r>
-              <a:rPr/>
-              <a:t>Domain Expert 3 (Explain the inputs and settings for the best model)</a:t>
-            </a:r>
-          </a:p>
-        </p:txBody>
-      </p:sp>
-    </p:spTree>
-  </p:cSld>
-</p:sld>
-</file>
-
 <file path=ppt/slides/slide9.xml><?xml version="1.0" encoding="utf-8"?>
 <p:sld xmlns:a="http://schemas.openxmlformats.org/drawingml/2006/main" xmlns:r="http://schemas.openxmlformats.org/officeDocument/2006/relationships" xmlns:p="http://schemas.openxmlformats.org/presentationml/2006/main">
   <p:cSld>
@@ -3787,7 +5283,7 @@
             </a:pPr>
             <a:r>
               <a:rPr/>
-              <a:t>Project Manager</a:t>
+              <a:t>Domain Expert 3 (Explain the inputs and settings for the best model)</a:t>
             </a:r>
           </a:p>
         </p:txBody>

</xml_diff>

<commit_message>
adding more domain expert slides
</commit_message>
<xml_diff>
--- a/Project-3/individual-models/data/presentation.pptx
+++ b/Project-3/individual-models/data/presentation.pptx
@@ -19,6 +19,7 @@
     <p:sldId id="267" r:id="rId13"/>
     <p:sldId id="268" r:id="rId14"/>
     <p:sldId id="269" r:id="rId15"/>
+    <p:sldId id="270" r:id="rId16"/>
   </p:sldIdLst>
   <p:sldSz cx="9144000" cy="5143500" type="screen16x9"/>
   <p:notesSz cx="6858000" cy="9144000"/>
@@ -3128,7 +3129,7 @@
             </a:pPr>
             <a:r>
               <a:rPr/>
-              <a:t>Redwood Analytics Project 3</a:t>
+              <a:t>Redwood Analytics Project 3: Predicting Tree Biomass</a:t>
             </a:r>
           </a:p>
         </p:txBody>
@@ -3156,6 +3157,10 @@
             <a:pPr lvl="0" indent="0" marL="0">
               <a:buNone/>
             </a:pPr>
+            <a:r>
+              <a:rPr/>
+              <a:t>By Evan Blem, Dean Callahan, Zach Griffiths, and Jaiden Roe</a:t>
+            </a:r>
             <a:br/>
             <a:br/>
           </a:p>
@@ -3203,7 +3208,32 @@
             </a:pPr>
             <a:r>
               <a:rPr/>
-              <a:t>Project Manager</a:t>
+              <a:t>Performance Metric</a:t>
+            </a:r>
+          </a:p>
+        </p:txBody>
+      </p:sp>
+      <p:sp>
+        <p:nvSpPr>
+          <p:cNvPr id="3" name="Content Placeholder 2"/>
+          <p:cNvSpPr>
+            <a:spLocks noGrp="1"/>
+          </p:cNvSpPr>
+          <p:nvPr>
+            <p:ph idx="1"/>
+          </p:nvPr>
+        </p:nvSpPr>
+        <p:spPr/>
+        <p:txBody>
+          <a:bodyPr/>
+          <a:lstStyle/>
+          <a:p>
+            <a:pPr lvl="0" indent="0" marL="0">
+              <a:buNone/>
+            </a:pPr>
+            <a:r>
+              <a:rPr/>
+              <a:t>The Performance metric we choose is Root Mean Square Logarithmic Error(RMSLE), because when we were looking at the dataset of the biomass of different kinds of tree species, we saw that some species have more data than other species so the assume that the data is skewed</a:t>
             </a:r>
           </a:p>
         </p:txBody>
@@ -3250,7 +3280,7 @@
             </a:pPr>
             <a:r>
               <a:rPr/>
-              <a:t>Technical Lead</a:t>
+              <a:t>Model</a:t>
             </a:r>
           </a:p>
         </p:txBody>
@@ -3276,11 +3306,13 @@
                 <a:tableStyleId>{5C22544A-7EE6-4342-B048-85BDC9FD1C3A}</a:tableStyleId>
               </a:tblPr>
               <a:tblGrid>
-                <a:gridCol w="1638300"/>
-                <a:gridCol w="1638300"/>
-                <a:gridCol w="1638300"/>
-                <a:gridCol w="1638300"/>
-                <a:gridCol w="1638300"/>
+                <a:gridCol w="1168400"/>
+                <a:gridCol w="1168400"/>
+                <a:gridCol w="1168400"/>
+                <a:gridCol w="1168400"/>
+                <a:gridCol w="1168400"/>
+                <a:gridCol w="1168400"/>
+                <a:gridCol w="1168400"/>
               </a:tblGrid>
               <a:tr h="0">
                 <a:tc>
@@ -3303,7 +3335,7 @@
                       </a:pPr>
                       <a:r>
                         <a:rPr/>
-                        <a:t>SPCD</a:t>
+                        <a:t>Species</a:t>
                       </a:r>
                     </a:p>
                   </a:txBody>
@@ -3319,7 +3351,7 @@
                       </a:pPr>
                       <a:r>
                         <a:rPr/>
-                        <a:t>DO_BH</a:t>
+                        <a:t>k</a:t>
                       </a:r>
                     </a:p>
                   </a:txBody>
@@ -3335,7 +3367,7 @@
                       </a:pPr>
                       <a:r>
                         <a:rPr/>
-                        <a:t>HT_TOT</a:t>
+                        <a:t>MSE</a:t>
                       </a:r>
                     </a:p>
                   </a:txBody>
@@ -3351,7 +3383,39 @@
                       </a:pPr>
                       <a:r>
                         <a:rPr/>
-                        <a:t>TT_DW_CRM</a:t>
+                        <a:t>RMSE</a:t>
+                      </a:r>
+                    </a:p>
+                  </a:txBody>
+                  <a:tcPr/>
+                </a:tc>
+                <a:tc>
+                  <a:txBody>
+                    <a:bodyPr/>
+                    <a:lstStyle/>
+                    <a:p>
+                      <a:pPr lvl="0" indent="0" marL="0">
+                        <a:buNone/>
+                      </a:pPr>
+                      <a:r>
+                        <a:rPr/>
+                        <a:t>MAE</a:t>
+                      </a:r>
+                    </a:p>
+                  </a:txBody>
+                  <a:tcPr/>
+                </a:tc>
+                <a:tc>
+                  <a:txBody>
+                    <a:bodyPr/>
+                    <a:lstStyle/>
+                    <a:p>
+                      <a:pPr lvl="0" indent="0" marL="0">
+                        <a:buNone/>
+                      </a:pPr>
+                      <a:r>
+                        <a:rPr/>
+                        <a:t>RMSLE</a:t>
                       </a:r>
                     </a:p>
                   </a:txBody>
@@ -3384,52 +3448,82 @@
                       </a:pPr>
                       <a:r>
                         <a:rPr/>
-                        <a:t>12</a:t>
-                      </a:r>
-                    </a:p>
-                  </a:txBody>
-                </a:tc>
-                <a:tc>
-                  <a:txBody>
-                    <a:bodyPr/>
-                    <a:lstStyle/>
-                    <a:p>
-                      <a:pPr lvl="0" indent="0" marL="0">
-                        <a:buNone/>
-                      </a:pPr>
-                      <a:r>
-                        <a:rPr/>
-                        <a:t>7.5</a:t>
-                      </a:r>
-                    </a:p>
-                  </a:txBody>
-                </a:tc>
-                <a:tc>
-                  <a:txBody>
-                    <a:bodyPr/>
-                    <a:lstStyle/>
-                    <a:p>
-                      <a:pPr lvl="0" indent="0" marL="0">
-                        <a:buNone/>
-                      </a:pPr>
-                      <a:r>
-                        <a:rPr/>
-                        <a:t>45.2</a:t>
-                      </a:r>
-                    </a:p>
-                  </a:txBody>
-                </a:tc>
-                <a:tc>
-                  <a:txBody>
-                    <a:bodyPr/>
-                    <a:lstStyle/>
-                    <a:p>
-                      <a:pPr lvl="0" indent="0" marL="0">
-                        <a:buNone/>
-                      </a:pPr>
-                      <a:r>
-                        <a:rPr/>
-                        <a:t>178.86</a:t>
+                        <a:t>balsam fir</a:t>
+                      </a:r>
+                    </a:p>
+                  </a:txBody>
+                </a:tc>
+                <a:tc>
+                  <a:txBody>
+                    <a:bodyPr/>
+                    <a:lstStyle/>
+                    <a:p>
+                      <a:pPr lvl="0" indent="0" marL="0">
+                        <a:buNone/>
+                      </a:pPr>
+                      <a:r>
+                        <a:rPr/>
+                        <a:t>2</a:t>
+                      </a:r>
+                    </a:p>
+                  </a:txBody>
+                </a:tc>
+                <a:tc>
+                  <a:txBody>
+                    <a:bodyPr/>
+                    <a:lstStyle/>
+                    <a:p>
+                      <a:pPr lvl="0" indent="0" marL="0">
+                        <a:buNone/>
+                      </a:pPr>
+                      <a:r>
+                        <a:rPr/>
+                        <a:t>15832.049590</a:t>
+                      </a:r>
+                    </a:p>
+                  </a:txBody>
+                </a:tc>
+                <a:tc>
+                  <a:txBody>
+                    <a:bodyPr/>
+                    <a:lstStyle/>
+                    <a:p>
+                      <a:pPr lvl="0" indent="0" marL="0">
+                        <a:buNone/>
+                      </a:pPr>
+                      <a:r>
+                        <a:rPr/>
+                        <a:t>125.825473</a:t>
+                      </a:r>
+                    </a:p>
+                  </a:txBody>
+                </a:tc>
+                <a:tc>
+                  <a:txBody>
+                    <a:bodyPr/>
+                    <a:lstStyle/>
+                    <a:p>
+                      <a:pPr lvl="0" indent="0" marL="0">
+                        <a:buNone/>
+                      </a:pPr>
+                      <a:r>
+                        <a:rPr/>
+                        <a:t>34.801913</a:t>
+                      </a:r>
+                    </a:p>
+                  </a:txBody>
+                </a:tc>
+                <a:tc>
+                  <a:txBody>
+                    <a:bodyPr/>
+                    <a:lstStyle/>
+                    <a:p>
+                      <a:pPr lvl="0" indent="0" marL="0">
+                        <a:buNone/>
+                      </a:pPr>
+                      <a:r>
+                        <a:rPr/>
+                        <a:t>0.119574</a:t>
                       </a:r>
                     </a:p>
                   </a:txBody>
@@ -3461,52 +3555,82 @@
                       </a:pPr>
                       <a:r>
                         <a:rPr/>
-                        <a:t>12</a:t>
-                      </a:r>
-                    </a:p>
-                  </a:txBody>
-                </a:tc>
-                <a:tc>
-                  <a:txBody>
-                    <a:bodyPr/>
-                    <a:lstStyle/>
-                    <a:p>
-                      <a:pPr lvl="0" indent="0" marL="0">
-                        <a:buNone/>
-                      </a:pPr>
-                      <a:r>
-                        <a:rPr/>
-                        <a:t>9.3</a:t>
-                      </a:r>
-                    </a:p>
-                  </a:txBody>
-                </a:tc>
-                <a:tc>
-                  <a:txBody>
-                    <a:bodyPr/>
-                    <a:lstStyle/>
-                    <a:p>
-                      <a:pPr lvl="0" indent="0" marL="0">
-                        <a:buNone/>
-                      </a:pPr>
-                      <a:r>
-                        <a:rPr/>
-                        <a:t>62.7</a:t>
-                      </a:r>
-                    </a:p>
-                  </a:txBody>
-                </a:tc>
-                <a:tc>
-                  <a:txBody>
-                    <a:bodyPr/>
-                    <a:lstStyle/>
-                    <a:p>
-                      <a:pPr lvl="0" indent="0" marL="0">
-                        <a:buNone/>
-                      </a:pPr>
-                      <a:r>
-                        <a:rPr/>
-                        <a:t>323.46</a:t>
+                        <a:t>balsam fir</a:t>
+                      </a:r>
+                    </a:p>
+                  </a:txBody>
+                </a:tc>
+                <a:tc>
+                  <a:txBody>
+                    <a:bodyPr/>
+                    <a:lstStyle/>
+                    <a:p>
+                      <a:pPr lvl="0" indent="0" marL="0">
+                        <a:buNone/>
+                      </a:pPr>
+                      <a:r>
+                        <a:rPr/>
+                        <a:t>3</a:t>
+                      </a:r>
+                    </a:p>
+                  </a:txBody>
+                </a:tc>
+                <a:tc>
+                  <a:txBody>
+                    <a:bodyPr/>
+                    <a:lstStyle/>
+                    <a:p>
+                      <a:pPr lvl="0" indent="0" marL="0">
+                        <a:buNone/>
+                      </a:pPr>
+                      <a:r>
+                        <a:rPr/>
+                        <a:t>16809.506015</a:t>
+                      </a:r>
+                    </a:p>
+                  </a:txBody>
+                </a:tc>
+                <a:tc>
+                  <a:txBody>
+                    <a:bodyPr/>
+                    <a:lstStyle/>
+                    <a:p>
+                      <a:pPr lvl="0" indent="0" marL="0">
+                        <a:buNone/>
+                      </a:pPr>
+                      <a:r>
+                        <a:rPr/>
+                        <a:t>129.651479</a:t>
+                      </a:r>
+                    </a:p>
+                  </a:txBody>
+                </a:tc>
+                <a:tc>
+                  <a:txBody>
+                    <a:bodyPr/>
+                    <a:lstStyle/>
+                    <a:p>
+                      <a:pPr lvl="0" indent="0" marL="0">
+                        <a:buNone/>
+                      </a:pPr>
+                      <a:r>
+                        <a:rPr/>
+                        <a:t>36.646493</a:t>
+                      </a:r>
+                    </a:p>
+                  </a:txBody>
+                </a:tc>
+                <a:tc>
+                  <a:txBody>
+                    <a:bodyPr/>
+                    <a:lstStyle/>
+                    <a:p>
+                      <a:pPr lvl="0" indent="0" marL="0">
+                        <a:buNone/>
+                      </a:pPr>
+                      <a:r>
+                        <a:rPr/>
+                        <a:t>0.123724</a:t>
                       </a:r>
                     </a:p>
                   </a:txBody>
@@ -3538,52 +3662,82 @@
                       </a:pPr>
                       <a:r>
                         <a:rPr/>
-                        <a:t>12</a:t>
-                      </a:r>
-                    </a:p>
-                  </a:txBody>
-                </a:tc>
-                <a:tc>
-                  <a:txBody>
-                    <a:bodyPr/>
-                    <a:lstStyle/>
-                    <a:p>
-                      <a:pPr lvl="0" indent="0" marL="0">
-                        <a:buNone/>
-                      </a:pPr>
-                      <a:r>
-                        <a:rPr/>
-                        <a:t>9.7</a:t>
-                      </a:r>
-                    </a:p>
-                  </a:txBody>
-                </a:tc>
-                <a:tc>
-                  <a:txBody>
-                    <a:bodyPr/>
-                    <a:lstStyle/>
-                    <a:p>
-                      <a:pPr lvl="0" indent="0" marL="0">
-                        <a:buNone/>
-                      </a:pPr>
-                      <a:r>
-                        <a:rPr/>
-                        <a:t>56.7</a:t>
-                      </a:r>
-                    </a:p>
-                  </a:txBody>
-                </a:tc>
-                <a:tc>
-                  <a:txBody>
-                    <a:bodyPr/>
-                    <a:lstStyle/>
-                    <a:p>
-                      <a:pPr lvl="0" indent="0" marL="0">
-                        <a:buNone/>
-                      </a:pPr>
-                      <a:r>
-                        <a:rPr/>
-                        <a:t>342.47</a:t>
+                        <a:t>balsam fir</a:t>
+                      </a:r>
+                    </a:p>
+                  </a:txBody>
+                </a:tc>
+                <a:tc>
+                  <a:txBody>
+                    <a:bodyPr/>
+                    <a:lstStyle/>
+                    <a:p>
+                      <a:pPr lvl="0" indent="0" marL="0">
+                        <a:buNone/>
+                      </a:pPr>
+                      <a:r>
+                        <a:rPr/>
+                        <a:t>4</a:t>
+                      </a:r>
+                    </a:p>
+                  </a:txBody>
+                </a:tc>
+                <a:tc>
+                  <a:txBody>
+                    <a:bodyPr/>
+                    <a:lstStyle/>
+                    <a:p>
+                      <a:pPr lvl="0" indent="0" marL="0">
+                        <a:buNone/>
+                      </a:pPr>
+                      <a:r>
+                        <a:rPr/>
+                        <a:t>18117.114099</a:t>
+                      </a:r>
+                    </a:p>
+                  </a:txBody>
+                </a:tc>
+                <a:tc>
+                  <a:txBody>
+                    <a:bodyPr/>
+                    <a:lstStyle/>
+                    <a:p>
+                      <a:pPr lvl="0" indent="0" marL="0">
+                        <a:buNone/>
+                      </a:pPr>
+                      <a:r>
+                        <a:rPr/>
+                        <a:t>134.599829</a:t>
+                      </a:r>
+                    </a:p>
+                  </a:txBody>
+                </a:tc>
+                <a:tc>
+                  <a:txBody>
+                    <a:bodyPr/>
+                    <a:lstStyle/>
+                    <a:p>
+                      <a:pPr lvl="0" indent="0" marL="0">
+                        <a:buNone/>
+                      </a:pPr>
+                      <a:r>
+                        <a:rPr/>
+                        <a:t>38.884870</a:t>
+                      </a:r>
+                    </a:p>
+                  </a:txBody>
+                </a:tc>
+                <a:tc>
+                  <a:txBody>
+                    <a:bodyPr/>
+                    <a:lstStyle/>
+                    <a:p>
+                      <a:pPr lvl="0" indent="0" marL="0">
+                        <a:buNone/>
+                      </a:pPr>
+                      <a:r>
+                        <a:rPr/>
+                        <a:t>0.133858</a:t>
                       </a:r>
                     </a:p>
                   </a:txBody>
@@ -3615,52 +3769,82 @@
                       </a:pPr>
                       <a:r>
                         <a:rPr/>
-                        <a:t>12</a:t>
-                      </a:r>
-                    </a:p>
-                  </a:txBody>
-                </a:tc>
-                <a:tc>
-                  <a:txBody>
-                    <a:bodyPr/>
-                    <a:lstStyle/>
-                    <a:p>
-                      <a:pPr lvl="0" indent="0" marL="0">
-                        <a:buNone/>
-                      </a:pPr>
-                      <a:r>
-                        <a:rPr/>
-                        <a:t>11.4</a:t>
-                      </a:r>
-                    </a:p>
-                  </a:txBody>
-                </a:tc>
-                <a:tc>
-                  <a:txBody>
-                    <a:bodyPr/>
-                    <a:lstStyle/>
-                    <a:p>
-                      <a:pPr lvl="0" indent="0" marL="0">
-                        <a:buNone/>
-                      </a:pPr>
-                      <a:r>
-                        <a:rPr/>
-                        <a:t>66.1</a:t>
-                      </a:r>
-                    </a:p>
-                  </a:txBody>
-                </a:tc>
-                <a:tc>
-                  <a:txBody>
-                    <a:bodyPr/>
-                    <a:lstStyle/>
-                    <a:p>
-                      <a:pPr lvl="0" indent="0" marL="0">
-                        <a:buNone/>
-                      </a:pPr>
-                      <a:r>
-                        <a:rPr/>
-                        <a:t>499.35</a:t>
+                        <a:t>balsam fir</a:t>
+                      </a:r>
+                    </a:p>
+                  </a:txBody>
+                </a:tc>
+                <a:tc>
+                  <a:txBody>
+                    <a:bodyPr/>
+                    <a:lstStyle/>
+                    <a:p>
+                      <a:pPr lvl="0" indent="0" marL="0">
+                        <a:buNone/>
+                      </a:pPr>
+                      <a:r>
+                        <a:rPr/>
+                        <a:t>5</a:t>
+                      </a:r>
+                    </a:p>
+                  </a:txBody>
+                </a:tc>
+                <a:tc>
+                  <a:txBody>
+                    <a:bodyPr/>
+                    <a:lstStyle/>
+                    <a:p>
+                      <a:pPr lvl="0" indent="0" marL="0">
+                        <a:buNone/>
+                      </a:pPr>
+                      <a:r>
+                        <a:rPr/>
+                        <a:t>21026.044395</a:t>
+                      </a:r>
+                    </a:p>
+                  </a:txBody>
+                </a:tc>
+                <a:tc>
+                  <a:txBody>
+                    <a:bodyPr/>
+                    <a:lstStyle/>
+                    <a:p>
+                      <a:pPr lvl="0" indent="0" marL="0">
+                        <a:buNone/>
+                      </a:pPr>
+                      <a:r>
+                        <a:rPr/>
+                        <a:t>145.003601</a:t>
+                      </a:r>
+                    </a:p>
+                  </a:txBody>
+                </a:tc>
+                <a:tc>
+                  <a:txBody>
+                    <a:bodyPr/>
+                    <a:lstStyle/>
+                    <a:p>
+                      <a:pPr lvl="0" indent="0" marL="0">
+                        <a:buNone/>
+                      </a:pPr>
+                      <a:r>
+                        <a:rPr/>
+                        <a:t>41.209530</a:t>
+                      </a:r>
+                    </a:p>
+                  </a:txBody>
+                </a:tc>
+                <a:tc>
+                  <a:txBody>
+                    <a:bodyPr/>
+                    <a:lstStyle/>
+                    <a:p>
+                      <a:pPr lvl="0" indent="0" marL="0">
+                        <a:buNone/>
+                      </a:pPr>
+                      <a:r>
+                        <a:rPr/>
+                        <a:t>0.144063</a:t>
                       </a:r>
                     </a:p>
                   </a:txBody>
@@ -3692,52 +3876,724 @@
                       </a:pPr>
                       <a:r>
                         <a:rPr/>
-                        <a:t>12</a:t>
-                      </a:r>
-                    </a:p>
-                  </a:txBody>
-                </a:tc>
-                <a:tc>
-                  <a:txBody>
-                    <a:bodyPr/>
-                    <a:lstStyle/>
-                    <a:p>
-                      <a:pPr lvl="0" indent="0" marL="0">
-                        <a:buNone/>
-                      </a:pPr>
-                      <a:r>
-                        <a:rPr/>
-                        <a:t>6.4</a:t>
-                      </a:r>
-                    </a:p>
-                  </a:txBody>
-                </a:tc>
-                <a:tc>
-                  <a:txBody>
-                    <a:bodyPr/>
-                    <a:lstStyle/>
-                    <a:p>
-                      <a:pPr lvl="0" indent="0" marL="0">
-                        <a:buNone/>
-                      </a:pPr>
-                      <a:r>
-                        <a:rPr/>
-                        <a:t>51.8</a:t>
-                      </a:r>
-                    </a:p>
-                  </a:txBody>
-                </a:tc>
-                <a:tc>
-                  <a:txBody>
-                    <a:bodyPr/>
-                    <a:lstStyle/>
-                    <a:p>
-                      <a:pPr lvl="0" indent="0" marL="0">
-                        <a:buNone/>
-                      </a:pPr>
-                      <a:r>
-                        <a:rPr/>
-                        <a:t>113.92</a:t>
+                        <a:t>balsam fir</a:t>
+                      </a:r>
+                    </a:p>
+                  </a:txBody>
+                </a:tc>
+                <a:tc>
+                  <a:txBody>
+                    <a:bodyPr/>
+                    <a:lstStyle/>
+                    <a:p>
+                      <a:pPr lvl="0" indent="0" marL="0">
+                        <a:buNone/>
+                      </a:pPr>
+                      <a:r>
+                        <a:rPr/>
+                        <a:t>6</a:t>
+                      </a:r>
+                    </a:p>
+                  </a:txBody>
+                </a:tc>
+                <a:tc>
+                  <a:txBody>
+                    <a:bodyPr/>
+                    <a:lstStyle/>
+                    <a:p>
+                      <a:pPr lvl="0" indent="0" marL="0">
+                        <a:buNone/>
+                      </a:pPr>
+                      <a:r>
+                        <a:rPr/>
+                        <a:t>21741.891998</a:t>
+                      </a:r>
+                    </a:p>
+                  </a:txBody>
+                </a:tc>
+                <a:tc>
+                  <a:txBody>
+                    <a:bodyPr/>
+                    <a:lstStyle/>
+                    <a:p>
+                      <a:pPr lvl="0" indent="0" marL="0">
+                        <a:buNone/>
+                      </a:pPr>
+                      <a:r>
+                        <a:rPr/>
+                        <a:t>147.451321</a:t>
+                      </a:r>
+                    </a:p>
+                  </a:txBody>
+                </a:tc>
+                <a:tc>
+                  <a:txBody>
+                    <a:bodyPr/>
+                    <a:lstStyle/>
+                    <a:p>
+                      <a:pPr lvl="0" indent="0" marL="0">
+                        <a:buNone/>
+                      </a:pPr>
+                      <a:r>
+                        <a:rPr/>
+                        <a:t>40.791681</a:t>
+                      </a:r>
+                    </a:p>
+                  </a:txBody>
+                </a:tc>
+                <a:tc>
+                  <a:txBody>
+                    <a:bodyPr/>
+                    <a:lstStyle/>
+                    <a:p>
+                      <a:pPr lvl="0" indent="0" marL="0">
+                        <a:buNone/>
+                      </a:pPr>
+                      <a:r>
+                        <a:rPr/>
+                        <a:t>0.142862</a:t>
+                      </a:r>
+                    </a:p>
+                  </a:txBody>
+                </a:tc>
+              </a:tr>
+              <a:tr h="0">
+                <a:tc>
+                  <a:txBody>
+                    <a:bodyPr/>
+                    <a:lstStyle/>
+                    <a:p>
+                      <a:pPr lvl="0" indent="0" marL="0">
+                        <a:buNone/>
+                      </a:pPr>
+                      <a:r>
+                        <a:rPr/>
+                        <a:t>...</a:t>
+                      </a:r>
+                    </a:p>
+                  </a:txBody>
+                </a:tc>
+                <a:tc>
+                  <a:txBody>
+                    <a:bodyPr/>
+                    <a:lstStyle/>
+                    <a:p>
+                      <a:pPr lvl="0" indent="0" marL="0">
+                        <a:buNone/>
+                      </a:pPr>
+                      <a:r>
+                        <a:rPr/>
+                        <a:t>...</a:t>
+                      </a:r>
+                    </a:p>
+                  </a:txBody>
+                </a:tc>
+                <a:tc>
+                  <a:txBody>
+                    <a:bodyPr/>
+                    <a:lstStyle/>
+                    <a:p>
+                      <a:pPr lvl="0" indent="0" marL="0">
+                        <a:buNone/>
+                      </a:pPr>
+                      <a:r>
+                        <a:rPr/>
+                        <a:t>...</a:t>
+                      </a:r>
+                    </a:p>
+                  </a:txBody>
+                </a:tc>
+                <a:tc>
+                  <a:txBody>
+                    <a:bodyPr/>
+                    <a:lstStyle/>
+                    <a:p>
+                      <a:pPr lvl="0" indent="0" marL="0">
+                        <a:buNone/>
+                      </a:pPr>
+                      <a:r>
+                        <a:rPr/>
+                        <a:t>...</a:t>
+                      </a:r>
+                    </a:p>
+                  </a:txBody>
+                </a:tc>
+                <a:tc>
+                  <a:txBody>
+                    <a:bodyPr/>
+                    <a:lstStyle/>
+                    <a:p>
+                      <a:pPr lvl="0" indent="0" marL="0">
+                        <a:buNone/>
+                      </a:pPr>
+                      <a:r>
+                        <a:rPr/>
+                        <a:t>...</a:t>
+                      </a:r>
+                    </a:p>
+                  </a:txBody>
+                </a:tc>
+                <a:tc>
+                  <a:txBody>
+                    <a:bodyPr/>
+                    <a:lstStyle/>
+                    <a:p>
+                      <a:pPr lvl="0" indent="0" marL="0">
+                        <a:buNone/>
+                      </a:pPr>
+                      <a:r>
+                        <a:rPr/>
+                        <a:t>...</a:t>
+                      </a:r>
+                    </a:p>
+                  </a:txBody>
+                </a:tc>
+                <a:tc>
+                  <a:txBody>
+                    <a:bodyPr/>
+                    <a:lstStyle/>
+                    <a:p>
+                      <a:pPr lvl="0" indent="0" marL="0">
+                        <a:buNone/>
+                      </a:pPr>
+                      <a:r>
+                        <a:rPr/>
+                        <a:t>...</a:t>
+                      </a:r>
+                    </a:p>
+                  </a:txBody>
+                </a:tc>
+              </a:tr>
+              <a:tr h="0">
+                <a:tc>
+                  <a:txBody>
+                    <a:bodyPr/>
+                    <a:lstStyle/>
+                    <a:p>
+                      <a:pPr lvl="0" indent="0" marL="0">
+                        <a:buNone/>
+                      </a:pPr>
+                      <a:r>
+                        <a:rPr/>
+                        <a:t>895</a:t>
+                      </a:r>
+                    </a:p>
+                  </a:txBody>
+                </a:tc>
+                <a:tc>
+                  <a:txBody>
+                    <a:bodyPr/>
+                    <a:lstStyle/>
+                    <a:p>
+                      <a:pPr lvl="0" indent="0" marL="0">
+                        <a:buNone/>
+                      </a:pPr>
+                      <a:r>
+                        <a:rPr/>
+                        <a:t>sugarberry</a:t>
+                      </a:r>
+                    </a:p>
+                  </a:txBody>
+                </a:tc>
+                <a:tc>
+                  <a:txBody>
+                    <a:bodyPr/>
+                    <a:lstStyle/>
+                    <a:p>
+                      <a:pPr lvl="0" indent="0" marL="0">
+                        <a:buNone/>
+                      </a:pPr>
+                      <a:r>
+                        <a:rPr/>
+                        <a:t>6</a:t>
+                      </a:r>
+                    </a:p>
+                  </a:txBody>
+                </a:tc>
+                <a:tc>
+                  <a:txBody>
+                    <a:bodyPr/>
+                    <a:lstStyle/>
+                    <a:p>
+                      <a:pPr lvl="0" indent="0" marL="0">
+                        <a:buNone/>
+                      </a:pPr>
+                      <a:r>
+                        <a:rPr/>
+                        <a:t>1051.773141</a:t>
+                      </a:r>
+                    </a:p>
+                  </a:txBody>
+                </a:tc>
+                <a:tc>
+                  <a:txBody>
+                    <a:bodyPr/>
+                    <a:lstStyle/>
+                    <a:p>
+                      <a:pPr lvl="0" indent="0" marL="0">
+                        <a:buNone/>
+                      </a:pPr>
+                      <a:r>
+                        <a:rPr/>
+                        <a:t>32.431052</a:t>
+                      </a:r>
+                    </a:p>
+                  </a:txBody>
+                </a:tc>
+                <a:tc>
+                  <a:txBody>
+                    <a:bodyPr/>
+                    <a:lstStyle/>
+                    <a:p>
+                      <a:pPr lvl="0" indent="0" marL="0">
+                        <a:buNone/>
+                      </a:pPr>
+                      <a:r>
+                        <a:rPr/>
+                        <a:t>20.969306</a:t>
+                      </a:r>
+                    </a:p>
+                  </a:txBody>
+                </a:tc>
+                <a:tc>
+                  <a:txBody>
+                    <a:bodyPr/>
+                    <a:lstStyle/>
+                    <a:p>
+                      <a:pPr lvl="0" indent="0" marL="0">
+                        <a:buNone/>
+                      </a:pPr>
+                      <a:r>
+                        <a:rPr/>
+                        <a:t>0.565727</a:t>
+                      </a:r>
+                    </a:p>
+                  </a:txBody>
+                </a:tc>
+              </a:tr>
+              <a:tr h="0">
+                <a:tc>
+                  <a:txBody>
+                    <a:bodyPr/>
+                    <a:lstStyle/>
+                    <a:p>
+                      <a:pPr lvl="0" indent="0" marL="0">
+                        <a:buNone/>
+                      </a:pPr>
+                      <a:r>
+                        <a:rPr/>
+                        <a:t>896</a:t>
+                      </a:r>
+                    </a:p>
+                  </a:txBody>
+                </a:tc>
+                <a:tc>
+                  <a:txBody>
+                    <a:bodyPr/>
+                    <a:lstStyle/>
+                    <a:p>
+                      <a:pPr lvl="0" indent="0" marL="0">
+                        <a:buNone/>
+                      </a:pPr>
+                      <a:r>
+                        <a:rPr/>
+                        <a:t>sugarberry</a:t>
+                      </a:r>
+                    </a:p>
+                  </a:txBody>
+                </a:tc>
+                <a:tc>
+                  <a:txBody>
+                    <a:bodyPr/>
+                    <a:lstStyle/>
+                    <a:p>
+                      <a:pPr lvl="0" indent="0" marL="0">
+                        <a:buNone/>
+                      </a:pPr>
+                      <a:r>
+                        <a:rPr/>
+                        <a:t>7</a:t>
+                      </a:r>
+                    </a:p>
+                  </a:txBody>
+                </a:tc>
+                <a:tc>
+                  <a:txBody>
+                    <a:bodyPr/>
+                    <a:lstStyle/>
+                    <a:p>
+                      <a:pPr lvl="0" indent="0" marL="0">
+                        <a:buNone/>
+                      </a:pPr>
+                      <a:r>
+                        <a:rPr/>
+                        <a:t>1393.100286</a:t>
+                      </a:r>
+                    </a:p>
+                  </a:txBody>
+                </a:tc>
+                <a:tc>
+                  <a:txBody>
+                    <a:bodyPr/>
+                    <a:lstStyle/>
+                    <a:p>
+                      <a:pPr lvl="0" indent="0" marL="0">
+                        <a:buNone/>
+                      </a:pPr>
+                      <a:r>
+                        <a:rPr/>
+                        <a:t>37.324259</a:t>
+                      </a:r>
+                    </a:p>
+                  </a:txBody>
+                </a:tc>
+                <a:tc>
+                  <a:txBody>
+                    <a:bodyPr/>
+                    <a:lstStyle/>
+                    <a:p>
+                      <a:pPr lvl="0" indent="0" marL="0">
+                        <a:buNone/>
+                      </a:pPr>
+                      <a:r>
+                        <a:rPr/>
+                        <a:t>25.037024</a:t>
+                      </a:r>
+                    </a:p>
+                  </a:txBody>
+                </a:tc>
+                <a:tc>
+                  <a:txBody>
+                    <a:bodyPr/>
+                    <a:lstStyle/>
+                    <a:p>
+                      <a:pPr lvl="0" indent="0" marL="0">
+                        <a:buNone/>
+                      </a:pPr>
+                      <a:r>
+                        <a:rPr/>
+                        <a:t>0.637629</a:t>
+                      </a:r>
+                    </a:p>
+                  </a:txBody>
+                </a:tc>
+              </a:tr>
+              <a:tr h="0">
+                <a:tc>
+                  <a:txBody>
+                    <a:bodyPr/>
+                    <a:lstStyle/>
+                    <a:p>
+                      <a:pPr lvl="0" indent="0" marL="0">
+                        <a:buNone/>
+                      </a:pPr>
+                      <a:r>
+                        <a:rPr/>
+                        <a:t>897</a:t>
+                      </a:r>
+                    </a:p>
+                  </a:txBody>
+                </a:tc>
+                <a:tc>
+                  <a:txBody>
+                    <a:bodyPr/>
+                    <a:lstStyle/>
+                    <a:p>
+                      <a:pPr lvl="0" indent="0" marL="0">
+                        <a:buNone/>
+                      </a:pPr>
+                      <a:r>
+                        <a:rPr/>
+                        <a:t>sugarberry</a:t>
+                      </a:r>
+                    </a:p>
+                  </a:txBody>
+                </a:tc>
+                <a:tc>
+                  <a:txBody>
+                    <a:bodyPr/>
+                    <a:lstStyle/>
+                    <a:p>
+                      <a:pPr lvl="0" indent="0" marL="0">
+                        <a:buNone/>
+                      </a:pPr>
+                      <a:r>
+                        <a:rPr/>
+                        <a:t>8</a:t>
+                      </a:r>
+                    </a:p>
+                  </a:txBody>
+                </a:tc>
+                <a:tc>
+                  <a:txBody>
+                    <a:bodyPr/>
+                    <a:lstStyle/>
+                    <a:p>
+                      <a:pPr lvl="0" indent="0" marL="0">
+                        <a:buNone/>
+                      </a:pPr>
+                      <a:r>
+                        <a:rPr/>
+                        <a:t>1455.022421</a:t>
+                      </a:r>
+                    </a:p>
+                  </a:txBody>
+                </a:tc>
+                <a:tc>
+                  <a:txBody>
+                    <a:bodyPr/>
+                    <a:lstStyle/>
+                    <a:p>
+                      <a:pPr lvl="0" indent="0" marL="0">
+                        <a:buNone/>
+                      </a:pPr>
+                      <a:r>
+                        <a:rPr/>
+                        <a:t>38.144756</a:t>
+                      </a:r>
+                    </a:p>
+                  </a:txBody>
+                </a:tc>
+                <a:tc>
+                  <a:txBody>
+                    <a:bodyPr/>
+                    <a:lstStyle/>
+                    <a:p>
+                      <a:pPr lvl="0" indent="0" marL="0">
+                        <a:buNone/>
+                      </a:pPr>
+                      <a:r>
+                        <a:rPr/>
+                        <a:t>26.680208</a:t>
+                      </a:r>
+                    </a:p>
+                  </a:txBody>
+                </a:tc>
+                <a:tc>
+                  <a:txBody>
+                    <a:bodyPr/>
+                    <a:lstStyle/>
+                    <a:p>
+                      <a:pPr lvl="0" indent="0" marL="0">
+                        <a:buNone/>
+                      </a:pPr>
+                      <a:r>
+                        <a:rPr/>
+                        <a:t>0.665159</a:t>
+                      </a:r>
+                    </a:p>
+                  </a:txBody>
+                </a:tc>
+              </a:tr>
+              <a:tr h="0">
+                <a:tc>
+                  <a:txBody>
+                    <a:bodyPr/>
+                    <a:lstStyle/>
+                    <a:p>
+                      <a:pPr lvl="0" indent="0" marL="0">
+                        <a:buNone/>
+                      </a:pPr>
+                      <a:r>
+                        <a:rPr/>
+                        <a:t>898</a:t>
+                      </a:r>
+                    </a:p>
+                  </a:txBody>
+                </a:tc>
+                <a:tc>
+                  <a:txBody>
+                    <a:bodyPr/>
+                    <a:lstStyle/>
+                    <a:p>
+                      <a:pPr lvl="0" indent="0" marL="0">
+                        <a:buNone/>
+                      </a:pPr>
+                      <a:r>
+                        <a:rPr/>
+                        <a:t>sugarberry</a:t>
+                      </a:r>
+                    </a:p>
+                  </a:txBody>
+                </a:tc>
+                <a:tc>
+                  <a:txBody>
+                    <a:bodyPr/>
+                    <a:lstStyle/>
+                    <a:p>
+                      <a:pPr lvl="0" indent="0" marL="0">
+                        <a:buNone/>
+                      </a:pPr>
+                      <a:r>
+                        <a:rPr/>
+                        <a:t>9</a:t>
+                      </a:r>
+                    </a:p>
+                  </a:txBody>
+                </a:tc>
+                <a:tc>
+                  <a:txBody>
+                    <a:bodyPr/>
+                    <a:lstStyle/>
+                    <a:p>
+                      <a:pPr lvl="0" indent="0" marL="0">
+                        <a:buNone/>
+                      </a:pPr>
+                      <a:r>
+                        <a:rPr/>
+                        <a:t>1358.161657</a:t>
+                      </a:r>
+                    </a:p>
+                  </a:txBody>
+                </a:tc>
+                <a:tc>
+                  <a:txBody>
+                    <a:bodyPr/>
+                    <a:lstStyle/>
+                    <a:p>
+                      <a:pPr lvl="0" indent="0" marL="0">
+                        <a:buNone/>
+                      </a:pPr>
+                      <a:r>
+                        <a:rPr/>
+                        <a:t>36.853245</a:t>
+                      </a:r>
+                    </a:p>
+                  </a:txBody>
+                </a:tc>
+                <a:tc>
+                  <a:txBody>
+                    <a:bodyPr/>
+                    <a:lstStyle/>
+                    <a:p>
+                      <a:pPr lvl="0" indent="0" marL="0">
+                        <a:buNone/>
+                      </a:pPr>
+                      <a:r>
+                        <a:rPr/>
+                        <a:t>21.021667</a:t>
+                      </a:r>
+                    </a:p>
+                  </a:txBody>
+                </a:tc>
+                <a:tc>
+                  <a:txBody>
+                    <a:bodyPr/>
+                    <a:lstStyle/>
+                    <a:p>
+                      <a:pPr lvl="0" indent="0" marL="0">
+                        <a:buNone/>
+                      </a:pPr>
+                      <a:r>
+                        <a:rPr/>
+                        <a:t>0.685162</a:t>
+                      </a:r>
+                    </a:p>
+                  </a:txBody>
+                </a:tc>
+              </a:tr>
+              <a:tr h="0">
+                <a:tc>
+                  <a:txBody>
+                    <a:bodyPr/>
+                    <a:lstStyle/>
+                    <a:p>
+                      <a:pPr lvl="0" indent="0" marL="0">
+                        <a:buNone/>
+                      </a:pPr>
+                      <a:r>
+                        <a:rPr/>
+                        <a:t>899</a:t>
+                      </a:r>
+                    </a:p>
+                  </a:txBody>
+                </a:tc>
+                <a:tc>
+                  <a:txBody>
+                    <a:bodyPr/>
+                    <a:lstStyle/>
+                    <a:p>
+                      <a:pPr lvl="0" indent="0" marL="0">
+                        <a:buNone/>
+                      </a:pPr>
+                      <a:r>
+                        <a:rPr/>
+                        <a:t>sugarberry</a:t>
+                      </a:r>
+                    </a:p>
+                  </a:txBody>
+                </a:tc>
+                <a:tc>
+                  <a:txBody>
+                    <a:bodyPr/>
+                    <a:lstStyle/>
+                    <a:p>
+                      <a:pPr lvl="0" indent="0" marL="0">
+                        <a:buNone/>
+                      </a:pPr>
+                      <a:r>
+                        <a:rPr/>
+                        <a:t>10</a:t>
+                      </a:r>
+                    </a:p>
+                  </a:txBody>
+                </a:tc>
+                <a:tc>
+                  <a:txBody>
+                    <a:bodyPr/>
+                    <a:lstStyle/>
+                    <a:p>
+                      <a:pPr lvl="0" indent="0" marL="0">
+                        <a:buNone/>
+                      </a:pPr>
+                      <a:r>
+                        <a:rPr/>
+                        <a:t>1607.296767</a:t>
+                      </a:r>
+                    </a:p>
+                  </a:txBody>
+                </a:tc>
+                <a:tc>
+                  <a:txBody>
+                    <a:bodyPr/>
+                    <a:lstStyle/>
+                    <a:p>
+                      <a:pPr lvl="0" indent="0" marL="0">
+                        <a:buNone/>
+                      </a:pPr>
+                      <a:r>
+                        <a:rPr/>
+                        <a:t>40.091106</a:t>
+                      </a:r>
+                    </a:p>
+                  </a:txBody>
+                </a:tc>
+                <a:tc>
+                  <a:txBody>
+                    <a:bodyPr/>
+                    <a:lstStyle/>
+                    <a:p>
+                      <a:pPr lvl="0" indent="0" marL="0">
+                        <a:buNone/>
+                      </a:pPr>
+                      <a:r>
+                        <a:rPr/>
+                        <a:t>23.172083</a:t>
+                      </a:r>
+                    </a:p>
+                  </a:txBody>
+                </a:tc>
+                <a:tc>
+                  <a:txBody>
+                    <a:bodyPr/>
+                    <a:lstStyle/>
+                    <a:p>
+                      <a:pPr lvl="0" indent="0" marL="0">
+                        <a:buNone/>
+                      </a:pPr>
+                      <a:r>
+                        <a:rPr/>
+                        <a:t>0.677519</a:t>
                       </a:r>
                     </a:p>
                   </a:txBody>
@@ -3769,6 +4625,31 @@
           <a:chExt cx="0" cy="0"/>
         </a:xfrm>
       </p:grpSpPr>
+      <p:sp>
+        <p:nvSpPr>
+          <p:cNvPr id="2" name="Title 1"/>
+          <p:cNvSpPr>
+            <a:spLocks noGrp="1"/>
+          </p:cNvSpPr>
+          <p:nvPr>
+            <p:ph type="title"/>
+          </p:nvPr>
+        </p:nvSpPr>
+        <p:spPr/>
+        <p:txBody>
+          <a:bodyPr/>
+          <a:lstStyle/>
+          <a:p>
+            <a:pPr lvl="0" indent="0" marL="0">
+              <a:buNone/>
+            </a:pPr>
+            <a:r>
+              <a:rPr/>
+              <a:t>Technical Lead</a:t>
+            </a:r>
+          </a:p>
+        </p:txBody>
+      </p:sp>
       <p:graphicFrame>
         <p:nvGraphicFramePr>
           <p:cNvPr id="6" name="Content Placeholder 5"/>
@@ -3790,9 +4671,11 @@
                 <a:tableStyleId>{5C22544A-7EE6-4342-B048-85BDC9FD1C3A}</a:tableStyleId>
               </a:tblPr>
               <a:tblGrid>
-                <a:gridCol w="2743200"/>
-                <a:gridCol w="2743200"/>
-                <a:gridCol w="2743200"/>
+                <a:gridCol w="1638300"/>
+                <a:gridCol w="1638300"/>
+                <a:gridCol w="1638300"/>
+                <a:gridCol w="1638300"/>
+                <a:gridCol w="1638300"/>
               </a:tblGrid>
               <a:tr h="0">
                 <a:tc>
@@ -3831,7 +4714,39 @@
                       </a:pPr>
                       <a:r>
                         <a:rPr/>
-                        <a:t>COMMON_NAME</a:t>
+                        <a:t>DO_BH</a:t>
+                      </a:r>
+                    </a:p>
+                  </a:txBody>
+                  <a:tcPr/>
+                </a:tc>
+                <a:tc>
+                  <a:txBody>
+                    <a:bodyPr/>
+                    <a:lstStyle/>
+                    <a:p>
+                      <a:pPr lvl="0" indent="0" marL="0">
+                        <a:buNone/>
+                      </a:pPr>
+                      <a:r>
+                        <a:rPr/>
+                        <a:t>HT_TOT</a:t>
+                      </a:r>
+                    </a:p>
+                  </a:txBody>
+                  <a:tcPr/>
+                </a:tc>
+                <a:tc>
+                  <a:txBody>
+                    <a:bodyPr/>
+                    <a:lstStyle/>
+                    <a:p>
+                      <a:pPr lvl="0" indent="0" marL="0">
+                        <a:buNone/>
+                      </a:pPr>
+                      <a:r>
+                        <a:rPr/>
+                        <a:t>TT_DW_CRM</a:t>
                       </a:r>
                     </a:p>
                   </a:txBody>
@@ -3864,22 +4779,52 @@
                       </a:pPr>
                       <a:r>
                         <a:rPr/>
-                        <a:t>10</a:t>
-                      </a:r>
-                    </a:p>
-                  </a:txBody>
-                </a:tc>
-                <a:tc>
-                  <a:txBody>
-                    <a:bodyPr/>
-                    <a:lstStyle/>
-                    <a:p>
-                      <a:pPr lvl="0" indent="0" marL="0">
-                        <a:buNone/>
-                      </a:pPr>
-                      <a:r>
-                        <a:rPr/>
-                        <a:t>fir spp.</a:t>
+                        <a:t>12</a:t>
+                      </a:r>
+                    </a:p>
+                  </a:txBody>
+                </a:tc>
+                <a:tc>
+                  <a:txBody>
+                    <a:bodyPr/>
+                    <a:lstStyle/>
+                    <a:p>
+                      <a:pPr lvl="0" indent="0" marL="0">
+                        <a:buNone/>
+                      </a:pPr>
+                      <a:r>
+                        <a:rPr/>
+                        <a:t>7.5</a:t>
+                      </a:r>
+                    </a:p>
+                  </a:txBody>
+                </a:tc>
+                <a:tc>
+                  <a:txBody>
+                    <a:bodyPr/>
+                    <a:lstStyle/>
+                    <a:p>
+                      <a:pPr lvl="0" indent="0" marL="0">
+                        <a:buNone/>
+                      </a:pPr>
+                      <a:r>
+                        <a:rPr/>
+                        <a:t>45.2</a:t>
+                      </a:r>
+                    </a:p>
+                  </a:txBody>
+                </a:tc>
+                <a:tc>
+                  <a:txBody>
+                    <a:bodyPr/>
+                    <a:lstStyle/>
+                    <a:p>
+                      <a:pPr lvl="0" indent="0" marL="0">
+                        <a:buNone/>
+                      </a:pPr>
+                      <a:r>
+                        <a:rPr/>
+                        <a:t>178.86</a:t>
                       </a:r>
                     </a:p>
                   </a:txBody>
@@ -3911,22 +4856,52 @@
                       </a:pPr>
                       <a:r>
                         <a:rPr/>
-                        <a:t>11</a:t>
-                      </a:r>
-                    </a:p>
-                  </a:txBody>
-                </a:tc>
-                <a:tc>
-                  <a:txBody>
-                    <a:bodyPr/>
-                    <a:lstStyle/>
-                    <a:p>
-                      <a:pPr lvl="0" indent="0" marL="0">
-                        <a:buNone/>
-                      </a:pPr>
-                      <a:r>
-                        <a:rPr/>
-                        <a:t>Pacific silver fir</a:t>
+                        <a:t>12</a:t>
+                      </a:r>
+                    </a:p>
+                  </a:txBody>
+                </a:tc>
+                <a:tc>
+                  <a:txBody>
+                    <a:bodyPr/>
+                    <a:lstStyle/>
+                    <a:p>
+                      <a:pPr lvl="0" indent="0" marL="0">
+                        <a:buNone/>
+                      </a:pPr>
+                      <a:r>
+                        <a:rPr/>
+                        <a:t>9.3</a:t>
+                      </a:r>
+                    </a:p>
+                  </a:txBody>
+                </a:tc>
+                <a:tc>
+                  <a:txBody>
+                    <a:bodyPr/>
+                    <a:lstStyle/>
+                    <a:p>
+                      <a:pPr lvl="0" indent="0" marL="0">
+                        <a:buNone/>
+                      </a:pPr>
+                      <a:r>
+                        <a:rPr/>
+                        <a:t>62.7</a:t>
+                      </a:r>
+                    </a:p>
+                  </a:txBody>
+                </a:tc>
+                <a:tc>
+                  <a:txBody>
+                    <a:bodyPr/>
+                    <a:lstStyle/>
+                    <a:p>
+                      <a:pPr lvl="0" indent="0" marL="0">
+                        <a:buNone/>
+                      </a:pPr>
+                      <a:r>
+                        <a:rPr/>
+                        <a:t>323.46</a:t>
                       </a:r>
                     </a:p>
                   </a:txBody>
@@ -3973,7 +4948,37 @@
                       </a:pPr>
                       <a:r>
                         <a:rPr/>
-                        <a:t>balsam fir</a:t>
+                        <a:t>9.7</a:t>
+                      </a:r>
+                    </a:p>
+                  </a:txBody>
+                </a:tc>
+                <a:tc>
+                  <a:txBody>
+                    <a:bodyPr/>
+                    <a:lstStyle/>
+                    <a:p>
+                      <a:pPr lvl="0" indent="0" marL="0">
+                        <a:buNone/>
+                      </a:pPr>
+                      <a:r>
+                        <a:rPr/>
+                        <a:t>56.7</a:t>
+                      </a:r>
+                    </a:p>
+                  </a:txBody>
+                </a:tc>
+                <a:tc>
+                  <a:txBody>
+                    <a:bodyPr/>
+                    <a:lstStyle/>
+                    <a:p>
+                      <a:pPr lvl="0" indent="0" marL="0">
+                        <a:buNone/>
+                      </a:pPr>
+                      <a:r>
+                        <a:rPr/>
+                        <a:t>342.47</a:t>
                       </a:r>
                     </a:p>
                   </a:txBody>
@@ -4005,22 +5010,52 @@
                       </a:pPr>
                       <a:r>
                         <a:rPr/>
-                        <a:t>14</a:t>
-                      </a:r>
-                    </a:p>
-                  </a:txBody>
-                </a:tc>
-                <a:tc>
-                  <a:txBody>
-                    <a:bodyPr/>
-                    <a:lstStyle/>
-                    <a:p>
-                      <a:pPr lvl="0" indent="0" marL="0">
-                        <a:buNone/>
-                      </a:pPr>
-                      <a:r>
-                        <a:rPr/>
-                        <a:t>Santa Lucia or bristlecone fir</a:t>
+                        <a:t>12</a:t>
+                      </a:r>
+                    </a:p>
+                  </a:txBody>
+                </a:tc>
+                <a:tc>
+                  <a:txBody>
+                    <a:bodyPr/>
+                    <a:lstStyle/>
+                    <a:p>
+                      <a:pPr lvl="0" indent="0" marL="0">
+                        <a:buNone/>
+                      </a:pPr>
+                      <a:r>
+                        <a:rPr/>
+                        <a:t>11.4</a:t>
+                      </a:r>
+                    </a:p>
+                  </a:txBody>
+                </a:tc>
+                <a:tc>
+                  <a:txBody>
+                    <a:bodyPr/>
+                    <a:lstStyle/>
+                    <a:p>
+                      <a:pPr lvl="0" indent="0" marL="0">
+                        <a:buNone/>
+                      </a:pPr>
+                      <a:r>
+                        <a:rPr/>
+                        <a:t>66.1</a:t>
+                      </a:r>
+                    </a:p>
+                  </a:txBody>
+                </a:tc>
+                <a:tc>
+                  <a:txBody>
+                    <a:bodyPr/>
+                    <a:lstStyle/>
+                    <a:p>
+                      <a:pPr lvl="0" indent="0" marL="0">
+                        <a:buNone/>
+                      </a:pPr>
+                      <a:r>
+                        <a:rPr/>
+                        <a:t>499.35</a:t>
                       </a:r>
                     </a:p>
                   </a:txBody>
@@ -4052,22 +5087,52 @@
                       </a:pPr>
                       <a:r>
                         <a:rPr/>
-                        <a:t>15</a:t>
-                      </a:r>
-                    </a:p>
-                  </a:txBody>
-                </a:tc>
-                <a:tc>
-                  <a:txBody>
-                    <a:bodyPr/>
-                    <a:lstStyle/>
-                    <a:p>
-                      <a:pPr lvl="0" indent="0" marL="0">
-                        <a:buNone/>
-                      </a:pPr>
-                      <a:r>
-                        <a:rPr/>
-                        <a:t>white fir</a:t>
+                        <a:t>12</a:t>
+                      </a:r>
+                    </a:p>
+                  </a:txBody>
+                </a:tc>
+                <a:tc>
+                  <a:txBody>
+                    <a:bodyPr/>
+                    <a:lstStyle/>
+                    <a:p>
+                      <a:pPr lvl="0" indent="0" marL="0">
+                        <a:buNone/>
+                      </a:pPr>
+                      <a:r>
+                        <a:rPr/>
+                        <a:t>6.4</a:t>
+                      </a:r>
+                    </a:p>
+                  </a:txBody>
+                </a:tc>
+                <a:tc>
+                  <a:txBody>
+                    <a:bodyPr/>
+                    <a:lstStyle/>
+                    <a:p>
+                      <a:pPr lvl="0" indent="0" marL="0">
+                        <a:buNone/>
+                      </a:pPr>
+                      <a:r>
+                        <a:rPr/>
+                        <a:t>51.8</a:t>
+                      </a:r>
+                    </a:p>
+                  </a:txBody>
+                </a:tc>
+                <a:tc>
+                  <a:txBody>
+                    <a:bodyPr/>
+                    <a:lstStyle/>
+                    <a:p>
+                      <a:pPr lvl="0" indent="0" marL="0">
+                        <a:buNone/>
+                      </a:pPr>
+                      <a:r>
+                        <a:rPr/>
+                        <a:t>113.92</a:t>
                       </a:r>
                     </a:p>
                   </a:txBody>
@@ -4120,12 +5185,9 @@
                 <a:tableStyleId>{5C22544A-7EE6-4342-B048-85BDC9FD1C3A}</a:tableStyleId>
               </a:tblPr>
               <a:tblGrid>
-                <a:gridCol w="1371600"/>
-                <a:gridCol w="1371600"/>
-                <a:gridCol w="1371600"/>
-                <a:gridCol w="1371600"/>
-                <a:gridCol w="1371600"/>
-                <a:gridCol w="1371600"/>
+                <a:gridCol w="2743200"/>
+                <a:gridCol w="2743200"/>
+                <a:gridCol w="2743200"/>
               </a:tblGrid>
               <a:tr h="0">
                 <a:tc>
@@ -4164,54 +5226,6 @@
                       </a:pPr>
                       <a:r>
                         <a:rPr/>
-                        <a:t>DO_BH</a:t>
-                      </a:r>
-                    </a:p>
-                  </a:txBody>
-                  <a:tcPr/>
-                </a:tc>
-                <a:tc>
-                  <a:txBody>
-                    <a:bodyPr/>
-                    <a:lstStyle/>
-                    <a:p>
-                      <a:pPr lvl="0" indent="0" marL="0">
-                        <a:buNone/>
-                      </a:pPr>
-                      <a:r>
-                        <a:rPr/>
-                        <a:t>HT_TOT</a:t>
-                      </a:r>
-                    </a:p>
-                  </a:txBody>
-                  <a:tcPr/>
-                </a:tc>
-                <a:tc>
-                  <a:txBody>
-                    <a:bodyPr/>
-                    <a:lstStyle/>
-                    <a:p>
-                      <a:pPr lvl="0" indent="0" marL="0">
-                        <a:buNone/>
-                      </a:pPr>
-                      <a:r>
-                        <a:rPr/>
-                        <a:t>TT_DW_CRM</a:t>
-                      </a:r>
-                    </a:p>
-                  </a:txBody>
-                  <a:tcPr/>
-                </a:tc>
-                <a:tc>
-                  <a:txBody>
-                    <a:bodyPr/>
-                    <a:lstStyle/>
-                    <a:p>
-                      <a:pPr lvl="0" indent="0" marL="0">
-                        <a:buNone/>
-                      </a:pPr>
-                      <a:r>
-                        <a:rPr/>
                         <a:t>COMMON_NAME</a:t>
                       </a:r>
                     </a:p>
@@ -4245,67 +5259,22 @@
                       </a:pPr>
                       <a:r>
                         <a:rPr/>
-                        <a:t>12</a:t>
-                      </a:r>
-                    </a:p>
-                  </a:txBody>
-                </a:tc>
-                <a:tc>
-                  <a:txBody>
-                    <a:bodyPr/>
-                    <a:lstStyle/>
-                    <a:p>
-                      <a:pPr lvl="0" indent="0" marL="0">
-                        <a:buNone/>
-                      </a:pPr>
-                      <a:r>
-                        <a:rPr/>
-                        <a:t>7.5</a:t>
-                      </a:r>
-                    </a:p>
-                  </a:txBody>
-                </a:tc>
-                <a:tc>
-                  <a:txBody>
-                    <a:bodyPr/>
-                    <a:lstStyle/>
-                    <a:p>
-                      <a:pPr lvl="0" indent="0" marL="0">
-                        <a:buNone/>
-                      </a:pPr>
-                      <a:r>
-                        <a:rPr/>
-                        <a:t>45.2</a:t>
-                      </a:r>
-                    </a:p>
-                  </a:txBody>
-                </a:tc>
-                <a:tc>
-                  <a:txBody>
-                    <a:bodyPr/>
-                    <a:lstStyle/>
-                    <a:p>
-                      <a:pPr lvl="0" indent="0" marL="0">
-                        <a:buNone/>
-                      </a:pPr>
-                      <a:r>
-                        <a:rPr/>
-                        <a:t>178.86</a:t>
-                      </a:r>
-                    </a:p>
-                  </a:txBody>
-                </a:tc>
-                <a:tc>
-                  <a:txBody>
-                    <a:bodyPr/>
-                    <a:lstStyle/>
-                    <a:p>
-                      <a:pPr lvl="0" indent="0" marL="0">
-                        <a:buNone/>
-                      </a:pPr>
-                      <a:r>
-                        <a:rPr/>
-                        <a:t>balsam fir</a:t>
+                        <a:t>10</a:t>
+                      </a:r>
+                    </a:p>
+                  </a:txBody>
+                </a:tc>
+                <a:tc>
+                  <a:txBody>
+                    <a:bodyPr/>
+                    <a:lstStyle/>
+                    <a:p>
+                      <a:pPr lvl="0" indent="0" marL="0">
+                        <a:buNone/>
+                      </a:pPr>
+                      <a:r>
+                        <a:rPr/>
+                        <a:t>fir spp.</a:t>
                       </a:r>
                     </a:p>
                   </a:txBody>
@@ -4337,67 +5306,22 @@
                       </a:pPr>
                       <a:r>
                         <a:rPr/>
-                        <a:t>12</a:t>
-                      </a:r>
-                    </a:p>
-                  </a:txBody>
-                </a:tc>
-                <a:tc>
-                  <a:txBody>
-                    <a:bodyPr/>
-                    <a:lstStyle/>
-                    <a:p>
-                      <a:pPr lvl="0" indent="0" marL="0">
-                        <a:buNone/>
-                      </a:pPr>
-                      <a:r>
-                        <a:rPr/>
-                        <a:t>9.3</a:t>
-                      </a:r>
-                    </a:p>
-                  </a:txBody>
-                </a:tc>
-                <a:tc>
-                  <a:txBody>
-                    <a:bodyPr/>
-                    <a:lstStyle/>
-                    <a:p>
-                      <a:pPr lvl="0" indent="0" marL="0">
-                        <a:buNone/>
-                      </a:pPr>
-                      <a:r>
-                        <a:rPr/>
-                        <a:t>62.7</a:t>
-                      </a:r>
-                    </a:p>
-                  </a:txBody>
-                </a:tc>
-                <a:tc>
-                  <a:txBody>
-                    <a:bodyPr/>
-                    <a:lstStyle/>
-                    <a:p>
-                      <a:pPr lvl="0" indent="0" marL="0">
-                        <a:buNone/>
-                      </a:pPr>
-                      <a:r>
-                        <a:rPr/>
-                        <a:t>323.46</a:t>
-                      </a:r>
-                    </a:p>
-                  </a:txBody>
-                </a:tc>
-                <a:tc>
-                  <a:txBody>
-                    <a:bodyPr/>
-                    <a:lstStyle/>
-                    <a:p>
-                      <a:pPr lvl="0" indent="0" marL="0">
-                        <a:buNone/>
-                      </a:pPr>
-                      <a:r>
-                        <a:rPr/>
-                        <a:t>balsam fir</a:t>
+                        <a:t>11</a:t>
+                      </a:r>
+                    </a:p>
+                  </a:txBody>
+                </a:tc>
+                <a:tc>
+                  <a:txBody>
+                    <a:bodyPr/>
+                    <a:lstStyle/>
+                    <a:p>
+                      <a:pPr lvl="0" indent="0" marL="0">
+                        <a:buNone/>
+                      </a:pPr>
+                      <a:r>
+                        <a:rPr/>
+                        <a:t>Pacific silver fir</a:t>
                       </a:r>
                     </a:p>
                   </a:txBody>
@@ -4444,51 +5368,6 @@
                       </a:pPr>
                       <a:r>
                         <a:rPr/>
-                        <a:t>9.7</a:t>
-                      </a:r>
-                    </a:p>
-                  </a:txBody>
-                </a:tc>
-                <a:tc>
-                  <a:txBody>
-                    <a:bodyPr/>
-                    <a:lstStyle/>
-                    <a:p>
-                      <a:pPr lvl="0" indent="0" marL="0">
-                        <a:buNone/>
-                      </a:pPr>
-                      <a:r>
-                        <a:rPr/>
-                        <a:t>56.7</a:t>
-                      </a:r>
-                    </a:p>
-                  </a:txBody>
-                </a:tc>
-                <a:tc>
-                  <a:txBody>
-                    <a:bodyPr/>
-                    <a:lstStyle/>
-                    <a:p>
-                      <a:pPr lvl="0" indent="0" marL="0">
-                        <a:buNone/>
-                      </a:pPr>
-                      <a:r>
-                        <a:rPr/>
-                        <a:t>342.47</a:t>
-                      </a:r>
-                    </a:p>
-                  </a:txBody>
-                </a:tc>
-                <a:tc>
-                  <a:txBody>
-                    <a:bodyPr/>
-                    <a:lstStyle/>
-                    <a:p>
-                      <a:pPr lvl="0" indent="0" marL="0">
-                        <a:buNone/>
-                      </a:pPr>
-                      <a:r>
-                        <a:rPr/>
                         <a:t>balsam fir</a:t>
                       </a:r>
                     </a:p>
@@ -4521,67 +5400,22 @@
                       </a:pPr>
                       <a:r>
                         <a:rPr/>
-                        <a:t>12</a:t>
-                      </a:r>
-                    </a:p>
-                  </a:txBody>
-                </a:tc>
-                <a:tc>
-                  <a:txBody>
-                    <a:bodyPr/>
-                    <a:lstStyle/>
-                    <a:p>
-                      <a:pPr lvl="0" indent="0" marL="0">
-                        <a:buNone/>
-                      </a:pPr>
-                      <a:r>
-                        <a:rPr/>
-                        <a:t>11.4</a:t>
-                      </a:r>
-                    </a:p>
-                  </a:txBody>
-                </a:tc>
-                <a:tc>
-                  <a:txBody>
-                    <a:bodyPr/>
-                    <a:lstStyle/>
-                    <a:p>
-                      <a:pPr lvl="0" indent="0" marL="0">
-                        <a:buNone/>
-                      </a:pPr>
-                      <a:r>
-                        <a:rPr/>
-                        <a:t>66.1</a:t>
-                      </a:r>
-                    </a:p>
-                  </a:txBody>
-                </a:tc>
-                <a:tc>
-                  <a:txBody>
-                    <a:bodyPr/>
-                    <a:lstStyle/>
-                    <a:p>
-                      <a:pPr lvl="0" indent="0" marL="0">
-                        <a:buNone/>
-                      </a:pPr>
-                      <a:r>
-                        <a:rPr/>
-                        <a:t>499.35</a:t>
-                      </a:r>
-                    </a:p>
-                  </a:txBody>
-                </a:tc>
-                <a:tc>
-                  <a:txBody>
-                    <a:bodyPr/>
-                    <a:lstStyle/>
-                    <a:p>
-                      <a:pPr lvl="0" indent="0" marL="0">
-                        <a:buNone/>
-                      </a:pPr>
-                      <a:r>
-                        <a:rPr/>
-                        <a:t>balsam fir</a:t>
+                        <a:t>14</a:t>
+                      </a:r>
+                    </a:p>
+                  </a:txBody>
+                </a:tc>
+                <a:tc>
+                  <a:txBody>
+                    <a:bodyPr/>
+                    <a:lstStyle/>
+                    <a:p>
+                      <a:pPr lvl="0" indent="0" marL="0">
+                        <a:buNone/>
+                      </a:pPr>
+                      <a:r>
+                        <a:rPr/>
+                        <a:t>Santa Lucia or bristlecone fir</a:t>
                       </a:r>
                     </a:p>
                   </a:txBody>
@@ -4613,67 +5447,22 @@
                       </a:pPr>
                       <a:r>
                         <a:rPr/>
-                        <a:t>12</a:t>
-                      </a:r>
-                    </a:p>
-                  </a:txBody>
-                </a:tc>
-                <a:tc>
-                  <a:txBody>
-                    <a:bodyPr/>
-                    <a:lstStyle/>
-                    <a:p>
-                      <a:pPr lvl="0" indent="0" marL="0">
-                        <a:buNone/>
-                      </a:pPr>
-                      <a:r>
-                        <a:rPr/>
-                        <a:t>6.4</a:t>
-                      </a:r>
-                    </a:p>
-                  </a:txBody>
-                </a:tc>
-                <a:tc>
-                  <a:txBody>
-                    <a:bodyPr/>
-                    <a:lstStyle/>
-                    <a:p>
-                      <a:pPr lvl="0" indent="0" marL="0">
-                        <a:buNone/>
-                      </a:pPr>
-                      <a:r>
-                        <a:rPr/>
-                        <a:t>51.8</a:t>
-                      </a:r>
-                    </a:p>
-                  </a:txBody>
-                </a:tc>
-                <a:tc>
-                  <a:txBody>
-                    <a:bodyPr/>
-                    <a:lstStyle/>
-                    <a:p>
-                      <a:pPr lvl="0" indent="0" marL="0">
-                        <a:buNone/>
-                      </a:pPr>
-                      <a:r>
-                        <a:rPr/>
-                        <a:t>113.92</a:t>
-                      </a:r>
-                    </a:p>
-                  </a:txBody>
-                </a:tc>
-                <a:tc>
-                  <a:txBody>
-                    <a:bodyPr/>
-                    <a:lstStyle/>
-                    <a:p>
-                      <a:pPr lvl="0" indent="0" marL="0">
-                        <a:buNone/>
-                      </a:pPr>
-                      <a:r>
-                        <a:rPr/>
-                        <a:t>balsam fir</a:t>
+                        <a:t>15</a:t>
+                      </a:r>
+                    </a:p>
+                  </a:txBody>
+                </a:tc>
+                <a:tc>
+                  <a:txBody>
+                    <a:bodyPr/>
+                    <a:lstStyle/>
+                    <a:p>
+                      <a:pPr lvl="0" indent="0" marL="0">
+                        <a:buNone/>
+                      </a:pPr>
+                      <a:r>
+                        <a:rPr/>
+                        <a:t>white fir</a:t>
                       </a:r>
                     </a:p>
                   </a:txBody>
@@ -4705,6 +5494,612 @@
           <a:chExt cx="0" cy="0"/>
         </a:xfrm>
       </p:grpSpPr>
+      <p:graphicFrame>
+        <p:nvGraphicFramePr>
+          <p:cNvPr id="6" name="Content Placeholder 5"/>
+          <p:cNvGraphicFramePr>
+            <a:graphicFrameLocks noGrp="1"/>
+          </p:cNvGraphicFramePr>
+          <p:nvPr>
+            <p:ph idx="1"/>
+          </p:nvPr>
+        </p:nvGraphicFramePr>
+        <p:xfrm>
+          <a:off x="457200" y="1193800"/>
+          <a:ext cx="8229600" cy="3390900"/>
+        </p:xfrm>
+        <a:graphic>
+          <a:graphicData uri="http://schemas.openxmlformats.org/drawingml/2006/table">
+            <a:tbl>
+              <a:tblPr firstRow="1" bandRow="1">
+                <a:tableStyleId>{5C22544A-7EE6-4342-B048-85BDC9FD1C3A}</a:tableStyleId>
+              </a:tblPr>
+              <a:tblGrid>
+                <a:gridCol w="1371600"/>
+                <a:gridCol w="1371600"/>
+                <a:gridCol w="1371600"/>
+                <a:gridCol w="1371600"/>
+                <a:gridCol w="1371600"/>
+                <a:gridCol w="1371600"/>
+              </a:tblGrid>
+              <a:tr h="0">
+                <a:tc>
+                  <a:txBody>
+                    <a:bodyPr/>
+                    <a:lstStyle/>
+                    <a:p>
+                      <a:endParaRPr/>
+                    </a:p>
+                  </a:txBody>
+                  <a:tcPr/>
+                </a:tc>
+                <a:tc>
+                  <a:txBody>
+                    <a:bodyPr/>
+                    <a:lstStyle/>
+                    <a:p>
+                      <a:pPr lvl="0" indent="0" marL="0">
+                        <a:buNone/>
+                      </a:pPr>
+                      <a:r>
+                        <a:rPr/>
+                        <a:t>SPCD</a:t>
+                      </a:r>
+                    </a:p>
+                  </a:txBody>
+                  <a:tcPr/>
+                </a:tc>
+                <a:tc>
+                  <a:txBody>
+                    <a:bodyPr/>
+                    <a:lstStyle/>
+                    <a:p>
+                      <a:pPr lvl="0" indent="0" marL="0">
+                        <a:buNone/>
+                      </a:pPr>
+                      <a:r>
+                        <a:rPr/>
+                        <a:t>DO_BH</a:t>
+                      </a:r>
+                    </a:p>
+                  </a:txBody>
+                  <a:tcPr/>
+                </a:tc>
+                <a:tc>
+                  <a:txBody>
+                    <a:bodyPr/>
+                    <a:lstStyle/>
+                    <a:p>
+                      <a:pPr lvl="0" indent="0" marL="0">
+                        <a:buNone/>
+                      </a:pPr>
+                      <a:r>
+                        <a:rPr/>
+                        <a:t>HT_TOT</a:t>
+                      </a:r>
+                    </a:p>
+                  </a:txBody>
+                  <a:tcPr/>
+                </a:tc>
+                <a:tc>
+                  <a:txBody>
+                    <a:bodyPr/>
+                    <a:lstStyle/>
+                    <a:p>
+                      <a:pPr lvl="0" indent="0" marL="0">
+                        <a:buNone/>
+                      </a:pPr>
+                      <a:r>
+                        <a:rPr/>
+                        <a:t>TT_DW_CRM</a:t>
+                      </a:r>
+                    </a:p>
+                  </a:txBody>
+                  <a:tcPr/>
+                </a:tc>
+                <a:tc>
+                  <a:txBody>
+                    <a:bodyPr/>
+                    <a:lstStyle/>
+                    <a:p>
+                      <a:pPr lvl="0" indent="0" marL="0">
+                        <a:buNone/>
+                      </a:pPr>
+                      <a:r>
+                        <a:rPr/>
+                        <a:t>COMMON_NAME</a:t>
+                      </a:r>
+                    </a:p>
+                  </a:txBody>
+                  <a:tcPr/>
+                </a:tc>
+              </a:tr>
+              <a:tr h="0">
+                <a:tc>
+                  <a:txBody>
+                    <a:bodyPr/>
+                    <a:lstStyle/>
+                    <a:p>
+                      <a:pPr lvl="0" indent="0" marL="0">
+                        <a:buNone/>
+                      </a:pPr>
+                      <a:r>
+                        <a:rPr/>
+                        <a:t>0</a:t>
+                      </a:r>
+                    </a:p>
+                  </a:txBody>
+                </a:tc>
+                <a:tc>
+                  <a:txBody>
+                    <a:bodyPr/>
+                    <a:lstStyle/>
+                    <a:p>
+                      <a:pPr lvl="0" indent="0" marL="0">
+                        <a:buNone/>
+                      </a:pPr>
+                      <a:r>
+                        <a:rPr/>
+                        <a:t>12</a:t>
+                      </a:r>
+                    </a:p>
+                  </a:txBody>
+                </a:tc>
+                <a:tc>
+                  <a:txBody>
+                    <a:bodyPr/>
+                    <a:lstStyle/>
+                    <a:p>
+                      <a:pPr lvl="0" indent="0" marL="0">
+                        <a:buNone/>
+                      </a:pPr>
+                      <a:r>
+                        <a:rPr/>
+                        <a:t>7.5</a:t>
+                      </a:r>
+                    </a:p>
+                  </a:txBody>
+                </a:tc>
+                <a:tc>
+                  <a:txBody>
+                    <a:bodyPr/>
+                    <a:lstStyle/>
+                    <a:p>
+                      <a:pPr lvl="0" indent="0" marL="0">
+                        <a:buNone/>
+                      </a:pPr>
+                      <a:r>
+                        <a:rPr/>
+                        <a:t>45.2</a:t>
+                      </a:r>
+                    </a:p>
+                  </a:txBody>
+                </a:tc>
+                <a:tc>
+                  <a:txBody>
+                    <a:bodyPr/>
+                    <a:lstStyle/>
+                    <a:p>
+                      <a:pPr lvl="0" indent="0" marL="0">
+                        <a:buNone/>
+                      </a:pPr>
+                      <a:r>
+                        <a:rPr/>
+                        <a:t>178.86</a:t>
+                      </a:r>
+                    </a:p>
+                  </a:txBody>
+                </a:tc>
+                <a:tc>
+                  <a:txBody>
+                    <a:bodyPr/>
+                    <a:lstStyle/>
+                    <a:p>
+                      <a:pPr lvl="0" indent="0" marL="0">
+                        <a:buNone/>
+                      </a:pPr>
+                      <a:r>
+                        <a:rPr/>
+                        <a:t>balsam fir</a:t>
+                      </a:r>
+                    </a:p>
+                  </a:txBody>
+                </a:tc>
+              </a:tr>
+              <a:tr h="0">
+                <a:tc>
+                  <a:txBody>
+                    <a:bodyPr/>
+                    <a:lstStyle/>
+                    <a:p>
+                      <a:pPr lvl="0" indent="0" marL="0">
+                        <a:buNone/>
+                      </a:pPr>
+                      <a:r>
+                        <a:rPr/>
+                        <a:t>1</a:t>
+                      </a:r>
+                    </a:p>
+                  </a:txBody>
+                </a:tc>
+                <a:tc>
+                  <a:txBody>
+                    <a:bodyPr/>
+                    <a:lstStyle/>
+                    <a:p>
+                      <a:pPr lvl="0" indent="0" marL="0">
+                        <a:buNone/>
+                      </a:pPr>
+                      <a:r>
+                        <a:rPr/>
+                        <a:t>12</a:t>
+                      </a:r>
+                    </a:p>
+                  </a:txBody>
+                </a:tc>
+                <a:tc>
+                  <a:txBody>
+                    <a:bodyPr/>
+                    <a:lstStyle/>
+                    <a:p>
+                      <a:pPr lvl="0" indent="0" marL="0">
+                        <a:buNone/>
+                      </a:pPr>
+                      <a:r>
+                        <a:rPr/>
+                        <a:t>9.3</a:t>
+                      </a:r>
+                    </a:p>
+                  </a:txBody>
+                </a:tc>
+                <a:tc>
+                  <a:txBody>
+                    <a:bodyPr/>
+                    <a:lstStyle/>
+                    <a:p>
+                      <a:pPr lvl="0" indent="0" marL="0">
+                        <a:buNone/>
+                      </a:pPr>
+                      <a:r>
+                        <a:rPr/>
+                        <a:t>62.7</a:t>
+                      </a:r>
+                    </a:p>
+                  </a:txBody>
+                </a:tc>
+                <a:tc>
+                  <a:txBody>
+                    <a:bodyPr/>
+                    <a:lstStyle/>
+                    <a:p>
+                      <a:pPr lvl="0" indent="0" marL="0">
+                        <a:buNone/>
+                      </a:pPr>
+                      <a:r>
+                        <a:rPr/>
+                        <a:t>323.46</a:t>
+                      </a:r>
+                    </a:p>
+                  </a:txBody>
+                </a:tc>
+                <a:tc>
+                  <a:txBody>
+                    <a:bodyPr/>
+                    <a:lstStyle/>
+                    <a:p>
+                      <a:pPr lvl="0" indent="0" marL="0">
+                        <a:buNone/>
+                      </a:pPr>
+                      <a:r>
+                        <a:rPr/>
+                        <a:t>balsam fir</a:t>
+                      </a:r>
+                    </a:p>
+                  </a:txBody>
+                </a:tc>
+              </a:tr>
+              <a:tr h="0">
+                <a:tc>
+                  <a:txBody>
+                    <a:bodyPr/>
+                    <a:lstStyle/>
+                    <a:p>
+                      <a:pPr lvl="0" indent="0" marL="0">
+                        <a:buNone/>
+                      </a:pPr>
+                      <a:r>
+                        <a:rPr/>
+                        <a:t>2</a:t>
+                      </a:r>
+                    </a:p>
+                  </a:txBody>
+                </a:tc>
+                <a:tc>
+                  <a:txBody>
+                    <a:bodyPr/>
+                    <a:lstStyle/>
+                    <a:p>
+                      <a:pPr lvl="0" indent="0" marL="0">
+                        <a:buNone/>
+                      </a:pPr>
+                      <a:r>
+                        <a:rPr/>
+                        <a:t>12</a:t>
+                      </a:r>
+                    </a:p>
+                  </a:txBody>
+                </a:tc>
+                <a:tc>
+                  <a:txBody>
+                    <a:bodyPr/>
+                    <a:lstStyle/>
+                    <a:p>
+                      <a:pPr lvl="0" indent="0" marL="0">
+                        <a:buNone/>
+                      </a:pPr>
+                      <a:r>
+                        <a:rPr/>
+                        <a:t>9.7</a:t>
+                      </a:r>
+                    </a:p>
+                  </a:txBody>
+                </a:tc>
+                <a:tc>
+                  <a:txBody>
+                    <a:bodyPr/>
+                    <a:lstStyle/>
+                    <a:p>
+                      <a:pPr lvl="0" indent="0" marL="0">
+                        <a:buNone/>
+                      </a:pPr>
+                      <a:r>
+                        <a:rPr/>
+                        <a:t>56.7</a:t>
+                      </a:r>
+                    </a:p>
+                  </a:txBody>
+                </a:tc>
+                <a:tc>
+                  <a:txBody>
+                    <a:bodyPr/>
+                    <a:lstStyle/>
+                    <a:p>
+                      <a:pPr lvl="0" indent="0" marL="0">
+                        <a:buNone/>
+                      </a:pPr>
+                      <a:r>
+                        <a:rPr/>
+                        <a:t>342.47</a:t>
+                      </a:r>
+                    </a:p>
+                  </a:txBody>
+                </a:tc>
+                <a:tc>
+                  <a:txBody>
+                    <a:bodyPr/>
+                    <a:lstStyle/>
+                    <a:p>
+                      <a:pPr lvl="0" indent="0" marL="0">
+                        <a:buNone/>
+                      </a:pPr>
+                      <a:r>
+                        <a:rPr/>
+                        <a:t>balsam fir</a:t>
+                      </a:r>
+                    </a:p>
+                  </a:txBody>
+                </a:tc>
+              </a:tr>
+              <a:tr h="0">
+                <a:tc>
+                  <a:txBody>
+                    <a:bodyPr/>
+                    <a:lstStyle/>
+                    <a:p>
+                      <a:pPr lvl="0" indent="0" marL="0">
+                        <a:buNone/>
+                      </a:pPr>
+                      <a:r>
+                        <a:rPr/>
+                        <a:t>3</a:t>
+                      </a:r>
+                    </a:p>
+                  </a:txBody>
+                </a:tc>
+                <a:tc>
+                  <a:txBody>
+                    <a:bodyPr/>
+                    <a:lstStyle/>
+                    <a:p>
+                      <a:pPr lvl="0" indent="0" marL="0">
+                        <a:buNone/>
+                      </a:pPr>
+                      <a:r>
+                        <a:rPr/>
+                        <a:t>12</a:t>
+                      </a:r>
+                    </a:p>
+                  </a:txBody>
+                </a:tc>
+                <a:tc>
+                  <a:txBody>
+                    <a:bodyPr/>
+                    <a:lstStyle/>
+                    <a:p>
+                      <a:pPr lvl="0" indent="0" marL="0">
+                        <a:buNone/>
+                      </a:pPr>
+                      <a:r>
+                        <a:rPr/>
+                        <a:t>11.4</a:t>
+                      </a:r>
+                    </a:p>
+                  </a:txBody>
+                </a:tc>
+                <a:tc>
+                  <a:txBody>
+                    <a:bodyPr/>
+                    <a:lstStyle/>
+                    <a:p>
+                      <a:pPr lvl="0" indent="0" marL="0">
+                        <a:buNone/>
+                      </a:pPr>
+                      <a:r>
+                        <a:rPr/>
+                        <a:t>66.1</a:t>
+                      </a:r>
+                    </a:p>
+                  </a:txBody>
+                </a:tc>
+                <a:tc>
+                  <a:txBody>
+                    <a:bodyPr/>
+                    <a:lstStyle/>
+                    <a:p>
+                      <a:pPr lvl="0" indent="0" marL="0">
+                        <a:buNone/>
+                      </a:pPr>
+                      <a:r>
+                        <a:rPr/>
+                        <a:t>499.35</a:t>
+                      </a:r>
+                    </a:p>
+                  </a:txBody>
+                </a:tc>
+                <a:tc>
+                  <a:txBody>
+                    <a:bodyPr/>
+                    <a:lstStyle/>
+                    <a:p>
+                      <a:pPr lvl="0" indent="0" marL="0">
+                        <a:buNone/>
+                      </a:pPr>
+                      <a:r>
+                        <a:rPr/>
+                        <a:t>balsam fir</a:t>
+                      </a:r>
+                    </a:p>
+                  </a:txBody>
+                </a:tc>
+              </a:tr>
+              <a:tr h="0">
+                <a:tc>
+                  <a:txBody>
+                    <a:bodyPr/>
+                    <a:lstStyle/>
+                    <a:p>
+                      <a:pPr lvl="0" indent="0" marL="0">
+                        <a:buNone/>
+                      </a:pPr>
+                      <a:r>
+                        <a:rPr/>
+                        <a:t>4</a:t>
+                      </a:r>
+                    </a:p>
+                  </a:txBody>
+                </a:tc>
+                <a:tc>
+                  <a:txBody>
+                    <a:bodyPr/>
+                    <a:lstStyle/>
+                    <a:p>
+                      <a:pPr lvl="0" indent="0" marL="0">
+                        <a:buNone/>
+                      </a:pPr>
+                      <a:r>
+                        <a:rPr/>
+                        <a:t>12</a:t>
+                      </a:r>
+                    </a:p>
+                  </a:txBody>
+                </a:tc>
+                <a:tc>
+                  <a:txBody>
+                    <a:bodyPr/>
+                    <a:lstStyle/>
+                    <a:p>
+                      <a:pPr lvl="0" indent="0" marL="0">
+                        <a:buNone/>
+                      </a:pPr>
+                      <a:r>
+                        <a:rPr/>
+                        <a:t>6.4</a:t>
+                      </a:r>
+                    </a:p>
+                  </a:txBody>
+                </a:tc>
+                <a:tc>
+                  <a:txBody>
+                    <a:bodyPr/>
+                    <a:lstStyle/>
+                    <a:p>
+                      <a:pPr lvl="0" indent="0" marL="0">
+                        <a:buNone/>
+                      </a:pPr>
+                      <a:r>
+                        <a:rPr/>
+                        <a:t>51.8</a:t>
+                      </a:r>
+                    </a:p>
+                  </a:txBody>
+                </a:tc>
+                <a:tc>
+                  <a:txBody>
+                    <a:bodyPr/>
+                    <a:lstStyle/>
+                    <a:p>
+                      <a:pPr lvl="0" indent="0" marL="0">
+                        <a:buNone/>
+                      </a:pPr>
+                      <a:r>
+                        <a:rPr/>
+                        <a:t>113.92</a:t>
+                      </a:r>
+                    </a:p>
+                  </a:txBody>
+                </a:tc>
+                <a:tc>
+                  <a:txBody>
+                    <a:bodyPr/>
+                    <a:lstStyle/>
+                    <a:p>
+                      <a:pPr lvl="0" indent="0" marL="0">
+                        <a:buNone/>
+                      </a:pPr>
+                      <a:r>
+                        <a:rPr/>
+                        <a:t>balsam fir</a:t>
+                      </a:r>
+                    </a:p>
+                  </a:txBody>
+                </a:tc>
+              </a:tr>
+            </a:tbl>
+          </a:graphicData>
+        </a:graphic>
+      </p:graphicFrame>
+    </p:spTree>
+  </p:cSld>
+</p:sld>
+</file>
+
+<file path=ppt/slides/slide15.xml><?xml version="1.0" encoding="utf-8"?>
+<p:sld xmlns:a="http://schemas.openxmlformats.org/drawingml/2006/main" xmlns:r="http://schemas.openxmlformats.org/officeDocument/2006/relationships" xmlns:p="http://schemas.openxmlformats.org/presentationml/2006/main">
+  <p:cSld>
+    <p:spTree>
+      <p:nvGrpSpPr>
+        <p:cNvPr id="1" name=""/>
+        <p:cNvGrpSpPr/>
+        <p:nvPr/>
+      </p:nvGrpSpPr>
+      <p:grpSpPr>
+        <a:xfrm>
+          <a:off x="0" y="0"/>
+          <a:ext cx="0" cy="0"/>
+          <a:chOff x="0" y="0"/>
+          <a:chExt cx="0" cy="0"/>
+        </a:xfrm>
+      </p:grpSpPr>
       <p:sp>
         <p:nvSpPr>
           <p:cNvPr id="2" name="Title 1"/>
@@ -4754,12 +6149,12 @@
       </p:grpSpPr>
       <p:sp>
         <p:nvSpPr>
-          <p:cNvPr id="3" name="Content Placeholder 2"/>
+          <p:cNvPr id="2" name="Title 1"/>
           <p:cNvSpPr>
             <a:spLocks noGrp="1"/>
           </p:cNvSpPr>
           <p:nvPr>
-            <p:ph idx="1"/>
+            <p:ph type="title"/>
           </p:nvPr>
         </p:nvSpPr>
         <p:spPr/>
@@ -4772,7 +6167,37 @@
             </a:pPr>
             <a:r>
               <a:rPr/>
-              <a:t>#Redwood Analytics Project 3</a:t>
+              <a:t>Data Dictionary</a:t>
+            </a:r>
+          </a:p>
+        </p:txBody>
+      </p:sp>
+      <p:sp>
+        <p:nvSpPr>
+          <p:cNvPr id="3" name="Content Placeholder 2"/>
+          <p:cNvSpPr>
+            <a:spLocks noGrp="1"/>
+          </p:cNvSpPr>
+          <p:nvPr>
+            <p:ph idx="1"/>
+          </p:nvPr>
+        </p:nvSpPr>
+        <p:spPr/>
+        <p:txBody>
+          <a:bodyPr/>
+          <a:lstStyle/>
+          <a:p>
+            <a:pPr lvl="0"/>
+            <a:r>
+              <a:rPr/>
+              <a:t>SPCD (Species Code): A numeric code which unqiuely identifies each tree species as specifed by the FIA (Forest Inventory and Analysis) species coding system. Each FIA species code corresponds uniquely to a scientific and common name. (Official definition: FIA species code.)</a:t>
+            </a:r>
+          </a:p>
+          <a:p>
+            <a:pPr lvl="0"/>
+            <a:r>
+              <a:rPr/>
+              <a:t>DO_BH (Diameter at Breast Height [Outside Bark]): Diameter of the tree stem measured at breast height (4.5 feet or 1.37 meters above ground) including bark. This is the standard foresty measurement “DBH (outside bark)” and is the primary size variable used in nearly all allometric biomass models. This is measured in inches.</a:t>
             </a:r>
           </a:p>
         </p:txBody>
@@ -4819,7 +6244,7 @@
             </a:pPr>
             <a:r>
               <a:rPr/>
-              <a:t>Data Dictionary</a:t>
+              <a:t>Data Dictionary Continued</a:t>
             </a:r>
           </a:p>
         </p:txBody>
@@ -4842,14 +6267,16 @@
             <a:pPr lvl="0"/>
             <a:r>
               <a:rPr/>
-              <a:t>SPCD (Species Code): A numeric code which unqiuely identifies each tree species as specifed by the FIA (Forest Inventory and Analysis) species coding system. Each FIA species code corresponds uniquely to a scientific and common name. (Official definition: FIA species code.)</a:t>
-            </a:r>
-          </a:p>
-          <a:p>
-            <a:pPr lvl="0"/>
+              <a:t>HT_TOT (Total Tree Height): The total height of the tree measured from ground level to the top of the crown. Used as a second size metric in volume and biomass modeling.This is measured in feet.</a:t>
+            </a:r>
+          </a:p>
+          <a:p>
+            <a:pPr lvl="0" indent="0" marL="0">
+              <a:buNone/>
+            </a:pPr>
             <a:r>
               <a:rPr/>
-              <a:t>DO_BH (Diameter at Breast Height [Outside Bark]): Diameter of the tree stem measured at breast height (4.5 feet or 1.37 meters above ground) including bark. This is the standard foresty measurement “DBH (outside bark)” and is the primary size variable used in nearly all allometric biomass models. This is measured in inches.</a:t>
+              <a:t>-TT_DW_CRM (Total Tree Dry Biomass): The total above-ground dry weight of the tree (includes stem wood, stem bark, branches, folliage). This value comes from destructive sampling: the tree was felled, seperated into componenets, oven-dried, and weighed. This variable serves as the response variable (“target”) from biomass prediction. This is measured in kilograms.</a:t>
             </a:r>
           </a:p>
         </p:txBody>
@@ -4860,85 +6287,6 @@
 </file>
 
 <file path=ppt/slides/slide4.xml><?xml version="1.0" encoding="utf-8"?>
-<p:sld xmlns:a="http://schemas.openxmlformats.org/drawingml/2006/main" xmlns:r="http://schemas.openxmlformats.org/officeDocument/2006/relationships" xmlns:p="http://schemas.openxmlformats.org/presentationml/2006/main">
-  <p:cSld>
-    <p:spTree>
-      <p:nvGrpSpPr>
-        <p:cNvPr id="1" name=""/>
-        <p:cNvGrpSpPr/>
-        <p:nvPr/>
-      </p:nvGrpSpPr>
-      <p:grpSpPr>
-        <a:xfrm>
-          <a:off x="0" y="0"/>
-          <a:ext cx="0" cy="0"/>
-          <a:chOff x="0" y="0"/>
-          <a:chExt cx="0" cy="0"/>
-        </a:xfrm>
-      </p:grpSpPr>
-      <p:sp>
-        <p:nvSpPr>
-          <p:cNvPr id="2" name="Title 1"/>
-          <p:cNvSpPr>
-            <a:spLocks noGrp="1"/>
-          </p:cNvSpPr>
-          <p:nvPr>
-            <p:ph type="title"/>
-          </p:nvPr>
-        </p:nvSpPr>
-        <p:spPr/>
-        <p:txBody>
-          <a:bodyPr/>
-          <a:lstStyle/>
-          <a:p>
-            <a:pPr lvl="0" indent="0" marL="0">
-              <a:buNone/>
-            </a:pPr>
-            <a:r>
-              <a:rPr/>
-              <a:t>Data Dictionary Continued</a:t>
-            </a:r>
-          </a:p>
-        </p:txBody>
-      </p:sp>
-      <p:sp>
-        <p:nvSpPr>
-          <p:cNvPr id="3" name="Content Placeholder 2"/>
-          <p:cNvSpPr>
-            <a:spLocks noGrp="1"/>
-          </p:cNvSpPr>
-          <p:nvPr>
-            <p:ph idx="1"/>
-          </p:nvPr>
-        </p:nvSpPr>
-        <p:spPr/>
-        <p:txBody>
-          <a:bodyPr/>
-          <a:lstStyle/>
-          <a:p>
-            <a:pPr lvl="0"/>
-            <a:r>
-              <a:rPr/>
-              <a:t>HT_TOT (Total Tree Height): The total height of the tree measured from ground level to the top of the crown. Used as a second size metric in volume and biomass modeling.This is measured in feet.</a:t>
-            </a:r>
-          </a:p>
-          <a:p>
-            <a:pPr lvl="0" indent="0" marL="0">
-              <a:buNone/>
-            </a:pPr>
-            <a:r>
-              <a:rPr/>
-              <a:t>-TT_DW_CRM (Total Tree Dry Biomass): The total above-ground dry weight of the tree (includes stem wood, stem bark, branches, folliage). This value comes from destructive sampling: the tree was felled, seperated into componenets, oven-dried, and weighed. This variable serves as the response variable (“target”) from biomass prediction. This is measured in kilograms.</a:t>
-            </a:r>
-          </a:p>
-        </p:txBody>
-      </p:sp>
-    </p:spTree>
-  </p:cSld>
-</p:sld>
-</file>
-
-<file path=ppt/slides/slide5.xml><?xml version="1.0" encoding="utf-8"?>
 <p:sld xmlns:a="http://schemas.openxmlformats.org/drawingml/2006/main" xmlns:r="http://schemas.openxmlformats.org/officeDocument/2006/relationships" xmlns:p="http://schemas.openxmlformats.org/presentationml/2006/main">
   <p:cSld>
     <p:spTree>
@@ -5015,6 +6363,819 @@
 </p:sld>
 </file>
 
+<file path=ppt/slides/slide5.xml><?xml version="1.0" encoding="utf-8"?>
+<p:sld xmlns:a="http://schemas.openxmlformats.org/drawingml/2006/main" xmlns:r="http://schemas.openxmlformats.org/officeDocument/2006/relationships" xmlns:p="http://schemas.openxmlformats.org/presentationml/2006/main">
+  <p:cSld>
+    <p:spTree>
+      <p:nvGrpSpPr>
+        <p:cNvPr id="1" name=""/>
+        <p:cNvGrpSpPr/>
+        <p:nvPr/>
+      </p:nvGrpSpPr>
+      <p:grpSpPr>
+        <a:xfrm>
+          <a:off x="0" y="0"/>
+          <a:ext cx="0" cy="0"/>
+          <a:chOff x="0" y="0"/>
+          <a:chExt cx="0" cy="0"/>
+        </a:xfrm>
+      </p:grpSpPr>
+      <p:sp>
+        <p:nvSpPr>
+          <p:cNvPr id="2" name="Title 1"/>
+          <p:cNvSpPr>
+            <a:spLocks noGrp="1"/>
+          </p:cNvSpPr>
+          <p:nvPr>
+            <p:ph type="title"/>
+          </p:nvPr>
+        </p:nvSpPr>
+        <p:spPr>
+          <a:xfrm>
+            <a:off x="457201" y="204787"/>
+            <a:ext cx="3008313" cy="871538"/>
+          </a:xfrm>
+        </p:spPr>
+        <p:txBody>
+          <a:bodyPr/>
+          <a:lstStyle/>
+          <a:p>
+            <a:pPr lvl="0" indent="0" marL="0">
+              <a:buNone/>
+            </a:pPr>
+            <a:r>
+              <a:rPr/>
+              <a:t>Data Summaries</a:t>
+            </a:r>
+          </a:p>
+        </p:txBody>
+      </p:sp>
+      <p:sp>
+        <p:nvSpPr>
+          <p:cNvPr id="4" name="Text Placeholder 3"/>
+          <p:cNvSpPr>
+            <a:spLocks noGrp="1"/>
+          </p:cNvSpPr>
+          <p:nvPr>
+            <p:ph idx="2" sz="half" type="body"/>
+          </p:nvPr>
+        </p:nvSpPr>
+        <p:spPr/>
+        <p:txBody>
+          <a:bodyPr/>
+          <a:lstStyle/>
+          <a:p>
+            <a:pPr lvl="0" indent="0">
+              <a:buNone/>
+            </a:pPr>
+            <a:r>
+              <a:rPr>
+                <a:latin typeface="Courier"/>
+              </a:rPr>
+              <a:t>COMMON_NAME
+loblolly pine     20140
+slash pine         8006
+Douglas-fir        7322
+ponderosa pine     5609
+shortleaf pine     5599
+longleaf pine      4949
+white oak          3955
+sweetgum           3494
+yellow-poplar      3372
+red maple          3109
+Name: count, dtype: int64</a:t>
+            </a:r>
+          </a:p>
+        </p:txBody>
+      </p:sp>
+      <p:graphicFrame>
+        <p:nvGraphicFramePr>
+          <p:cNvPr id="6" name="Content Placeholder 5"/>
+          <p:cNvGraphicFramePr>
+            <a:graphicFrameLocks noGrp="1"/>
+          </p:cNvGraphicFramePr>
+          <p:nvPr>
+            <p:ph idx="1"/>
+          </p:nvPr>
+        </p:nvGraphicFramePr>
+        <p:xfrm>
+          <a:off x="3568700" y="203200"/>
+          <a:ext cx="5105400" cy="4381500"/>
+        </p:xfrm>
+        <a:graphic>
+          <a:graphicData uri="http://schemas.openxmlformats.org/drawingml/2006/table">
+            <a:tbl>
+              <a:tblPr firstRow="1" bandRow="1">
+                <a:tableStyleId>{5C22544A-7EE6-4342-B048-85BDC9FD1C3A}</a:tableStyleId>
+              </a:tblPr>
+              <a:tblGrid>
+                <a:gridCol w="1016000"/>
+                <a:gridCol w="1016000"/>
+                <a:gridCol w="1016000"/>
+                <a:gridCol w="1016000"/>
+                <a:gridCol w="1016000"/>
+              </a:tblGrid>
+              <a:tr h="0">
+                <a:tc>
+                  <a:txBody>
+                    <a:bodyPr/>
+                    <a:lstStyle/>
+                    <a:p>
+                      <a:endParaRPr/>
+                    </a:p>
+                  </a:txBody>
+                  <a:tcPr/>
+                </a:tc>
+                <a:tc>
+                  <a:txBody>
+                    <a:bodyPr/>
+                    <a:lstStyle/>
+                    <a:p>
+                      <a:pPr lvl="0" indent="0" marL="0">
+                        <a:buNone/>
+                      </a:pPr>
+                      <a:r>
+                        <a:rPr/>
+                        <a:t>SPCD</a:t>
+                      </a:r>
+                    </a:p>
+                  </a:txBody>
+                  <a:tcPr/>
+                </a:tc>
+                <a:tc>
+                  <a:txBody>
+                    <a:bodyPr/>
+                    <a:lstStyle/>
+                    <a:p>
+                      <a:pPr lvl="0" indent="0" marL="0">
+                        <a:buNone/>
+                      </a:pPr>
+                      <a:r>
+                        <a:rPr/>
+                        <a:t>DO_BH</a:t>
+                      </a:r>
+                    </a:p>
+                  </a:txBody>
+                  <a:tcPr/>
+                </a:tc>
+                <a:tc>
+                  <a:txBody>
+                    <a:bodyPr/>
+                    <a:lstStyle/>
+                    <a:p>
+                      <a:pPr lvl="0" indent="0" marL="0">
+                        <a:buNone/>
+                      </a:pPr>
+                      <a:r>
+                        <a:rPr/>
+                        <a:t>HT_TOT</a:t>
+                      </a:r>
+                    </a:p>
+                  </a:txBody>
+                  <a:tcPr/>
+                </a:tc>
+                <a:tc>
+                  <a:txBody>
+                    <a:bodyPr/>
+                    <a:lstStyle/>
+                    <a:p>
+                      <a:pPr lvl="0" indent="0" marL="0">
+                        <a:buNone/>
+                      </a:pPr>
+                      <a:r>
+                        <a:rPr/>
+                        <a:t>TT_DW_CRM</a:t>
+                      </a:r>
+                    </a:p>
+                  </a:txBody>
+                  <a:tcPr/>
+                </a:tc>
+              </a:tr>
+              <a:tr h="0">
+                <a:tc>
+                  <a:txBody>
+                    <a:bodyPr/>
+                    <a:lstStyle/>
+                    <a:p>
+                      <a:pPr lvl="0" indent="0" marL="0">
+                        <a:buNone/>
+                      </a:pPr>
+                      <a:r>
+                        <a:rPr/>
+                        <a:t>count</a:t>
+                      </a:r>
+                    </a:p>
+                  </a:txBody>
+                </a:tc>
+                <a:tc>
+                  <a:txBody>
+                    <a:bodyPr/>
+                    <a:lstStyle/>
+                    <a:p>
+                      <a:pPr lvl="0" indent="0" marL="0">
+                        <a:buNone/>
+                      </a:pPr>
+                      <a:r>
+                        <a:rPr/>
+                        <a:t>137079.000000</a:t>
+                      </a:r>
+                    </a:p>
+                  </a:txBody>
+                </a:tc>
+                <a:tc>
+                  <a:txBody>
+                    <a:bodyPr/>
+                    <a:lstStyle/>
+                    <a:p>
+                      <a:pPr lvl="0" indent="0" marL="0">
+                        <a:buNone/>
+                      </a:pPr>
+                      <a:r>
+                        <a:rPr/>
+                        <a:t>137079.000000</a:t>
+                      </a:r>
+                    </a:p>
+                  </a:txBody>
+                </a:tc>
+                <a:tc>
+                  <a:txBody>
+                    <a:bodyPr/>
+                    <a:lstStyle/>
+                    <a:p>
+                      <a:pPr lvl="0" indent="0" marL="0">
+                        <a:buNone/>
+                      </a:pPr>
+                      <a:r>
+                        <a:rPr/>
+                        <a:t>137079.000000</a:t>
+                      </a:r>
+                    </a:p>
+                  </a:txBody>
+                </a:tc>
+                <a:tc>
+                  <a:txBody>
+                    <a:bodyPr/>
+                    <a:lstStyle/>
+                    <a:p>
+                      <a:pPr lvl="0" indent="0" marL="0">
+                        <a:buNone/>
+                      </a:pPr>
+                      <a:r>
+                        <a:rPr/>
+                        <a:t>1.370790e+05</a:t>
+                      </a:r>
+                    </a:p>
+                  </a:txBody>
+                </a:tc>
+              </a:tr>
+              <a:tr h="0">
+                <a:tc>
+                  <a:txBody>
+                    <a:bodyPr/>
+                    <a:lstStyle/>
+                    <a:p>
+                      <a:pPr lvl="0" indent="0" marL="0">
+                        <a:buNone/>
+                      </a:pPr>
+                      <a:r>
+                        <a:rPr/>
+                        <a:t>mean</a:t>
+                      </a:r>
+                    </a:p>
+                  </a:txBody>
+                </a:tc>
+                <a:tc>
+                  <a:txBody>
+                    <a:bodyPr/>
+                    <a:lstStyle/>
+                    <a:p>
+                      <a:pPr lvl="0" indent="0" marL="0">
+                        <a:buNone/>
+                      </a:pPr>
+                      <a:r>
+                        <a:rPr/>
+                        <a:t>341.054465</a:t>
+                      </a:r>
+                    </a:p>
+                  </a:txBody>
+                </a:tc>
+                <a:tc>
+                  <a:txBody>
+                    <a:bodyPr/>
+                    <a:lstStyle/>
+                    <a:p>
+                      <a:pPr lvl="0" indent="0" marL="0">
+                        <a:buNone/>
+                      </a:pPr>
+                      <a:r>
+                        <a:rPr/>
+                        <a:t>11.104809</a:t>
+                      </a:r>
+                    </a:p>
+                  </a:txBody>
+                </a:tc>
+                <a:tc>
+                  <a:txBody>
+                    <a:bodyPr/>
+                    <a:lstStyle/>
+                    <a:p>
+                      <a:pPr lvl="0" indent="0" marL="0">
+                        <a:buNone/>
+                      </a:pPr>
+                      <a:r>
+                        <a:rPr/>
+                        <a:t>62.081565</a:t>
+                      </a:r>
+                    </a:p>
+                  </a:txBody>
+                </a:tc>
+                <a:tc>
+                  <a:txBody>
+                    <a:bodyPr/>
+                    <a:lstStyle/>
+                    <a:p>
+                      <a:pPr lvl="0" indent="0" marL="0">
+                        <a:buNone/>
+                      </a:pPr>
+                      <a:r>
+                        <a:rPr/>
+                        <a:t>1.530719e+03</a:t>
+                      </a:r>
+                    </a:p>
+                  </a:txBody>
+                </a:tc>
+              </a:tr>
+              <a:tr h="0">
+                <a:tc>
+                  <a:txBody>
+                    <a:bodyPr/>
+                    <a:lstStyle/>
+                    <a:p>
+                      <a:pPr lvl="0" indent="0" marL="0">
+                        <a:buNone/>
+                      </a:pPr>
+                      <a:r>
+                        <a:rPr/>
+                        <a:t>std</a:t>
+                      </a:r>
+                    </a:p>
+                  </a:txBody>
+                </a:tc>
+                <a:tc>
+                  <a:txBody>
+                    <a:bodyPr/>
+                    <a:lstStyle/>
+                    <a:p>
+                      <a:pPr lvl="0" indent="0" marL="0">
+                        <a:buNone/>
+                      </a:pPr>
+                      <a:r>
+                        <a:rPr/>
+                        <a:t>341.609599</a:t>
+                      </a:r>
+                    </a:p>
+                  </a:txBody>
+                </a:tc>
+                <a:tc>
+                  <a:txBody>
+                    <a:bodyPr/>
+                    <a:lstStyle/>
+                    <a:p>
+                      <a:pPr lvl="0" indent="0" marL="0">
+                        <a:buNone/>
+                      </a:pPr>
+                      <a:r>
+                        <a:rPr/>
+                        <a:t>8.046896</a:t>
+                      </a:r>
+                    </a:p>
+                  </a:txBody>
+                </a:tc>
+                <a:tc>
+                  <a:txBody>
+                    <a:bodyPr/>
+                    <a:lstStyle/>
+                    <a:p>
+                      <a:pPr lvl="0" indent="0" marL="0">
+                        <a:buNone/>
+                      </a:pPr>
+                      <a:r>
+                        <a:rPr/>
+                        <a:t>25.834963</a:t>
+                      </a:r>
+                    </a:p>
+                  </a:txBody>
+                </a:tc>
+                <a:tc>
+                  <a:txBody>
+                    <a:bodyPr/>
+                    <a:lstStyle/>
+                    <a:p>
+                      <a:pPr lvl="0" indent="0" marL="0">
+                        <a:buNone/>
+                      </a:pPr>
+                      <a:r>
+                        <a:rPr/>
+                        <a:t>1.698299e+04</a:t>
+                      </a:r>
+                    </a:p>
+                  </a:txBody>
+                </a:tc>
+              </a:tr>
+              <a:tr h="0">
+                <a:tc>
+                  <a:txBody>
+                    <a:bodyPr/>
+                    <a:lstStyle/>
+                    <a:p>
+                      <a:pPr lvl="0" indent="0" marL="0">
+                        <a:buNone/>
+                      </a:pPr>
+                      <a:r>
+                        <a:rPr/>
+                        <a:t>min</a:t>
+                      </a:r>
+                    </a:p>
+                  </a:txBody>
+                </a:tc>
+                <a:tc>
+                  <a:txBody>
+                    <a:bodyPr/>
+                    <a:lstStyle/>
+                    <a:p>
+                      <a:pPr lvl="0" indent="0" marL="0">
+                        <a:buNone/>
+                      </a:pPr>
+                      <a:r>
+                        <a:rPr/>
+                        <a:t>10.000000</a:t>
+                      </a:r>
+                    </a:p>
+                  </a:txBody>
+                </a:tc>
+                <a:tc>
+                  <a:txBody>
+                    <a:bodyPr/>
+                    <a:lstStyle/>
+                    <a:p>
+                      <a:pPr lvl="0" indent="0" marL="0">
+                        <a:buNone/>
+                      </a:pPr>
+                      <a:r>
+                        <a:rPr/>
+                        <a:t>1.000000</a:t>
+                      </a:r>
+                    </a:p>
+                  </a:txBody>
+                </a:tc>
+                <a:tc>
+                  <a:txBody>
+                    <a:bodyPr/>
+                    <a:lstStyle/>
+                    <a:p>
+                      <a:pPr lvl="0" indent="0" marL="0">
+                        <a:buNone/>
+                      </a:pPr>
+                      <a:r>
+                        <a:rPr/>
+                        <a:t>1.400000</a:t>
+                      </a:r>
+                    </a:p>
+                  </a:txBody>
+                </a:tc>
+                <a:tc>
+                  <a:txBody>
+                    <a:bodyPr/>
+                    <a:lstStyle/>
+                    <a:p>
+                      <a:pPr lvl="0" indent="0" marL="0">
+                        <a:buNone/>
+                      </a:pPr>
+                      <a:r>
+                        <a:rPr/>
+                        <a:t>1.020000e+00</a:t>
+                      </a:r>
+                    </a:p>
+                  </a:txBody>
+                </a:tc>
+              </a:tr>
+              <a:tr h="0">
+                <a:tc>
+                  <a:txBody>
+                    <a:bodyPr/>
+                    <a:lstStyle/>
+                    <a:p>
+                      <a:pPr lvl="0" indent="0" marL="0">
+                        <a:buNone/>
+                      </a:pPr>
+                      <a:r>
+                        <a:rPr/>
+                        <a:t>25%</a:t>
+                      </a:r>
+                    </a:p>
+                  </a:txBody>
+                </a:tc>
+                <a:tc>
+                  <a:txBody>
+                    <a:bodyPr/>
+                    <a:lstStyle/>
+                    <a:p>
+                      <a:pPr lvl="0" indent="0" marL="0">
+                        <a:buNone/>
+                      </a:pPr>
+                      <a:r>
+                        <a:rPr/>
+                        <a:t>121.000000</a:t>
+                      </a:r>
+                    </a:p>
+                  </a:txBody>
+                </a:tc>
+                <a:tc>
+                  <a:txBody>
+                    <a:bodyPr/>
+                    <a:lstStyle/>
+                    <a:p>
+                      <a:pPr lvl="0" indent="0" marL="0">
+                        <a:buNone/>
+                      </a:pPr>
+                      <a:r>
+                        <a:rPr/>
+                        <a:t>6.500000</a:t>
+                      </a:r>
+                    </a:p>
+                  </a:txBody>
+                </a:tc>
+                <a:tc>
+                  <a:txBody>
+                    <a:bodyPr/>
+                    <a:lstStyle/>
+                    <a:p>
+                      <a:pPr lvl="0" indent="0" marL="0">
+                        <a:buNone/>
+                      </a:pPr>
+                      <a:r>
+                        <a:rPr/>
+                        <a:t>45.000000</a:t>
+                      </a:r>
+                    </a:p>
+                  </a:txBody>
+                </a:tc>
+                <a:tc>
+                  <a:txBody>
+                    <a:bodyPr/>
+                    <a:lstStyle/>
+                    <a:p>
+                      <a:pPr lvl="0" indent="0" marL="0">
+                        <a:buNone/>
+                      </a:pPr>
+                      <a:r>
+                        <a:rPr/>
+                        <a:t>1.689850e+02</a:t>
+                      </a:r>
+                    </a:p>
+                  </a:txBody>
+                </a:tc>
+              </a:tr>
+              <a:tr h="0">
+                <a:tc>
+                  <a:txBody>
+                    <a:bodyPr/>
+                    <a:lstStyle/>
+                    <a:p>
+                      <a:pPr lvl="0" indent="0" marL="0">
+                        <a:buNone/>
+                      </a:pPr>
+                      <a:r>
+                        <a:rPr/>
+                        <a:t>50%</a:t>
+                      </a:r>
+                    </a:p>
+                  </a:txBody>
+                </a:tc>
+                <a:tc>
+                  <a:txBody>
+                    <a:bodyPr/>
+                    <a:lstStyle/>
+                    <a:p>
+                      <a:pPr lvl="0" indent="0" marL="0">
+                        <a:buNone/>
+                      </a:pPr>
+                      <a:r>
+                        <a:rPr/>
+                        <a:t>132.000000</a:t>
+                      </a:r>
+                    </a:p>
+                  </a:txBody>
+                </a:tc>
+                <a:tc>
+                  <a:txBody>
+                    <a:bodyPr/>
+                    <a:lstStyle/>
+                    <a:p>
+                      <a:pPr lvl="0" indent="0" marL="0">
+                        <a:buNone/>
+                      </a:pPr>
+                      <a:r>
+                        <a:rPr/>
+                        <a:t>9.900000</a:t>
+                      </a:r>
+                    </a:p>
+                  </a:txBody>
+                </a:tc>
+                <a:tc>
+                  <a:txBody>
+                    <a:bodyPr/>
+                    <a:lstStyle/>
+                    <a:p>
+                      <a:pPr lvl="0" indent="0" marL="0">
+                        <a:buNone/>
+                      </a:pPr>
+                      <a:r>
+                        <a:rPr/>
+                        <a:t>61.100000</a:t>
+                      </a:r>
+                    </a:p>
+                  </a:txBody>
+                </a:tc>
+                <a:tc>
+                  <a:txBody>
+                    <a:bodyPr/>
+                    <a:lstStyle/>
+                    <a:p>
+                      <a:pPr lvl="0" indent="0" marL="0">
+                        <a:buNone/>
+                      </a:pPr>
+                      <a:r>
+                        <a:rPr/>
+                        <a:t>5.276000e+02</a:t>
+                      </a:r>
+                    </a:p>
+                  </a:txBody>
+                </a:tc>
+              </a:tr>
+              <a:tr h="0">
+                <a:tc>
+                  <a:txBody>
+                    <a:bodyPr/>
+                    <a:lstStyle/>
+                    <a:p>
+                      <a:pPr lvl="0" indent="0" marL="0">
+                        <a:buNone/>
+                      </a:pPr>
+                      <a:r>
+                        <a:rPr/>
+                        <a:t>75%</a:t>
+                      </a:r>
+                    </a:p>
+                  </a:txBody>
+                </a:tc>
+                <a:tc>
+                  <a:txBody>
+                    <a:bodyPr/>
+                    <a:lstStyle/>
+                    <a:p>
+                      <a:pPr lvl="0" indent="0" marL="0">
+                        <a:buNone/>
+                      </a:pPr>
+                      <a:r>
+                        <a:rPr/>
+                        <a:t>611.000000</a:t>
+                      </a:r>
+                    </a:p>
+                  </a:txBody>
+                </a:tc>
+                <a:tc>
+                  <a:txBody>
+                    <a:bodyPr/>
+                    <a:lstStyle/>
+                    <a:p>
+                      <a:pPr lvl="0" indent="0" marL="0">
+                        <a:buNone/>
+                      </a:pPr>
+                      <a:r>
+                        <a:rPr/>
+                        <a:t>14.300000</a:t>
+                      </a:r>
+                    </a:p>
+                  </a:txBody>
+                </a:tc>
+                <a:tc>
+                  <a:txBody>
+                    <a:bodyPr/>
+                    <a:lstStyle/>
+                    <a:p>
+                      <a:pPr lvl="0" indent="0" marL="0">
+                        <a:buNone/>
+                      </a:pPr>
+                      <a:r>
+                        <a:rPr/>
+                        <a:t>76.700000</a:t>
+                      </a:r>
+                    </a:p>
+                  </a:txBody>
+                </a:tc>
+                <a:tc>
+                  <a:txBody>
+                    <a:bodyPr/>
+                    <a:lstStyle/>
+                    <a:p>
+                      <a:pPr lvl="0" indent="0" marL="0">
+                        <a:buNone/>
+                      </a:pPr>
+                      <a:r>
+                        <a:rPr/>
+                        <a:t>1.352070e+03</a:t>
+                      </a:r>
+                    </a:p>
+                  </a:txBody>
+                </a:tc>
+              </a:tr>
+              <a:tr h="0">
+                <a:tc>
+                  <a:txBody>
+                    <a:bodyPr/>
+                    <a:lstStyle/>
+                    <a:p>
+                      <a:pPr lvl="0" indent="0" marL="0">
+                        <a:buNone/>
+                      </a:pPr>
+                      <a:r>
+                        <a:rPr/>
+                        <a:t>max</a:t>
+                      </a:r>
+                    </a:p>
+                  </a:txBody>
+                </a:tc>
+                <a:tc>
+                  <a:txBody>
+                    <a:bodyPr/>
+                    <a:lstStyle/>
+                    <a:p>
+                      <a:pPr lvl="0" indent="0" marL="0">
+                        <a:buNone/>
+                      </a:pPr>
+                      <a:r>
+                        <a:rPr/>
+                        <a:t>8768.000000</a:t>
+                      </a:r>
+                    </a:p>
+                  </a:txBody>
+                </a:tc>
+                <a:tc>
+                  <a:txBody>
+                    <a:bodyPr/>
+                    <a:lstStyle/>
+                    <a:p>
+                      <a:pPr lvl="0" indent="0" marL="0">
+                        <a:buNone/>
+                      </a:pPr>
+                      <a:r>
+                        <a:rPr/>
+                        <a:t>334.900000</a:t>
+                      </a:r>
+                    </a:p>
+                  </a:txBody>
+                </a:tc>
+                <a:tc>
+                  <a:txBody>
+                    <a:bodyPr/>
+                    <a:lstStyle/>
+                    <a:p>
+                      <a:pPr lvl="0" indent="0" marL="0">
+                        <a:buNone/>
+                      </a:pPr>
+                      <a:r>
+                        <a:rPr/>
+                        <a:t>379.300000</a:t>
+                      </a:r>
+                    </a:p>
+                  </a:txBody>
+                </a:tc>
+                <a:tc>
+                  <a:txBody>
+                    <a:bodyPr/>
+                    <a:lstStyle/>
+                    <a:p>
+                      <a:pPr lvl="0" indent="0" marL="0">
+                        <a:buNone/>
+                      </a:pPr>
+                      <a:r>
+                        <a:rPr/>
+                        <a:t>1.385886e+06</a:t>
+                      </a:r>
+                    </a:p>
+                  </a:txBody>
+                </a:tc>
+              </a:tr>
+            </a:tbl>
+          </a:graphicData>
+        </a:graphic>
+      </p:graphicFrame>
+    </p:spTree>
+  </p:cSld>
+</p:sld>
+</file>
+
 <file path=ppt/slides/slide6.xml><?xml version="1.0" encoding="utf-8"?>
 <p:sld xmlns:a="http://schemas.openxmlformats.org/drawingml/2006/main" xmlns:r="http://schemas.openxmlformats.org/officeDocument/2006/relationships" xmlns:p="http://schemas.openxmlformats.org/presentationml/2006/main">
   <p:cSld>
@@ -5059,7 +7220,7 @@
       </p:sp>
       <p:pic>
         <p:nvPicPr>
-          <p:cNvPr descr="presentation_files/figure-pptx/cell-4-output-1.png" id="0" name="Picture 1"/>
+          <p:cNvPr descr="presentation_files/figure-pptx/cell-5-output-1.png" id="0" name="Picture 1"/>
           <p:cNvPicPr>
             <a:picLocks noGrp="1" noChangeAspect="1"/>
           </p:cNvPicPr>
@@ -5136,7 +7297,7 @@
       </p:sp>
       <p:pic>
         <p:nvPicPr>
-          <p:cNvPr descr="presentation_files/figure-pptx/cell-5-output-1.png" id="0" name="Picture 1"/>
+          <p:cNvPr descr="presentation_files/figure-pptx/cell-6-output-1.png" id="0" name="Picture 1"/>
           <p:cNvPicPr>
             <a:picLocks noGrp="1" noChangeAspect="1"/>
           </p:cNvPicPr>
@@ -5213,7 +7374,7 @@
       </p:sp>
       <p:pic>
         <p:nvPicPr>
-          <p:cNvPr descr="presentation_files/figure-pptx/cell-6-output-1.png" id="0" name="Picture 1"/>
+          <p:cNvPr descr="presentation_files/figure-pptx/cell-7-output-1.png" id="0" name="Picture 1"/>
           <p:cNvPicPr>
             <a:picLocks noGrp="1" noChangeAspect="1"/>
           </p:cNvPicPr>

</xml_diff>

<commit_message>
fixing slideshow display issues
</commit_message>
<xml_diff>
--- a/Project-3/individual-models/data/presentation.pptx
+++ b/Project-3/individual-models/data/presentation.pptx
@@ -21,7 +21,6 @@
     <p:sldId id="269" r:id="rId15"/>
     <p:sldId id="270" r:id="rId16"/>
     <p:sldId id="271" r:id="rId17"/>
-    <p:sldId id="272" r:id="rId18"/>
   </p:sldIdLst>
   <p:sldSz cx="9144000" cy="5143500" type="screen16x9"/>
   <p:notesSz cx="6858000" cy="9144000"/>
@@ -3210,7 +3209,7 @@
             </a:pPr>
             <a:r>
               <a:rPr/>
-              <a:t>Model General Information Cont.</a:t>
+              <a:t>Model Limitations:</a:t>
             </a:r>
           </a:p>
         </p:txBody>
@@ -3229,18 +3228,6 @@
         <p:txBody>
           <a:bodyPr/>
           <a:lstStyle/>
-          <a:p>
-            <a:pPr lvl="0" indent="0" marL="0">
-              <a:spcBef>
-                <a:spcPts val="3000"/>
-              </a:spcBef>
-              <a:buNone/>
-            </a:pPr>
-            <a:r>
-              <a:rPr b="1"/>
-              <a:t>Model Limitations:</a:t>
-            </a:r>
-          </a:p>
           <a:p>
             <a:pPr lvl="0"/>
             <a:r>
@@ -3306,7 +3293,32 @@
             </a:pPr>
             <a:r>
               <a:rPr/>
-              <a:t>Domain Expert 3 (Explain the inputs and settings for the best model)</a:t>
+              <a:t>Performance Metric</a:t>
+            </a:r>
+          </a:p>
+        </p:txBody>
+      </p:sp>
+      <p:sp>
+        <p:nvSpPr>
+          <p:cNvPr id="3" name="Content Placeholder 2"/>
+          <p:cNvSpPr>
+            <a:spLocks noGrp="1"/>
+          </p:cNvSpPr>
+          <p:nvPr>
+            <p:ph idx="1"/>
+          </p:nvPr>
+        </p:nvSpPr>
+        <p:spPr/>
+        <p:txBody>
+          <a:bodyPr/>
+          <a:lstStyle/>
+          <a:p>
+            <a:pPr lvl="0" indent="0" marL="0">
+              <a:buNone/>
+            </a:pPr>
+            <a:r>
+              <a:rPr/>
+              <a:t>The Performance metric we choose is Root Mean Square Logarithmic Error(RMSLE), because when we were looking at the dataset of the biomass of different kinds of tree species, we saw that some species have more data than other species so the assume that the data is skewed</a:t>
             </a:r>
           </a:p>
         </p:txBody>
@@ -3353,36 +3365,1329 @@
             </a:pPr>
             <a:r>
               <a:rPr/>
-              <a:t>Performance Metric</a:t>
-            </a:r>
-          </a:p>
-        </p:txBody>
-      </p:sp>
-      <p:sp>
-        <p:nvSpPr>
-          <p:cNvPr id="3" name="Content Placeholder 2"/>
-          <p:cNvSpPr>
-            <a:spLocks noGrp="1"/>
-          </p:cNvSpPr>
+              <a:t>Model</a:t>
+            </a:r>
+          </a:p>
+        </p:txBody>
+      </p:sp>
+      <p:graphicFrame>
+        <p:nvGraphicFramePr>
+          <p:cNvPr id="6" name="Content Placeholder 5"/>
+          <p:cNvGraphicFramePr>
+            <a:graphicFrameLocks noGrp="1"/>
+          </p:cNvGraphicFramePr>
           <p:nvPr>
             <p:ph idx="1"/>
           </p:nvPr>
-        </p:nvSpPr>
-        <p:spPr/>
-        <p:txBody>
-          <a:bodyPr/>
-          <a:lstStyle/>
-          <a:p>
-            <a:pPr lvl="0" indent="0" marL="0">
-              <a:buNone/>
-            </a:pPr>
-            <a:r>
-              <a:rPr/>
-              <a:t>The Performance metric we choose is Root Mean Square Logarithmic Error(RMSLE), because when we were looking at the dataset of the biomass of different kinds of tree species, we saw that some species have more data than other species so the assume that the data is skewed</a:t>
-            </a:r>
-          </a:p>
-        </p:txBody>
-      </p:sp>
+        </p:nvGraphicFramePr>
+        <p:xfrm>
+          <a:off x="457200" y="1193800"/>
+          <a:ext cx="8229600" cy="3390900"/>
+        </p:xfrm>
+        <a:graphic>
+          <a:graphicData uri="http://schemas.openxmlformats.org/drawingml/2006/table">
+            <a:tbl>
+              <a:tblPr firstRow="1" bandRow="1">
+                <a:tableStyleId>{5C22544A-7EE6-4342-B048-85BDC9FD1C3A}</a:tableStyleId>
+              </a:tblPr>
+              <a:tblGrid>
+                <a:gridCol w="1168400"/>
+                <a:gridCol w="1168400"/>
+                <a:gridCol w="1168400"/>
+                <a:gridCol w="1168400"/>
+                <a:gridCol w="1168400"/>
+                <a:gridCol w="1168400"/>
+                <a:gridCol w="1168400"/>
+              </a:tblGrid>
+              <a:tr h="0">
+                <a:tc>
+                  <a:txBody>
+                    <a:bodyPr/>
+                    <a:lstStyle/>
+                    <a:p>
+                      <a:endParaRPr/>
+                    </a:p>
+                  </a:txBody>
+                  <a:tcPr/>
+                </a:tc>
+                <a:tc>
+                  <a:txBody>
+                    <a:bodyPr/>
+                    <a:lstStyle/>
+                    <a:p>
+                      <a:pPr lvl="0" indent="0" marL="0">
+                        <a:buNone/>
+                      </a:pPr>
+                      <a:r>
+                        <a:rPr/>
+                        <a:t>Species</a:t>
+                      </a:r>
+                    </a:p>
+                  </a:txBody>
+                  <a:tcPr/>
+                </a:tc>
+                <a:tc>
+                  <a:txBody>
+                    <a:bodyPr/>
+                    <a:lstStyle/>
+                    <a:p>
+                      <a:pPr lvl="0" indent="0" marL="0">
+                        <a:buNone/>
+                      </a:pPr>
+                      <a:r>
+                        <a:rPr/>
+                        <a:t>k</a:t>
+                      </a:r>
+                    </a:p>
+                  </a:txBody>
+                  <a:tcPr/>
+                </a:tc>
+                <a:tc>
+                  <a:txBody>
+                    <a:bodyPr/>
+                    <a:lstStyle/>
+                    <a:p>
+                      <a:pPr lvl="0" indent="0" marL="0">
+                        <a:buNone/>
+                      </a:pPr>
+                      <a:r>
+                        <a:rPr/>
+                        <a:t>MSE</a:t>
+                      </a:r>
+                    </a:p>
+                  </a:txBody>
+                  <a:tcPr/>
+                </a:tc>
+                <a:tc>
+                  <a:txBody>
+                    <a:bodyPr/>
+                    <a:lstStyle/>
+                    <a:p>
+                      <a:pPr lvl="0" indent="0" marL="0">
+                        <a:buNone/>
+                      </a:pPr>
+                      <a:r>
+                        <a:rPr/>
+                        <a:t>RMSE</a:t>
+                      </a:r>
+                    </a:p>
+                  </a:txBody>
+                  <a:tcPr/>
+                </a:tc>
+                <a:tc>
+                  <a:txBody>
+                    <a:bodyPr/>
+                    <a:lstStyle/>
+                    <a:p>
+                      <a:pPr lvl="0" indent="0" marL="0">
+                        <a:buNone/>
+                      </a:pPr>
+                      <a:r>
+                        <a:rPr/>
+                        <a:t>MAE</a:t>
+                      </a:r>
+                    </a:p>
+                  </a:txBody>
+                  <a:tcPr/>
+                </a:tc>
+                <a:tc>
+                  <a:txBody>
+                    <a:bodyPr/>
+                    <a:lstStyle/>
+                    <a:p>
+                      <a:pPr lvl="0" indent="0" marL="0">
+                        <a:buNone/>
+                      </a:pPr>
+                      <a:r>
+                        <a:rPr/>
+                        <a:t>RMSLE</a:t>
+                      </a:r>
+                    </a:p>
+                  </a:txBody>
+                  <a:tcPr/>
+                </a:tc>
+              </a:tr>
+              <a:tr h="0">
+                <a:tc>
+                  <a:txBody>
+                    <a:bodyPr/>
+                    <a:lstStyle/>
+                    <a:p>
+                      <a:pPr lvl="0" indent="0" marL="0">
+                        <a:buNone/>
+                      </a:pPr>
+                      <a:r>
+                        <a:rPr/>
+                        <a:t>0</a:t>
+                      </a:r>
+                    </a:p>
+                  </a:txBody>
+                </a:tc>
+                <a:tc>
+                  <a:txBody>
+                    <a:bodyPr/>
+                    <a:lstStyle/>
+                    <a:p>
+                      <a:pPr lvl="0" indent="0" marL="0">
+                        <a:buNone/>
+                      </a:pPr>
+                      <a:r>
+                        <a:rPr/>
+                        <a:t>balsam fir</a:t>
+                      </a:r>
+                    </a:p>
+                  </a:txBody>
+                </a:tc>
+                <a:tc>
+                  <a:txBody>
+                    <a:bodyPr/>
+                    <a:lstStyle/>
+                    <a:p>
+                      <a:pPr lvl="0" indent="0" marL="0">
+                        <a:buNone/>
+                      </a:pPr>
+                      <a:r>
+                        <a:rPr/>
+                        <a:t>2</a:t>
+                      </a:r>
+                    </a:p>
+                  </a:txBody>
+                </a:tc>
+                <a:tc>
+                  <a:txBody>
+                    <a:bodyPr/>
+                    <a:lstStyle/>
+                    <a:p>
+                      <a:pPr lvl="0" indent="0" marL="0">
+                        <a:buNone/>
+                      </a:pPr>
+                      <a:r>
+                        <a:rPr/>
+                        <a:t>15832.049590</a:t>
+                      </a:r>
+                    </a:p>
+                  </a:txBody>
+                </a:tc>
+                <a:tc>
+                  <a:txBody>
+                    <a:bodyPr/>
+                    <a:lstStyle/>
+                    <a:p>
+                      <a:pPr lvl="0" indent="0" marL="0">
+                        <a:buNone/>
+                      </a:pPr>
+                      <a:r>
+                        <a:rPr/>
+                        <a:t>125.825473</a:t>
+                      </a:r>
+                    </a:p>
+                  </a:txBody>
+                </a:tc>
+                <a:tc>
+                  <a:txBody>
+                    <a:bodyPr/>
+                    <a:lstStyle/>
+                    <a:p>
+                      <a:pPr lvl="0" indent="0" marL="0">
+                        <a:buNone/>
+                      </a:pPr>
+                      <a:r>
+                        <a:rPr/>
+                        <a:t>34.801913</a:t>
+                      </a:r>
+                    </a:p>
+                  </a:txBody>
+                </a:tc>
+                <a:tc>
+                  <a:txBody>
+                    <a:bodyPr/>
+                    <a:lstStyle/>
+                    <a:p>
+                      <a:pPr lvl="0" indent="0" marL="0">
+                        <a:buNone/>
+                      </a:pPr>
+                      <a:r>
+                        <a:rPr/>
+                        <a:t>0.119574</a:t>
+                      </a:r>
+                    </a:p>
+                  </a:txBody>
+                </a:tc>
+              </a:tr>
+              <a:tr h="0">
+                <a:tc>
+                  <a:txBody>
+                    <a:bodyPr/>
+                    <a:lstStyle/>
+                    <a:p>
+                      <a:pPr lvl="0" indent="0" marL="0">
+                        <a:buNone/>
+                      </a:pPr>
+                      <a:r>
+                        <a:rPr/>
+                        <a:t>1</a:t>
+                      </a:r>
+                    </a:p>
+                  </a:txBody>
+                </a:tc>
+                <a:tc>
+                  <a:txBody>
+                    <a:bodyPr/>
+                    <a:lstStyle/>
+                    <a:p>
+                      <a:pPr lvl="0" indent="0" marL="0">
+                        <a:buNone/>
+                      </a:pPr>
+                      <a:r>
+                        <a:rPr/>
+                        <a:t>balsam fir</a:t>
+                      </a:r>
+                    </a:p>
+                  </a:txBody>
+                </a:tc>
+                <a:tc>
+                  <a:txBody>
+                    <a:bodyPr/>
+                    <a:lstStyle/>
+                    <a:p>
+                      <a:pPr lvl="0" indent="0" marL="0">
+                        <a:buNone/>
+                      </a:pPr>
+                      <a:r>
+                        <a:rPr/>
+                        <a:t>3</a:t>
+                      </a:r>
+                    </a:p>
+                  </a:txBody>
+                </a:tc>
+                <a:tc>
+                  <a:txBody>
+                    <a:bodyPr/>
+                    <a:lstStyle/>
+                    <a:p>
+                      <a:pPr lvl="0" indent="0" marL="0">
+                        <a:buNone/>
+                      </a:pPr>
+                      <a:r>
+                        <a:rPr/>
+                        <a:t>16809.506015</a:t>
+                      </a:r>
+                    </a:p>
+                  </a:txBody>
+                </a:tc>
+                <a:tc>
+                  <a:txBody>
+                    <a:bodyPr/>
+                    <a:lstStyle/>
+                    <a:p>
+                      <a:pPr lvl="0" indent="0" marL="0">
+                        <a:buNone/>
+                      </a:pPr>
+                      <a:r>
+                        <a:rPr/>
+                        <a:t>129.651479</a:t>
+                      </a:r>
+                    </a:p>
+                  </a:txBody>
+                </a:tc>
+                <a:tc>
+                  <a:txBody>
+                    <a:bodyPr/>
+                    <a:lstStyle/>
+                    <a:p>
+                      <a:pPr lvl="0" indent="0" marL="0">
+                        <a:buNone/>
+                      </a:pPr>
+                      <a:r>
+                        <a:rPr/>
+                        <a:t>36.646493</a:t>
+                      </a:r>
+                    </a:p>
+                  </a:txBody>
+                </a:tc>
+                <a:tc>
+                  <a:txBody>
+                    <a:bodyPr/>
+                    <a:lstStyle/>
+                    <a:p>
+                      <a:pPr lvl="0" indent="0" marL="0">
+                        <a:buNone/>
+                      </a:pPr>
+                      <a:r>
+                        <a:rPr/>
+                        <a:t>0.123724</a:t>
+                      </a:r>
+                    </a:p>
+                  </a:txBody>
+                </a:tc>
+              </a:tr>
+              <a:tr h="0">
+                <a:tc>
+                  <a:txBody>
+                    <a:bodyPr/>
+                    <a:lstStyle/>
+                    <a:p>
+                      <a:pPr lvl="0" indent="0" marL="0">
+                        <a:buNone/>
+                      </a:pPr>
+                      <a:r>
+                        <a:rPr/>
+                        <a:t>2</a:t>
+                      </a:r>
+                    </a:p>
+                  </a:txBody>
+                </a:tc>
+                <a:tc>
+                  <a:txBody>
+                    <a:bodyPr/>
+                    <a:lstStyle/>
+                    <a:p>
+                      <a:pPr lvl="0" indent="0" marL="0">
+                        <a:buNone/>
+                      </a:pPr>
+                      <a:r>
+                        <a:rPr/>
+                        <a:t>balsam fir</a:t>
+                      </a:r>
+                    </a:p>
+                  </a:txBody>
+                </a:tc>
+                <a:tc>
+                  <a:txBody>
+                    <a:bodyPr/>
+                    <a:lstStyle/>
+                    <a:p>
+                      <a:pPr lvl="0" indent="0" marL="0">
+                        <a:buNone/>
+                      </a:pPr>
+                      <a:r>
+                        <a:rPr/>
+                        <a:t>4</a:t>
+                      </a:r>
+                    </a:p>
+                  </a:txBody>
+                </a:tc>
+                <a:tc>
+                  <a:txBody>
+                    <a:bodyPr/>
+                    <a:lstStyle/>
+                    <a:p>
+                      <a:pPr lvl="0" indent="0" marL="0">
+                        <a:buNone/>
+                      </a:pPr>
+                      <a:r>
+                        <a:rPr/>
+                        <a:t>18117.114099</a:t>
+                      </a:r>
+                    </a:p>
+                  </a:txBody>
+                </a:tc>
+                <a:tc>
+                  <a:txBody>
+                    <a:bodyPr/>
+                    <a:lstStyle/>
+                    <a:p>
+                      <a:pPr lvl="0" indent="0" marL="0">
+                        <a:buNone/>
+                      </a:pPr>
+                      <a:r>
+                        <a:rPr/>
+                        <a:t>134.599829</a:t>
+                      </a:r>
+                    </a:p>
+                  </a:txBody>
+                </a:tc>
+                <a:tc>
+                  <a:txBody>
+                    <a:bodyPr/>
+                    <a:lstStyle/>
+                    <a:p>
+                      <a:pPr lvl="0" indent="0" marL="0">
+                        <a:buNone/>
+                      </a:pPr>
+                      <a:r>
+                        <a:rPr/>
+                        <a:t>38.884870</a:t>
+                      </a:r>
+                    </a:p>
+                  </a:txBody>
+                </a:tc>
+                <a:tc>
+                  <a:txBody>
+                    <a:bodyPr/>
+                    <a:lstStyle/>
+                    <a:p>
+                      <a:pPr lvl="0" indent="0" marL="0">
+                        <a:buNone/>
+                      </a:pPr>
+                      <a:r>
+                        <a:rPr/>
+                        <a:t>0.133858</a:t>
+                      </a:r>
+                    </a:p>
+                  </a:txBody>
+                </a:tc>
+              </a:tr>
+              <a:tr h="0">
+                <a:tc>
+                  <a:txBody>
+                    <a:bodyPr/>
+                    <a:lstStyle/>
+                    <a:p>
+                      <a:pPr lvl="0" indent="0" marL="0">
+                        <a:buNone/>
+                      </a:pPr>
+                      <a:r>
+                        <a:rPr/>
+                        <a:t>3</a:t>
+                      </a:r>
+                    </a:p>
+                  </a:txBody>
+                </a:tc>
+                <a:tc>
+                  <a:txBody>
+                    <a:bodyPr/>
+                    <a:lstStyle/>
+                    <a:p>
+                      <a:pPr lvl="0" indent="0" marL="0">
+                        <a:buNone/>
+                      </a:pPr>
+                      <a:r>
+                        <a:rPr/>
+                        <a:t>balsam fir</a:t>
+                      </a:r>
+                    </a:p>
+                  </a:txBody>
+                </a:tc>
+                <a:tc>
+                  <a:txBody>
+                    <a:bodyPr/>
+                    <a:lstStyle/>
+                    <a:p>
+                      <a:pPr lvl="0" indent="0" marL="0">
+                        <a:buNone/>
+                      </a:pPr>
+                      <a:r>
+                        <a:rPr/>
+                        <a:t>5</a:t>
+                      </a:r>
+                    </a:p>
+                  </a:txBody>
+                </a:tc>
+                <a:tc>
+                  <a:txBody>
+                    <a:bodyPr/>
+                    <a:lstStyle/>
+                    <a:p>
+                      <a:pPr lvl="0" indent="0" marL="0">
+                        <a:buNone/>
+                      </a:pPr>
+                      <a:r>
+                        <a:rPr/>
+                        <a:t>21026.044395</a:t>
+                      </a:r>
+                    </a:p>
+                  </a:txBody>
+                </a:tc>
+                <a:tc>
+                  <a:txBody>
+                    <a:bodyPr/>
+                    <a:lstStyle/>
+                    <a:p>
+                      <a:pPr lvl="0" indent="0" marL="0">
+                        <a:buNone/>
+                      </a:pPr>
+                      <a:r>
+                        <a:rPr/>
+                        <a:t>145.003601</a:t>
+                      </a:r>
+                    </a:p>
+                  </a:txBody>
+                </a:tc>
+                <a:tc>
+                  <a:txBody>
+                    <a:bodyPr/>
+                    <a:lstStyle/>
+                    <a:p>
+                      <a:pPr lvl="0" indent="0" marL="0">
+                        <a:buNone/>
+                      </a:pPr>
+                      <a:r>
+                        <a:rPr/>
+                        <a:t>41.209530</a:t>
+                      </a:r>
+                    </a:p>
+                  </a:txBody>
+                </a:tc>
+                <a:tc>
+                  <a:txBody>
+                    <a:bodyPr/>
+                    <a:lstStyle/>
+                    <a:p>
+                      <a:pPr lvl="0" indent="0" marL="0">
+                        <a:buNone/>
+                      </a:pPr>
+                      <a:r>
+                        <a:rPr/>
+                        <a:t>0.144063</a:t>
+                      </a:r>
+                    </a:p>
+                  </a:txBody>
+                </a:tc>
+              </a:tr>
+              <a:tr h="0">
+                <a:tc>
+                  <a:txBody>
+                    <a:bodyPr/>
+                    <a:lstStyle/>
+                    <a:p>
+                      <a:pPr lvl="0" indent="0" marL="0">
+                        <a:buNone/>
+                      </a:pPr>
+                      <a:r>
+                        <a:rPr/>
+                        <a:t>4</a:t>
+                      </a:r>
+                    </a:p>
+                  </a:txBody>
+                </a:tc>
+                <a:tc>
+                  <a:txBody>
+                    <a:bodyPr/>
+                    <a:lstStyle/>
+                    <a:p>
+                      <a:pPr lvl="0" indent="0" marL="0">
+                        <a:buNone/>
+                      </a:pPr>
+                      <a:r>
+                        <a:rPr/>
+                        <a:t>balsam fir</a:t>
+                      </a:r>
+                    </a:p>
+                  </a:txBody>
+                </a:tc>
+                <a:tc>
+                  <a:txBody>
+                    <a:bodyPr/>
+                    <a:lstStyle/>
+                    <a:p>
+                      <a:pPr lvl="0" indent="0" marL="0">
+                        <a:buNone/>
+                      </a:pPr>
+                      <a:r>
+                        <a:rPr/>
+                        <a:t>6</a:t>
+                      </a:r>
+                    </a:p>
+                  </a:txBody>
+                </a:tc>
+                <a:tc>
+                  <a:txBody>
+                    <a:bodyPr/>
+                    <a:lstStyle/>
+                    <a:p>
+                      <a:pPr lvl="0" indent="0" marL="0">
+                        <a:buNone/>
+                      </a:pPr>
+                      <a:r>
+                        <a:rPr/>
+                        <a:t>21741.891998</a:t>
+                      </a:r>
+                    </a:p>
+                  </a:txBody>
+                </a:tc>
+                <a:tc>
+                  <a:txBody>
+                    <a:bodyPr/>
+                    <a:lstStyle/>
+                    <a:p>
+                      <a:pPr lvl="0" indent="0" marL="0">
+                        <a:buNone/>
+                      </a:pPr>
+                      <a:r>
+                        <a:rPr/>
+                        <a:t>147.451321</a:t>
+                      </a:r>
+                    </a:p>
+                  </a:txBody>
+                </a:tc>
+                <a:tc>
+                  <a:txBody>
+                    <a:bodyPr/>
+                    <a:lstStyle/>
+                    <a:p>
+                      <a:pPr lvl="0" indent="0" marL="0">
+                        <a:buNone/>
+                      </a:pPr>
+                      <a:r>
+                        <a:rPr/>
+                        <a:t>40.791681</a:t>
+                      </a:r>
+                    </a:p>
+                  </a:txBody>
+                </a:tc>
+                <a:tc>
+                  <a:txBody>
+                    <a:bodyPr/>
+                    <a:lstStyle/>
+                    <a:p>
+                      <a:pPr lvl="0" indent="0" marL="0">
+                        <a:buNone/>
+                      </a:pPr>
+                      <a:r>
+                        <a:rPr/>
+                        <a:t>0.142862</a:t>
+                      </a:r>
+                    </a:p>
+                  </a:txBody>
+                </a:tc>
+              </a:tr>
+              <a:tr h="0">
+                <a:tc>
+                  <a:txBody>
+                    <a:bodyPr/>
+                    <a:lstStyle/>
+                    <a:p>
+                      <a:pPr lvl="0" indent="0" marL="0">
+                        <a:buNone/>
+                      </a:pPr>
+                      <a:r>
+                        <a:rPr/>
+                        <a:t>...</a:t>
+                      </a:r>
+                    </a:p>
+                  </a:txBody>
+                </a:tc>
+                <a:tc>
+                  <a:txBody>
+                    <a:bodyPr/>
+                    <a:lstStyle/>
+                    <a:p>
+                      <a:pPr lvl="0" indent="0" marL="0">
+                        <a:buNone/>
+                      </a:pPr>
+                      <a:r>
+                        <a:rPr/>
+                        <a:t>...</a:t>
+                      </a:r>
+                    </a:p>
+                  </a:txBody>
+                </a:tc>
+                <a:tc>
+                  <a:txBody>
+                    <a:bodyPr/>
+                    <a:lstStyle/>
+                    <a:p>
+                      <a:pPr lvl="0" indent="0" marL="0">
+                        <a:buNone/>
+                      </a:pPr>
+                      <a:r>
+                        <a:rPr/>
+                        <a:t>...</a:t>
+                      </a:r>
+                    </a:p>
+                  </a:txBody>
+                </a:tc>
+                <a:tc>
+                  <a:txBody>
+                    <a:bodyPr/>
+                    <a:lstStyle/>
+                    <a:p>
+                      <a:pPr lvl="0" indent="0" marL="0">
+                        <a:buNone/>
+                      </a:pPr>
+                      <a:r>
+                        <a:rPr/>
+                        <a:t>...</a:t>
+                      </a:r>
+                    </a:p>
+                  </a:txBody>
+                </a:tc>
+                <a:tc>
+                  <a:txBody>
+                    <a:bodyPr/>
+                    <a:lstStyle/>
+                    <a:p>
+                      <a:pPr lvl="0" indent="0" marL="0">
+                        <a:buNone/>
+                      </a:pPr>
+                      <a:r>
+                        <a:rPr/>
+                        <a:t>...</a:t>
+                      </a:r>
+                    </a:p>
+                  </a:txBody>
+                </a:tc>
+                <a:tc>
+                  <a:txBody>
+                    <a:bodyPr/>
+                    <a:lstStyle/>
+                    <a:p>
+                      <a:pPr lvl="0" indent="0" marL="0">
+                        <a:buNone/>
+                      </a:pPr>
+                      <a:r>
+                        <a:rPr/>
+                        <a:t>...</a:t>
+                      </a:r>
+                    </a:p>
+                  </a:txBody>
+                </a:tc>
+                <a:tc>
+                  <a:txBody>
+                    <a:bodyPr/>
+                    <a:lstStyle/>
+                    <a:p>
+                      <a:pPr lvl="0" indent="0" marL="0">
+                        <a:buNone/>
+                      </a:pPr>
+                      <a:r>
+                        <a:rPr/>
+                        <a:t>...</a:t>
+                      </a:r>
+                    </a:p>
+                  </a:txBody>
+                </a:tc>
+              </a:tr>
+              <a:tr h="0">
+                <a:tc>
+                  <a:txBody>
+                    <a:bodyPr/>
+                    <a:lstStyle/>
+                    <a:p>
+                      <a:pPr lvl="0" indent="0" marL="0">
+                        <a:buNone/>
+                      </a:pPr>
+                      <a:r>
+                        <a:rPr/>
+                        <a:t>895</a:t>
+                      </a:r>
+                    </a:p>
+                  </a:txBody>
+                </a:tc>
+                <a:tc>
+                  <a:txBody>
+                    <a:bodyPr/>
+                    <a:lstStyle/>
+                    <a:p>
+                      <a:pPr lvl="0" indent="0" marL="0">
+                        <a:buNone/>
+                      </a:pPr>
+                      <a:r>
+                        <a:rPr/>
+                        <a:t>sugarberry</a:t>
+                      </a:r>
+                    </a:p>
+                  </a:txBody>
+                </a:tc>
+                <a:tc>
+                  <a:txBody>
+                    <a:bodyPr/>
+                    <a:lstStyle/>
+                    <a:p>
+                      <a:pPr lvl="0" indent="0" marL="0">
+                        <a:buNone/>
+                      </a:pPr>
+                      <a:r>
+                        <a:rPr/>
+                        <a:t>6</a:t>
+                      </a:r>
+                    </a:p>
+                  </a:txBody>
+                </a:tc>
+                <a:tc>
+                  <a:txBody>
+                    <a:bodyPr/>
+                    <a:lstStyle/>
+                    <a:p>
+                      <a:pPr lvl="0" indent="0" marL="0">
+                        <a:buNone/>
+                      </a:pPr>
+                      <a:r>
+                        <a:rPr/>
+                        <a:t>1051.773141</a:t>
+                      </a:r>
+                    </a:p>
+                  </a:txBody>
+                </a:tc>
+                <a:tc>
+                  <a:txBody>
+                    <a:bodyPr/>
+                    <a:lstStyle/>
+                    <a:p>
+                      <a:pPr lvl="0" indent="0" marL="0">
+                        <a:buNone/>
+                      </a:pPr>
+                      <a:r>
+                        <a:rPr/>
+                        <a:t>32.431052</a:t>
+                      </a:r>
+                    </a:p>
+                  </a:txBody>
+                </a:tc>
+                <a:tc>
+                  <a:txBody>
+                    <a:bodyPr/>
+                    <a:lstStyle/>
+                    <a:p>
+                      <a:pPr lvl="0" indent="0" marL="0">
+                        <a:buNone/>
+                      </a:pPr>
+                      <a:r>
+                        <a:rPr/>
+                        <a:t>20.969306</a:t>
+                      </a:r>
+                    </a:p>
+                  </a:txBody>
+                </a:tc>
+                <a:tc>
+                  <a:txBody>
+                    <a:bodyPr/>
+                    <a:lstStyle/>
+                    <a:p>
+                      <a:pPr lvl="0" indent="0" marL="0">
+                        <a:buNone/>
+                      </a:pPr>
+                      <a:r>
+                        <a:rPr/>
+                        <a:t>0.565727</a:t>
+                      </a:r>
+                    </a:p>
+                  </a:txBody>
+                </a:tc>
+              </a:tr>
+              <a:tr h="0">
+                <a:tc>
+                  <a:txBody>
+                    <a:bodyPr/>
+                    <a:lstStyle/>
+                    <a:p>
+                      <a:pPr lvl="0" indent="0" marL="0">
+                        <a:buNone/>
+                      </a:pPr>
+                      <a:r>
+                        <a:rPr/>
+                        <a:t>896</a:t>
+                      </a:r>
+                    </a:p>
+                  </a:txBody>
+                </a:tc>
+                <a:tc>
+                  <a:txBody>
+                    <a:bodyPr/>
+                    <a:lstStyle/>
+                    <a:p>
+                      <a:pPr lvl="0" indent="0" marL="0">
+                        <a:buNone/>
+                      </a:pPr>
+                      <a:r>
+                        <a:rPr/>
+                        <a:t>sugarberry</a:t>
+                      </a:r>
+                    </a:p>
+                  </a:txBody>
+                </a:tc>
+                <a:tc>
+                  <a:txBody>
+                    <a:bodyPr/>
+                    <a:lstStyle/>
+                    <a:p>
+                      <a:pPr lvl="0" indent="0" marL="0">
+                        <a:buNone/>
+                      </a:pPr>
+                      <a:r>
+                        <a:rPr/>
+                        <a:t>7</a:t>
+                      </a:r>
+                    </a:p>
+                  </a:txBody>
+                </a:tc>
+                <a:tc>
+                  <a:txBody>
+                    <a:bodyPr/>
+                    <a:lstStyle/>
+                    <a:p>
+                      <a:pPr lvl="0" indent="0" marL="0">
+                        <a:buNone/>
+                      </a:pPr>
+                      <a:r>
+                        <a:rPr/>
+                        <a:t>1393.100286</a:t>
+                      </a:r>
+                    </a:p>
+                  </a:txBody>
+                </a:tc>
+                <a:tc>
+                  <a:txBody>
+                    <a:bodyPr/>
+                    <a:lstStyle/>
+                    <a:p>
+                      <a:pPr lvl="0" indent="0" marL="0">
+                        <a:buNone/>
+                      </a:pPr>
+                      <a:r>
+                        <a:rPr/>
+                        <a:t>37.324259</a:t>
+                      </a:r>
+                    </a:p>
+                  </a:txBody>
+                </a:tc>
+                <a:tc>
+                  <a:txBody>
+                    <a:bodyPr/>
+                    <a:lstStyle/>
+                    <a:p>
+                      <a:pPr lvl="0" indent="0" marL="0">
+                        <a:buNone/>
+                      </a:pPr>
+                      <a:r>
+                        <a:rPr/>
+                        <a:t>25.037024</a:t>
+                      </a:r>
+                    </a:p>
+                  </a:txBody>
+                </a:tc>
+                <a:tc>
+                  <a:txBody>
+                    <a:bodyPr/>
+                    <a:lstStyle/>
+                    <a:p>
+                      <a:pPr lvl="0" indent="0" marL="0">
+                        <a:buNone/>
+                      </a:pPr>
+                      <a:r>
+                        <a:rPr/>
+                        <a:t>0.637629</a:t>
+                      </a:r>
+                    </a:p>
+                  </a:txBody>
+                </a:tc>
+              </a:tr>
+              <a:tr h="0">
+                <a:tc>
+                  <a:txBody>
+                    <a:bodyPr/>
+                    <a:lstStyle/>
+                    <a:p>
+                      <a:pPr lvl="0" indent="0" marL="0">
+                        <a:buNone/>
+                      </a:pPr>
+                      <a:r>
+                        <a:rPr/>
+                        <a:t>897</a:t>
+                      </a:r>
+                    </a:p>
+                  </a:txBody>
+                </a:tc>
+                <a:tc>
+                  <a:txBody>
+                    <a:bodyPr/>
+                    <a:lstStyle/>
+                    <a:p>
+                      <a:pPr lvl="0" indent="0" marL="0">
+                        <a:buNone/>
+                      </a:pPr>
+                      <a:r>
+                        <a:rPr/>
+                        <a:t>sugarberry</a:t>
+                      </a:r>
+                    </a:p>
+                  </a:txBody>
+                </a:tc>
+                <a:tc>
+                  <a:txBody>
+                    <a:bodyPr/>
+                    <a:lstStyle/>
+                    <a:p>
+                      <a:pPr lvl="0" indent="0" marL="0">
+                        <a:buNone/>
+                      </a:pPr>
+                      <a:r>
+                        <a:rPr/>
+                        <a:t>8</a:t>
+                      </a:r>
+                    </a:p>
+                  </a:txBody>
+                </a:tc>
+                <a:tc>
+                  <a:txBody>
+                    <a:bodyPr/>
+                    <a:lstStyle/>
+                    <a:p>
+                      <a:pPr lvl="0" indent="0" marL="0">
+                        <a:buNone/>
+                      </a:pPr>
+                      <a:r>
+                        <a:rPr/>
+                        <a:t>1455.022421</a:t>
+                      </a:r>
+                    </a:p>
+                  </a:txBody>
+                </a:tc>
+                <a:tc>
+                  <a:txBody>
+                    <a:bodyPr/>
+                    <a:lstStyle/>
+                    <a:p>
+                      <a:pPr lvl="0" indent="0" marL="0">
+                        <a:buNone/>
+                      </a:pPr>
+                      <a:r>
+                        <a:rPr/>
+                        <a:t>38.144756</a:t>
+                      </a:r>
+                    </a:p>
+                  </a:txBody>
+                </a:tc>
+                <a:tc>
+                  <a:txBody>
+                    <a:bodyPr/>
+                    <a:lstStyle/>
+                    <a:p>
+                      <a:pPr lvl="0" indent="0" marL="0">
+                        <a:buNone/>
+                      </a:pPr>
+                      <a:r>
+                        <a:rPr/>
+                        <a:t>26.680208</a:t>
+                      </a:r>
+                    </a:p>
+                  </a:txBody>
+                </a:tc>
+                <a:tc>
+                  <a:txBody>
+                    <a:bodyPr/>
+                    <a:lstStyle/>
+                    <a:p>
+                      <a:pPr lvl="0" indent="0" marL="0">
+                        <a:buNone/>
+                      </a:pPr>
+                      <a:r>
+                        <a:rPr/>
+                        <a:t>0.665159</a:t>
+                      </a:r>
+                    </a:p>
+                  </a:txBody>
+                </a:tc>
+              </a:tr>
+              <a:tr h="0">
+                <a:tc>
+                  <a:txBody>
+                    <a:bodyPr/>
+                    <a:lstStyle/>
+                    <a:p>
+                      <a:pPr lvl="0" indent="0" marL="0">
+                        <a:buNone/>
+                      </a:pPr>
+                      <a:r>
+                        <a:rPr/>
+                        <a:t>898</a:t>
+                      </a:r>
+                    </a:p>
+                  </a:txBody>
+                </a:tc>
+                <a:tc>
+                  <a:txBody>
+                    <a:bodyPr/>
+                    <a:lstStyle/>
+                    <a:p>
+                      <a:pPr lvl="0" indent="0" marL="0">
+                        <a:buNone/>
+                      </a:pPr>
+                      <a:r>
+                        <a:rPr/>
+                        <a:t>sugarberry</a:t>
+                      </a:r>
+                    </a:p>
+                  </a:txBody>
+                </a:tc>
+                <a:tc>
+                  <a:txBody>
+                    <a:bodyPr/>
+                    <a:lstStyle/>
+                    <a:p>
+                      <a:pPr lvl="0" indent="0" marL="0">
+                        <a:buNone/>
+                      </a:pPr>
+                      <a:r>
+                        <a:rPr/>
+                        <a:t>9</a:t>
+                      </a:r>
+                    </a:p>
+                  </a:txBody>
+                </a:tc>
+                <a:tc>
+                  <a:txBody>
+                    <a:bodyPr/>
+                    <a:lstStyle/>
+                    <a:p>
+                      <a:pPr lvl="0" indent="0" marL="0">
+                        <a:buNone/>
+                      </a:pPr>
+                      <a:r>
+                        <a:rPr/>
+                        <a:t>1358.161657</a:t>
+                      </a:r>
+                    </a:p>
+                  </a:txBody>
+                </a:tc>
+                <a:tc>
+                  <a:txBody>
+                    <a:bodyPr/>
+                    <a:lstStyle/>
+                    <a:p>
+                      <a:pPr lvl="0" indent="0" marL="0">
+                        <a:buNone/>
+                      </a:pPr>
+                      <a:r>
+                        <a:rPr/>
+                        <a:t>36.853245</a:t>
+                      </a:r>
+                    </a:p>
+                  </a:txBody>
+                </a:tc>
+                <a:tc>
+                  <a:txBody>
+                    <a:bodyPr/>
+                    <a:lstStyle/>
+                    <a:p>
+                      <a:pPr lvl="0" indent="0" marL="0">
+                        <a:buNone/>
+                      </a:pPr>
+                      <a:r>
+                        <a:rPr/>
+                        <a:t>21.021667</a:t>
+                      </a:r>
+                    </a:p>
+                  </a:txBody>
+                </a:tc>
+                <a:tc>
+                  <a:txBody>
+                    <a:bodyPr/>
+                    <a:lstStyle/>
+                    <a:p>
+                      <a:pPr lvl="0" indent="0" marL="0">
+                        <a:buNone/>
+                      </a:pPr>
+                      <a:r>
+                        <a:rPr/>
+                        <a:t>0.685162</a:t>
+                      </a:r>
+                    </a:p>
+                  </a:txBody>
+                </a:tc>
+              </a:tr>
+              <a:tr h="0">
+                <a:tc>
+                  <a:txBody>
+                    <a:bodyPr/>
+                    <a:lstStyle/>
+                    <a:p>
+                      <a:pPr lvl="0" indent="0" marL="0">
+                        <a:buNone/>
+                      </a:pPr>
+                      <a:r>
+                        <a:rPr/>
+                        <a:t>899</a:t>
+                      </a:r>
+                    </a:p>
+                  </a:txBody>
+                </a:tc>
+                <a:tc>
+                  <a:txBody>
+                    <a:bodyPr/>
+                    <a:lstStyle/>
+                    <a:p>
+                      <a:pPr lvl="0" indent="0" marL="0">
+                        <a:buNone/>
+                      </a:pPr>
+                      <a:r>
+                        <a:rPr/>
+                        <a:t>sugarberry</a:t>
+                      </a:r>
+                    </a:p>
+                  </a:txBody>
+                </a:tc>
+                <a:tc>
+                  <a:txBody>
+                    <a:bodyPr/>
+                    <a:lstStyle/>
+                    <a:p>
+                      <a:pPr lvl="0" indent="0" marL="0">
+                        <a:buNone/>
+                      </a:pPr>
+                      <a:r>
+                        <a:rPr/>
+                        <a:t>10</a:t>
+                      </a:r>
+                    </a:p>
+                  </a:txBody>
+                </a:tc>
+                <a:tc>
+                  <a:txBody>
+                    <a:bodyPr/>
+                    <a:lstStyle/>
+                    <a:p>
+                      <a:pPr lvl="0" indent="0" marL="0">
+                        <a:buNone/>
+                      </a:pPr>
+                      <a:r>
+                        <a:rPr/>
+                        <a:t>1607.296767</a:t>
+                      </a:r>
+                    </a:p>
+                  </a:txBody>
+                </a:tc>
+                <a:tc>
+                  <a:txBody>
+                    <a:bodyPr/>
+                    <a:lstStyle/>
+                    <a:p>
+                      <a:pPr lvl="0" indent="0" marL="0">
+                        <a:buNone/>
+                      </a:pPr>
+                      <a:r>
+                        <a:rPr/>
+                        <a:t>40.091106</a:t>
+                      </a:r>
+                    </a:p>
+                  </a:txBody>
+                </a:tc>
+                <a:tc>
+                  <a:txBody>
+                    <a:bodyPr/>
+                    <a:lstStyle/>
+                    <a:p>
+                      <a:pPr lvl="0" indent="0" marL="0">
+                        <a:buNone/>
+                      </a:pPr>
+                      <a:r>
+                        <a:rPr/>
+                        <a:t>23.172083</a:t>
+                      </a:r>
+                    </a:p>
+                  </a:txBody>
+                </a:tc>
+                <a:tc>
+                  <a:txBody>
+                    <a:bodyPr/>
+                    <a:lstStyle/>
+                    <a:p>
+                      <a:pPr lvl="0" indent="0" marL="0">
+                        <a:buNone/>
+                      </a:pPr>
+                      <a:r>
+                        <a:rPr/>
+                        <a:t>0.677519</a:t>
+                      </a:r>
+                    </a:p>
+                  </a:txBody>
+                </a:tc>
+              </a:tr>
+            </a:tbl>
+          </a:graphicData>
+        </a:graphic>
+      </p:graphicFrame>
     </p:spTree>
   </p:cSld>
 </p:sld>
@@ -3425,7 +4730,7 @@
             </a:pPr>
             <a:r>
               <a:rPr/>
-              <a:t>Model</a:t>
+              <a:t>Technical Lead</a:t>
             </a:r>
           </a:p>
         </p:txBody>
@@ -3451,13 +4756,11 @@
                 <a:tableStyleId>{5C22544A-7EE6-4342-B048-85BDC9FD1C3A}</a:tableStyleId>
               </a:tblPr>
               <a:tblGrid>
-                <a:gridCol w="1168400"/>
-                <a:gridCol w="1168400"/>
-                <a:gridCol w="1168400"/>
-                <a:gridCol w="1168400"/>
-                <a:gridCol w="1168400"/>
-                <a:gridCol w="1168400"/>
-                <a:gridCol w="1168400"/>
+                <a:gridCol w="1638300"/>
+                <a:gridCol w="1638300"/>
+                <a:gridCol w="1638300"/>
+                <a:gridCol w="1638300"/>
+                <a:gridCol w="1638300"/>
               </a:tblGrid>
               <a:tr h="0">
                 <a:tc>
@@ -3480,7 +4783,7 @@
                       </a:pPr>
                       <a:r>
                         <a:rPr/>
-                        <a:t>Species</a:t>
+                        <a:t>SPCD</a:t>
                       </a:r>
                     </a:p>
                   </a:txBody>
@@ -3496,7 +4799,7 @@
                       </a:pPr>
                       <a:r>
                         <a:rPr/>
-                        <a:t>k</a:t>
+                        <a:t>DO_BH</a:t>
                       </a:r>
                     </a:p>
                   </a:txBody>
@@ -3512,7 +4815,7 @@
                       </a:pPr>
                       <a:r>
                         <a:rPr/>
-                        <a:t>MSE</a:t>
+                        <a:t>HT_TOT</a:t>
                       </a:r>
                     </a:p>
                   </a:txBody>
@@ -3528,39 +4831,7 @@
                       </a:pPr>
                       <a:r>
                         <a:rPr/>
-                        <a:t>RMSE</a:t>
-                      </a:r>
-                    </a:p>
-                  </a:txBody>
-                  <a:tcPr/>
-                </a:tc>
-                <a:tc>
-                  <a:txBody>
-                    <a:bodyPr/>
-                    <a:lstStyle/>
-                    <a:p>
-                      <a:pPr lvl="0" indent="0" marL="0">
-                        <a:buNone/>
-                      </a:pPr>
-                      <a:r>
-                        <a:rPr/>
-                        <a:t>MAE</a:t>
-                      </a:r>
-                    </a:p>
-                  </a:txBody>
-                  <a:tcPr/>
-                </a:tc>
-                <a:tc>
-                  <a:txBody>
-                    <a:bodyPr/>
-                    <a:lstStyle/>
-                    <a:p>
-                      <a:pPr lvl="0" indent="0" marL="0">
-                        <a:buNone/>
-                      </a:pPr>
-                      <a:r>
-                        <a:rPr/>
-                        <a:t>RMSLE</a:t>
+                        <a:t>TT_DW_CRM</a:t>
                       </a:r>
                     </a:p>
                   </a:txBody>
@@ -3593,82 +4864,52 @@
                       </a:pPr>
                       <a:r>
                         <a:rPr/>
-                        <a:t>balsam fir</a:t>
-                      </a:r>
-                    </a:p>
-                  </a:txBody>
-                </a:tc>
-                <a:tc>
-                  <a:txBody>
-                    <a:bodyPr/>
-                    <a:lstStyle/>
-                    <a:p>
-                      <a:pPr lvl="0" indent="0" marL="0">
-                        <a:buNone/>
-                      </a:pPr>
-                      <a:r>
-                        <a:rPr/>
-                        <a:t>2</a:t>
-                      </a:r>
-                    </a:p>
-                  </a:txBody>
-                </a:tc>
-                <a:tc>
-                  <a:txBody>
-                    <a:bodyPr/>
-                    <a:lstStyle/>
-                    <a:p>
-                      <a:pPr lvl="0" indent="0" marL="0">
-                        <a:buNone/>
-                      </a:pPr>
-                      <a:r>
-                        <a:rPr/>
-                        <a:t>15832.049590</a:t>
-                      </a:r>
-                    </a:p>
-                  </a:txBody>
-                </a:tc>
-                <a:tc>
-                  <a:txBody>
-                    <a:bodyPr/>
-                    <a:lstStyle/>
-                    <a:p>
-                      <a:pPr lvl="0" indent="0" marL="0">
-                        <a:buNone/>
-                      </a:pPr>
-                      <a:r>
-                        <a:rPr/>
-                        <a:t>125.825473</a:t>
-                      </a:r>
-                    </a:p>
-                  </a:txBody>
-                </a:tc>
-                <a:tc>
-                  <a:txBody>
-                    <a:bodyPr/>
-                    <a:lstStyle/>
-                    <a:p>
-                      <a:pPr lvl="0" indent="0" marL="0">
-                        <a:buNone/>
-                      </a:pPr>
-                      <a:r>
-                        <a:rPr/>
-                        <a:t>34.801913</a:t>
-                      </a:r>
-                    </a:p>
-                  </a:txBody>
-                </a:tc>
-                <a:tc>
-                  <a:txBody>
-                    <a:bodyPr/>
-                    <a:lstStyle/>
-                    <a:p>
-                      <a:pPr lvl="0" indent="0" marL="0">
-                        <a:buNone/>
-                      </a:pPr>
-                      <a:r>
-                        <a:rPr/>
-                        <a:t>0.119574</a:t>
+                        <a:t>12</a:t>
+                      </a:r>
+                    </a:p>
+                  </a:txBody>
+                </a:tc>
+                <a:tc>
+                  <a:txBody>
+                    <a:bodyPr/>
+                    <a:lstStyle/>
+                    <a:p>
+                      <a:pPr lvl="0" indent="0" marL="0">
+                        <a:buNone/>
+                      </a:pPr>
+                      <a:r>
+                        <a:rPr/>
+                        <a:t>7.5</a:t>
+                      </a:r>
+                    </a:p>
+                  </a:txBody>
+                </a:tc>
+                <a:tc>
+                  <a:txBody>
+                    <a:bodyPr/>
+                    <a:lstStyle/>
+                    <a:p>
+                      <a:pPr lvl="0" indent="0" marL="0">
+                        <a:buNone/>
+                      </a:pPr>
+                      <a:r>
+                        <a:rPr/>
+                        <a:t>45.2</a:t>
+                      </a:r>
+                    </a:p>
+                  </a:txBody>
+                </a:tc>
+                <a:tc>
+                  <a:txBody>
+                    <a:bodyPr/>
+                    <a:lstStyle/>
+                    <a:p>
+                      <a:pPr lvl="0" indent="0" marL="0">
+                        <a:buNone/>
+                      </a:pPr>
+                      <a:r>
+                        <a:rPr/>
+                        <a:t>178.86</a:t>
                       </a:r>
                     </a:p>
                   </a:txBody>
@@ -3700,82 +4941,52 @@
                       </a:pPr>
                       <a:r>
                         <a:rPr/>
-                        <a:t>balsam fir</a:t>
-                      </a:r>
-                    </a:p>
-                  </a:txBody>
-                </a:tc>
-                <a:tc>
-                  <a:txBody>
-                    <a:bodyPr/>
-                    <a:lstStyle/>
-                    <a:p>
-                      <a:pPr lvl="0" indent="0" marL="0">
-                        <a:buNone/>
-                      </a:pPr>
-                      <a:r>
-                        <a:rPr/>
-                        <a:t>3</a:t>
-                      </a:r>
-                    </a:p>
-                  </a:txBody>
-                </a:tc>
-                <a:tc>
-                  <a:txBody>
-                    <a:bodyPr/>
-                    <a:lstStyle/>
-                    <a:p>
-                      <a:pPr lvl="0" indent="0" marL="0">
-                        <a:buNone/>
-                      </a:pPr>
-                      <a:r>
-                        <a:rPr/>
-                        <a:t>16809.506015</a:t>
-                      </a:r>
-                    </a:p>
-                  </a:txBody>
-                </a:tc>
-                <a:tc>
-                  <a:txBody>
-                    <a:bodyPr/>
-                    <a:lstStyle/>
-                    <a:p>
-                      <a:pPr lvl="0" indent="0" marL="0">
-                        <a:buNone/>
-                      </a:pPr>
-                      <a:r>
-                        <a:rPr/>
-                        <a:t>129.651479</a:t>
-                      </a:r>
-                    </a:p>
-                  </a:txBody>
-                </a:tc>
-                <a:tc>
-                  <a:txBody>
-                    <a:bodyPr/>
-                    <a:lstStyle/>
-                    <a:p>
-                      <a:pPr lvl="0" indent="0" marL="0">
-                        <a:buNone/>
-                      </a:pPr>
-                      <a:r>
-                        <a:rPr/>
-                        <a:t>36.646493</a:t>
-                      </a:r>
-                    </a:p>
-                  </a:txBody>
-                </a:tc>
-                <a:tc>
-                  <a:txBody>
-                    <a:bodyPr/>
-                    <a:lstStyle/>
-                    <a:p>
-                      <a:pPr lvl="0" indent="0" marL="0">
-                        <a:buNone/>
-                      </a:pPr>
-                      <a:r>
-                        <a:rPr/>
-                        <a:t>0.123724</a:t>
+                        <a:t>12</a:t>
+                      </a:r>
+                    </a:p>
+                  </a:txBody>
+                </a:tc>
+                <a:tc>
+                  <a:txBody>
+                    <a:bodyPr/>
+                    <a:lstStyle/>
+                    <a:p>
+                      <a:pPr lvl="0" indent="0" marL="0">
+                        <a:buNone/>
+                      </a:pPr>
+                      <a:r>
+                        <a:rPr/>
+                        <a:t>9.3</a:t>
+                      </a:r>
+                    </a:p>
+                  </a:txBody>
+                </a:tc>
+                <a:tc>
+                  <a:txBody>
+                    <a:bodyPr/>
+                    <a:lstStyle/>
+                    <a:p>
+                      <a:pPr lvl="0" indent="0" marL="0">
+                        <a:buNone/>
+                      </a:pPr>
+                      <a:r>
+                        <a:rPr/>
+                        <a:t>62.7</a:t>
+                      </a:r>
+                    </a:p>
+                  </a:txBody>
+                </a:tc>
+                <a:tc>
+                  <a:txBody>
+                    <a:bodyPr/>
+                    <a:lstStyle/>
+                    <a:p>
+                      <a:pPr lvl="0" indent="0" marL="0">
+                        <a:buNone/>
+                      </a:pPr>
+                      <a:r>
+                        <a:rPr/>
+                        <a:t>323.46</a:t>
                       </a:r>
                     </a:p>
                   </a:txBody>
@@ -3807,82 +5018,52 @@
                       </a:pPr>
                       <a:r>
                         <a:rPr/>
-                        <a:t>balsam fir</a:t>
-                      </a:r>
-                    </a:p>
-                  </a:txBody>
-                </a:tc>
-                <a:tc>
-                  <a:txBody>
-                    <a:bodyPr/>
-                    <a:lstStyle/>
-                    <a:p>
-                      <a:pPr lvl="0" indent="0" marL="0">
-                        <a:buNone/>
-                      </a:pPr>
-                      <a:r>
-                        <a:rPr/>
-                        <a:t>4</a:t>
-                      </a:r>
-                    </a:p>
-                  </a:txBody>
-                </a:tc>
-                <a:tc>
-                  <a:txBody>
-                    <a:bodyPr/>
-                    <a:lstStyle/>
-                    <a:p>
-                      <a:pPr lvl="0" indent="0" marL="0">
-                        <a:buNone/>
-                      </a:pPr>
-                      <a:r>
-                        <a:rPr/>
-                        <a:t>18117.114099</a:t>
-                      </a:r>
-                    </a:p>
-                  </a:txBody>
-                </a:tc>
-                <a:tc>
-                  <a:txBody>
-                    <a:bodyPr/>
-                    <a:lstStyle/>
-                    <a:p>
-                      <a:pPr lvl="0" indent="0" marL="0">
-                        <a:buNone/>
-                      </a:pPr>
-                      <a:r>
-                        <a:rPr/>
-                        <a:t>134.599829</a:t>
-                      </a:r>
-                    </a:p>
-                  </a:txBody>
-                </a:tc>
-                <a:tc>
-                  <a:txBody>
-                    <a:bodyPr/>
-                    <a:lstStyle/>
-                    <a:p>
-                      <a:pPr lvl="0" indent="0" marL="0">
-                        <a:buNone/>
-                      </a:pPr>
-                      <a:r>
-                        <a:rPr/>
-                        <a:t>38.884870</a:t>
-                      </a:r>
-                    </a:p>
-                  </a:txBody>
-                </a:tc>
-                <a:tc>
-                  <a:txBody>
-                    <a:bodyPr/>
-                    <a:lstStyle/>
-                    <a:p>
-                      <a:pPr lvl="0" indent="0" marL="0">
-                        <a:buNone/>
-                      </a:pPr>
-                      <a:r>
-                        <a:rPr/>
-                        <a:t>0.133858</a:t>
+                        <a:t>12</a:t>
+                      </a:r>
+                    </a:p>
+                  </a:txBody>
+                </a:tc>
+                <a:tc>
+                  <a:txBody>
+                    <a:bodyPr/>
+                    <a:lstStyle/>
+                    <a:p>
+                      <a:pPr lvl="0" indent="0" marL="0">
+                        <a:buNone/>
+                      </a:pPr>
+                      <a:r>
+                        <a:rPr/>
+                        <a:t>9.7</a:t>
+                      </a:r>
+                    </a:p>
+                  </a:txBody>
+                </a:tc>
+                <a:tc>
+                  <a:txBody>
+                    <a:bodyPr/>
+                    <a:lstStyle/>
+                    <a:p>
+                      <a:pPr lvl="0" indent="0" marL="0">
+                        <a:buNone/>
+                      </a:pPr>
+                      <a:r>
+                        <a:rPr/>
+                        <a:t>56.7</a:t>
+                      </a:r>
+                    </a:p>
+                  </a:txBody>
+                </a:tc>
+                <a:tc>
+                  <a:txBody>
+                    <a:bodyPr/>
+                    <a:lstStyle/>
+                    <a:p>
+                      <a:pPr lvl="0" indent="0" marL="0">
+                        <a:buNone/>
+                      </a:pPr>
+                      <a:r>
+                        <a:rPr/>
+                        <a:t>342.47</a:t>
                       </a:r>
                     </a:p>
                   </a:txBody>
@@ -3914,82 +5095,52 @@
                       </a:pPr>
                       <a:r>
                         <a:rPr/>
-                        <a:t>balsam fir</a:t>
-                      </a:r>
-                    </a:p>
-                  </a:txBody>
-                </a:tc>
-                <a:tc>
-                  <a:txBody>
-                    <a:bodyPr/>
-                    <a:lstStyle/>
-                    <a:p>
-                      <a:pPr lvl="0" indent="0" marL="0">
-                        <a:buNone/>
-                      </a:pPr>
-                      <a:r>
-                        <a:rPr/>
-                        <a:t>5</a:t>
-                      </a:r>
-                    </a:p>
-                  </a:txBody>
-                </a:tc>
-                <a:tc>
-                  <a:txBody>
-                    <a:bodyPr/>
-                    <a:lstStyle/>
-                    <a:p>
-                      <a:pPr lvl="0" indent="0" marL="0">
-                        <a:buNone/>
-                      </a:pPr>
-                      <a:r>
-                        <a:rPr/>
-                        <a:t>21026.044395</a:t>
-                      </a:r>
-                    </a:p>
-                  </a:txBody>
-                </a:tc>
-                <a:tc>
-                  <a:txBody>
-                    <a:bodyPr/>
-                    <a:lstStyle/>
-                    <a:p>
-                      <a:pPr lvl="0" indent="0" marL="0">
-                        <a:buNone/>
-                      </a:pPr>
-                      <a:r>
-                        <a:rPr/>
-                        <a:t>145.003601</a:t>
-                      </a:r>
-                    </a:p>
-                  </a:txBody>
-                </a:tc>
-                <a:tc>
-                  <a:txBody>
-                    <a:bodyPr/>
-                    <a:lstStyle/>
-                    <a:p>
-                      <a:pPr lvl="0" indent="0" marL="0">
-                        <a:buNone/>
-                      </a:pPr>
-                      <a:r>
-                        <a:rPr/>
-                        <a:t>41.209530</a:t>
-                      </a:r>
-                    </a:p>
-                  </a:txBody>
-                </a:tc>
-                <a:tc>
-                  <a:txBody>
-                    <a:bodyPr/>
-                    <a:lstStyle/>
-                    <a:p>
-                      <a:pPr lvl="0" indent="0" marL="0">
-                        <a:buNone/>
-                      </a:pPr>
-                      <a:r>
-                        <a:rPr/>
-                        <a:t>0.144063</a:t>
+                        <a:t>12</a:t>
+                      </a:r>
+                    </a:p>
+                  </a:txBody>
+                </a:tc>
+                <a:tc>
+                  <a:txBody>
+                    <a:bodyPr/>
+                    <a:lstStyle/>
+                    <a:p>
+                      <a:pPr lvl="0" indent="0" marL="0">
+                        <a:buNone/>
+                      </a:pPr>
+                      <a:r>
+                        <a:rPr/>
+                        <a:t>11.4</a:t>
+                      </a:r>
+                    </a:p>
+                  </a:txBody>
+                </a:tc>
+                <a:tc>
+                  <a:txBody>
+                    <a:bodyPr/>
+                    <a:lstStyle/>
+                    <a:p>
+                      <a:pPr lvl="0" indent="0" marL="0">
+                        <a:buNone/>
+                      </a:pPr>
+                      <a:r>
+                        <a:rPr/>
+                        <a:t>66.1</a:t>
+                      </a:r>
+                    </a:p>
+                  </a:txBody>
+                </a:tc>
+                <a:tc>
+                  <a:txBody>
+                    <a:bodyPr/>
+                    <a:lstStyle/>
+                    <a:p>
+                      <a:pPr lvl="0" indent="0" marL="0">
+                        <a:buNone/>
+                      </a:pPr>
+                      <a:r>
+                        <a:rPr/>
+                        <a:t>499.35</a:t>
                       </a:r>
                     </a:p>
                   </a:txBody>
@@ -4021,724 +5172,52 @@
                       </a:pPr>
                       <a:r>
                         <a:rPr/>
-                        <a:t>balsam fir</a:t>
-                      </a:r>
-                    </a:p>
-                  </a:txBody>
-                </a:tc>
-                <a:tc>
-                  <a:txBody>
-                    <a:bodyPr/>
-                    <a:lstStyle/>
-                    <a:p>
-                      <a:pPr lvl="0" indent="0" marL="0">
-                        <a:buNone/>
-                      </a:pPr>
-                      <a:r>
-                        <a:rPr/>
-                        <a:t>6</a:t>
-                      </a:r>
-                    </a:p>
-                  </a:txBody>
-                </a:tc>
-                <a:tc>
-                  <a:txBody>
-                    <a:bodyPr/>
-                    <a:lstStyle/>
-                    <a:p>
-                      <a:pPr lvl="0" indent="0" marL="0">
-                        <a:buNone/>
-                      </a:pPr>
-                      <a:r>
-                        <a:rPr/>
-                        <a:t>21741.891998</a:t>
-                      </a:r>
-                    </a:p>
-                  </a:txBody>
-                </a:tc>
-                <a:tc>
-                  <a:txBody>
-                    <a:bodyPr/>
-                    <a:lstStyle/>
-                    <a:p>
-                      <a:pPr lvl="0" indent="0" marL="0">
-                        <a:buNone/>
-                      </a:pPr>
-                      <a:r>
-                        <a:rPr/>
-                        <a:t>147.451321</a:t>
-                      </a:r>
-                    </a:p>
-                  </a:txBody>
-                </a:tc>
-                <a:tc>
-                  <a:txBody>
-                    <a:bodyPr/>
-                    <a:lstStyle/>
-                    <a:p>
-                      <a:pPr lvl="0" indent="0" marL="0">
-                        <a:buNone/>
-                      </a:pPr>
-                      <a:r>
-                        <a:rPr/>
-                        <a:t>40.791681</a:t>
-                      </a:r>
-                    </a:p>
-                  </a:txBody>
-                </a:tc>
-                <a:tc>
-                  <a:txBody>
-                    <a:bodyPr/>
-                    <a:lstStyle/>
-                    <a:p>
-                      <a:pPr lvl="0" indent="0" marL="0">
-                        <a:buNone/>
-                      </a:pPr>
-                      <a:r>
-                        <a:rPr/>
-                        <a:t>0.142862</a:t>
-                      </a:r>
-                    </a:p>
-                  </a:txBody>
-                </a:tc>
-              </a:tr>
-              <a:tr h="0">
-                <a:tc>
-                  <a:txBody>
-                    <a:bodyPr/>
-                    <a:lstStyle/>
-                    <a:p>
-                      <a:pPr lvl="0" indent="0" marL="0">
-                        <a:buNone/>
-                      </a:pPr>
-                      <a:r>
-                        <a:rPr/>
-                        <a:t>...</a:t>
-                      </a:r>
-                    </a:p>
-                  </a:txBody>
-                </a:tc>
-                <a:tc>
-                  <a:txBody>
-                    <a:bodyPr/>
-                    <a:lstStyle/>
-                    <a:p>
-                      <a:pPr lvl="0" indent="0" marL="0">
-                        <a:buNone/>
-                      </a:pPr>
-                      <a:r>
-                        <a:rPr/>
-                        <a:t>...</a:t>
-                      </a:r>
-                    </a:p>
-                  </a:txBody>
-                </a:tc>
-                <a:tc>
-                  <a:txBody>
-                    <a:bodyPr/>
-                    <a:lstStyle/>
-                    <a:p>
-                      <a:pPr lvl="0" indent="0" marL="0">
-                        <a:buNone/>
-                      </a:pPr>
-                      <a:r>
-                        <a:rPr/>
-                        <a:t>...</a:t>
-                      </a:r>
-                    </a:p>
-                  </a:txBody>
-                </a:tc>
-                <a:tc>
-                  <a:txBody>
-                    <a:bodyPr/>
-                    <a:lstStyle/>
-                    <a:p>
-                      <a:pPr lvl="0" indent="0" marL="0">
-                        <a:buNone/>
-                      </a:pPr>
-                      <a:r>
-                        <a:rPr/>
-                        <a:t>...</a:t>
-                      </a:r>
-                    </a:p>
-                  </a:txBody>
-                </a:tc>
-                <a:tc>
-                  <a:txBody>
-                    <a:bodyPr/>
-                    <a:lstStyle/>
-                    <a:p>
-                      <a:pPr lvl="0" indent="0" marL="0">
-                        <a:buNone/>
-                      </a:pPr>
-                      <a:r>
-                        <a:rPr/>
-                        <a:t>...</a:t>
-                      </a:r>
-                    </a:p>
-                  </a:txBody>
-                </a:tc>
-                <a:tc>
-                  <a:txBody>
-                    <a:bodyPr/>
-                    <a:lstStyle/>
-                    <a:p>
-                      <a:pPr lvl="0" indent="0" marL="0">
-                        <a:buNone/>
-                      </a:pPr>
-                      <a:r>
-                        <a:rPr/>
-                        <a:t>...</a:t>
-                      </a:r>
-                    </a:p>
-                  </a:txBody>
-                </a:tc>
-                <a:tc>
-                  <a:txBody>
-                    <a:bodyPr/>
-                    <a:lstStyle/>
-                    <a:p>
-                      <a:pPr lvl="0" indent="0" marL="0">
-                        <a:buNone/>
-                      </a:pPr>
-                      <a:r>
-                        <a:rPr/>
-                        <a:t>...</a:t>
-                      </a:r>
-                    </a:p>
-                  </a:txBody>
-                </a:tc>
-              </a:tr>
-              <a:tr h="0">
-                <a:tc>
-                  <a:txBody>
-                    <a:bodyPr/>
-                    <a:lstStyle/>
-                    <a:p>
-                      <a:pPr lvl="0" indent="0" marL="0">
-                        <a:buNone/>
-                      </a:pPr>
-                      <a:r>
-                        <a:rPr/>
-                        <a:t>895</a:t>
-                      </a:r>
-                    </a:p>
-                  </a:txBody>
-                </a:tc>
-                <a:tc>
-                  <a:txBody>
-                    <a:bodyPr/>
-                    <a:lstStyle/>
-                    <a:p>
-                      <a:pPr lvl="0" indent="0" marL="0">
-                        <a:buNone/>
-                      </a:pPr>
-                      <a:r>
-                        <a:rPr/>
-                        <a:t>sugarberry</a:t>
-                      </a:r>
-                    </a:p>
-                  </a:txBody>
-                </a:tc>
-                <a:tc>
-                  <a:txBody>
-                    <a:bodyPr/>
-                    <a:lstStyle/>
-                    <a:p>
-                      <a:pPr lvl="0" indent="0" marL="0">
-                        <a:buNone/>
-                      </a:pPr>
-                      <a:r>
-                        <a:rPr/>
-                        <a:t>6</a:t>
-                      </a:r>
-                    </a:p>
-                  </a:txBody>
-                </a:tc>
-                <a:tc>
-                  <a:txBody>
-                    <a:bodyPr/>
-                    <a:lstStyle/>
-                    <a:p>
-                      <a:pPr lvl="0" indent="0" marL="0">
-                        <a:buNone/>
-                      </a:pPr>
-                      <a:r>
-                        <a:rPr/>
-                        <a:t>1051.773141</a:t>
-                      </a:r>
-                    </a:p>
-                  </a:txBody>
-                </a:tc>
-                <a:tc>
-                  <a:txBody>
-                    <a:bodyPr/>
-                    <a:lstStyle/>
-                    <a:p>
-                      <a:pPr lvl="0" indent="0" marL="0">
-                        <a:buNone/>
-                      </a:pPr>
-                      <a:r>
-                        <a:rPr/>
-                        <a:t>32.431052</a:t>
-                      </a:r>
-                    </a:p>
-                  </a:txBody>
-                </a:tc>
-                <a:tc>
-                  <a:txBody>
-                    <a:bodyPr/>
-                    <a:lstStyle/>
-                    <a:p>
-                      <a:pPr lvl="0" indent="0" marL="0">
-                        <a:buNone/>
-                      </a:pPr>
-                      <a:r>
-                        <a:rPr/>
-                        <a:t>20.969306</a:t>
-                      </a:r>
-                    </a:p>
-                  </a:txBody>
-                </a:tc>
-                <a:tc>
-                  <a:txBody>
-                    <a:bodyPr/>
-                    <a:lstStyle/>
-                    <a:p>
-                      <a:pPr lvl="0" indent="0" marL="0">
-                        <a:buNone/>
-                      </a:pPr>
-                      <a:r>
-                        <a:rPr/>
-                        <a:t>0.565727</a:t>
-                      </a:r>
-                    </a:p>
-                  </a:txBody>
-                </a:tc>
-              </a:tr>
-              <a:tr h="0">
-                <a:tc>
-                  <a:txBody>
-                    <a:bodyPr/>
-                    <a:lstStyle/>
-                    <a:p>
-                      <a:pPr lvl="0" indent="0" marL="0">
-                        <a:buNone/>
-                      </a:pPr>
-                      <a:r>
-                        <a:rPr/>
-                        <a:t>896</a:t>
-                      </a:r>
-                    </a:p>
-                  </a:txBody>
-                </a:tc>
-                <a:tc>
-                  <a:txBody>
-                    <a:bodyPr/>
-                    <a:lstStyle/>
-                    <a:p>
-                      <a:pPr lvl="0" indent="0" marL="0">
-                        <a:buNone/>
-                      </a:pPr>
-                      <a:r>
-                        <a:rPr/>
-                        <a:t>sugarberry</a:t>
-                      </a:r>
-                    </a:p>
-                  </a:txBody>
-                </a:tc>
-                <a:tc>
-                  <a:txBody>
-                    <a:bodyPr/>
-                    <a:lstStyle/>
-                    <a:p>
-                      <a:pPr lvl="0" indent="0" marL="0">
-                        <a:buNone/>
-                      </a:pPr>
-                      <a:r>
-                        <a:rPr/>
-                        <a:t>7</a:t>
-                      </a:r>
-                    </a:p>
-                  </a:txBody>
-                </a:tc>
-                <a:tc>
-                  <a:txBody>
-                    <a:bodyPr/>
-                    <a:lstStyle/>
-                    <a:p>
-                      <a:pPr lvl="0" indent="0" marL="0">
-                        <a:buNone/>
-                      </a:pPr>
-                      <a:r>
-                        <a:rPr/>
-                        <a:t>1393.100286</a:t>
-                      </a:r>
-                    </a:p>
-                  </a:txBody>
-                </a:tc>
-                <a:tc>
-                  <a:txBody>
-                    <a:bodyPr/>
-                    <a:lstStyle/>
-                    <a:p>
-                      <a:pPr lvl="0" indent="0" marL="0">
-                        <a:buNone/>
-                      </a:pPr>
-                      <a:r>
-                        <a:rPr/>
-                        <a:t>37.324259</a:t>
-                      </a:r>
-                    </a:p>
-                  </a:txBody>
-                </a:tc>
-                <a:tc>
-                  <a:txBody>
-                    <a:bodyPr/>
-                    <a:lstStyle/>
-                    <a:p>
-                      <a:pPr lvl="0" indent="0" marL="0">
-                        <a:buNone/>
-                      </a:pPr>
-                      <a:r>
-                        <a:rPr/>
-                        <a:t>25.037024</a:t>
-                      </a:r>
-                    </a:p>
-                  </a:txBody>
-                </a:tc>
-                <a:tc>
-                  <a:txBody>
-                    <a:bodyPr/>
-                    <a:lstStyle/>
-                    <a:p>
-                      <a:pPr lvl="0" indent="0" marL="0">
-                        <a:buNone/>
-                      </a:pPr>
-                      <a:r>
-                        <a:rPr/>
-                        <a:t>0.637629</a:t>
-                      </a:r>
-                    </a:p>
-                  </a:txBody>
-                </a:tc>
-              </a:tr>
-              <a:tr h="0">
-                <a:tc>
-                  <a:txBody>
-                    <a:bodyPr/>
-                    <a:lstStyle/>
-                    <a:p>
-                      <a:pPr lvl="0" indent="0" marL="0">
-                        <a:buNone/>
-                      </a:pPr>
-                      <a:r>
-                        <a:rPr/>
-                        <a:t>897</a:t>
-                      </a:r>
-                    </a:p>
-                  </a:txBody>
-                </a:tc>
-                <a:tc>
-                  <a:txBody>
-                    <a:bodyPr/>
-                    <a:lstStyle/>
-                    <a:p>
-                      <a:pPr lvl="0" indent="0" marL="0">
-                        <a:buNone/>
-                      </a:pPr>
-                      <a:r>
-                        <a:rPr/>
-                        <a:t>sugarberry</a:t>
-                      </a:r>
-                    </a:p>
-                  </a:txBody>
-                </a:tc>
-                <a:tc>
-                  <a:txBody>
-                    <a:bodyPr/>
-                    <a:lstStyle/>
-                    <a:p>
-                      <a:pPr lvl="0" indent="0" marL="0">
-                        <a:buNone/>
-                      </a:pPr>
-                      <a:r>
-                        <a:rPr/>
-                        <a:t>8</a:t>
-                      </a:r>
-                    </a:p>
-                  </a:txBody>
-                </a:tc>
-                <a:tc>
-                  <a:txBody>
-                    <a:bodyPr/>
-                    <a:lstStyle/>
-                    <a:p>
-                      <a:pPr lvl="0" indent="0" marL="0">
-                        <a:buNone/>
-                      </a:pPr>
-                      <a:r>
-                        <a:rPr/>
-                        <a:t>1455.022421</a:t>
-                      </a:r>
-                    </a:p>
-                  </a:txBody>
-                </a:tc>
-                <a:tc>
-                  <a:txBody>
-                    <a:bodyPr/>
-                    <a:lstStyle/>
-                    <a:p>
-                      <a:pPr lvl="0" indent="0" marL="0">
-                        <a:buNone/>
-                      </a:pPr>
-                      <a:r>
-                        <a:rPr/>
-                        <a:t>38.144756</a:t>
-                      </a:r>
-                    </a:p>
-                  </a:txBody>
-                </a:tc>
-                <a:tc>
-                  <a:txBody>
-                    <a:bodyPr/>
-                    <a:lstStyle/>
-                    <a:p>
-                      <a:pPr lvl="0" indent="0" marL="0">
-                        <a:buNone/>
-                      </a:pPr>
-                      <a:r>
-                        <a:rPr/>
-                        <a:t>26.680208</a:t>
-                      </a:r>
-                    </a:p>
-                  </a:txBody>
-                </a:tc>
-                <a:tc>
-                  <a:txBody>
-                    <a:bodyPr/>
-                    <a:lstStyle/>
-                    <a:p>
-                      <a:pPr lvl="0" indent="0" marL="0">
-                        <a:buNone/>
-                      </a:pPr>
-                      <a:r>
-                        <a:rPr/>
-                        <a:t>0.665159</a:t>
-                      </a:r>
-                    </a:p>
-                  </a:txBody>
-                </a:tc>
-              </a:tr>
-              <a:tr h="0">
-                <a:tc>
-                  <a:txBody>
-                    <a:bodyPr/>
-                    <a:lstStyle/>
-                    <a:p>
-                      <a:pPr lvl="0" indent="0" marL="0">
-                        <a:buNone/>
-                      </a:pPr>
-                      <a:r>
-                        <a:rPr/>
-                        <a:t>898</a:t>
-                      </a:r>
-                    </a:p>
-                  </a:txBody>
-                </a:tc>
-                <a:tc>
-                  <a:txBody>
-                    <a:bodyPr/>
-                    <a:lstStyle/>
-                    <a:p>
-                      <a:pPr lvl="0" indent="0" marL="0">
-                        <a:buNone/>
-                      </a:pPr>
-                      <a:r>
-                        <a:rPr/>
-                        <a:t>sugarberry</a:t>
-                      </a:r>
-                    </a:p>
-                  </a:txBody>
-                </a:tc>
-                <a:tc>
-                  <a:txBody>
-                    <a:bodyPr/>
-                    <a:lstStyle/>
-                    <a:p>
-                      <a:pPr lvl="0" indent="0" marL="0">
-                        <a:buNone/>
-                      </a:pPr>
-                      <a:r>
-                        <a:rPr/>
-                        <a:t>9</a:t>
-                      </a:r>
-                    </a:p>
-                  </a:txBody>
-                </a:tc>
-                <a:tc>
-                  <a:txBody>
-                    <a:bodyPr/>
-                    <a:lstStyle/>
-                    <a:p>
-                      <a:pPr lvl="0" indent="0" marL="0">
-                        <a:buNone/>
-                      </a:pPr>
-                      <a:r>
-                        <a:rPr/>
-                        <a:t>1358.161657</a:t>
-                      </a:r>
-                    </a:p>
-                  </a:txBody>
-                </a:tc>
-                <a:tc>
-                  <a:txBody>
-                    <a:bodyPr/>
-                    <a:lstStyle/>
-                    <a:p>
-                      <a:pPr lvl="0" indent="0" marL="0">
-                        <a:buNone/>
-                      </a:pPr>
-                      <a:r>
-                        <a:rPr/>
-                        <a:t>36.853245</a:t>
-                      </a:r>
-                    </a:p>
-                  </a:txBody>
-                </a:tc>
-                <a:tc>
-                  <a:txBody>
-                    <a:bodyPr/>
-                    <a:lstStyle/>
-                    <a:p>
-                      <a:pPr lvl="0" indent="0" marL="0">
-                        <a:buNone/>
-                      </a:pPr>
-                      <a:r>
-                        <a:rPr/>
-                        <a:t>21.021667</a:t>
-                      </a:r>
-                    </a:p>
-                  </a:txBody>
-                </a:tc>
-                <a:tc>
-                  <a:txBody>
-                    <a:bodyPr/>
-                    <a:lstStyle/>
-                    <a:p>
-                      <a:pPr lvl="0" indent="0" marL="0">
-                        <a:buNone/>
-                      </a:pPr>
-                      <a:r>
-                        <a:rPr/>
-                        <a:t>0.685162</a:t>
-                      </a:r>
-                    </a:p>
-                  </a:txBody>
-                </a:tc>
-              </a:tr>
-              <a:tr h="0">
-                <a:tc>
-                  <a:txBody>
-                    <a:bodyPr/>
-                    <a:lstStyle/>
-                    <a:p>
-                      <a:pPr lvl="0" indent="0" marL="0">
-                        <a:buNone/>
-                      </a:pPr>
-                      <a:r>
-                        <a:rPr/>
-                        <a:t>899</a:t>
-                      </a:r>
-                    </a:p>
-                  </a:txBody>
-                </a:tc>
-                <a:tc>
-                  <a:txBody>
-                    <a:bodyPr/>
-                    <a:lstStyle/>
-                    <a:p>
-                      <a:pPr lvl="0" indent="0" marL="0">
-                        <a:buNone/>
-                      </a:pPr>
-                      <a:r>
-                        <a:rPr/>
-                        <a:t>sugarberry</a:t>
-                      </a:r>
-                    </a:p>
-                  </a:txBody>
-                </a:tc>
-                <a:tc>
-                  <a:txBody>
-                    <a:bodyPr/>
-                    <a:lstStyle/>
-                    <a:p>
-                      <a:pPr lvl="0" indent="0" marL="0">
-                        <a:buNone/>
-                      </a:pPr>
-                      <a:r>
-                        <a:rPr/>
-                        <a:t>10</a:t>
-                      </a:r>
-                    </a:p>
-                  </a:txBody>
-                </a:tc>
-                <a:tc>
-                  <a:txBody>
-                    <a:bodyPr/>
-                    <a:lstStyle/>
-                    <a:p>
-                      <a:pPr lvl="0" indent="0" marL="0">
-                        <a:buNone/>
-                      </a:pPr>
-                      <a:r>
-                        <a:rPr/>
-                        <a:t>1607.296767</a:t>
-                      </a:r>
-                    </a:p>
-                  </a:txBody>
-                </a:tc>
-                <a:tc>
-                  <a:txBody>
-                    <a:bodyPr/>
-                    <a:lstStyle/>
-                    <a:p>
-                      <a:pPr lvl="0" indent="0" marL="0">
-                        <a:buNone/>
-                      </a:pPr>
-                      <a:r>
-                        <a:rPr/>
-                        <a:t>40.091106</a:t>
-                      </a:r>
-                    </a:p>
-                  </a:txBody>
-                </a:tc>
-                <a:tc>
-                  <a:txBody>
-                    <a:bodyPr/>
-                    <a:lstStyle/>
-                    <a:p>
-                      <a:pPr lvl="0" indent="0" marL="0">
-                        <a:buNone/>
-                      </a:pPr>
-                      <a:r>
-                        <a:rPr/>
-                        <a:t>23.172083</a:t>
-                      </a:r>
-                    </a:p>
-                  </a:txBody>
-                </a:tc>
-                <a:tc>
-                  <a:txBody>
-                    <a:bodyPr/>
-                    <a:lstStyle/>
-                    <a:p>
-                      <a:pPr lvl="0" indent="0" marL="0">
-                        <a:buNone/>
-                      </a:pPr>
-                      <a:r>
-                        <a:rPr/>
-                        <a:t>0.677519</a:t>
+                        <a:t>12</a:t>
+                      </a:r>
+                    </a:p>
+                  </a:txBody>
+                </a:tc>
+                <a:tc>
+                  <a:txBody>
+                    <a:bodyPr/>
+                    <a:lstStyle/>
+                    <a:p>
+                      <a:pPr lvl="0" indent="0" marL="0">
+                        <a:buNone/>
+                      </a:pPr>
+                      <a:r>
+                        <a:rPr/>
+                        <a:t>6.4</a:t>
+                      </a:r>
+                    </a:p>
+                  </a:txBody>
+                </a:tc>
+                <a:tc>
+                  <a:txBody>
+                    <a:bodyPr/>
+                    <a:lstStyle/>
+                    <a:p>
+                      <a:pPr lvl="0" indent="0" marL="0">
+                        <a:buNone/>
+                      </a:pPr>
+                      <a:r>
+                        <a:rPr/>
+                        <a:t>51.8</a:t>
+                      </a:r>
+                    </a:p>
+                  </a:txBody>
+                </a:tc>
+                <a:tc>
+                  <a:txBody>
+                    <a:bodyPr/>
+                    <a:lstStyle/>
+                    <a:p>
+                      <a:pPr lvl="0" indent="0" marL="0">
+                        <a:buNone/>
+                      </a:pPr>
+                      <a:r>
+                        <a:rPr/>
+                        <a:t>113.92</a:t>
                       </a:r>
                     </a:p>
                   </a:txBody>
@@ -4770,31 +5249,6 @@
           <a:chExt cx="0" cy="0"/>
         </a:xfrm>
       </p:grpSpPr>
-      <p:sp>
-        <p:nvSpPr>
-          <p:cNvPr id="2" name="Title 1"/>
-          <p:cNvSpPr>
-            <a:spLocks noGrp="1"/>
-          </p:cNvSpPr>
-          <p:nvPr>
-            <p:ph type="title"/>
-          </p:nvPr>
-        </p:nvSpPr>
-        <p:spPr/>
-        <p:txBody>
-          <a:bodyPr/>
-          <a:lstStyle/>
-          <a:p>
-            <a:pPr lvl="0" indent="0" marL="0">
-              <a:buNone/>
-            </a:pPr>
-            <a:r>
-              <a:rPr/>
-              <a:t>Technical Lead</a:t>
-            </a:r>
-          </a:p>
-        </p:txBody>
-      </p:sp>
       <p:graphicFrame>
         <p:nvGraphicFramePr>
           <p:cNvPr id="6" name="Content Placeholder 5"/>
@@ -4816,11 +5270,9 @@
                 <a:tableStyleId>{5C22544A-7EE6-4342-B048-85BDC9FD1C3A}</a:tableStyleId>
               </a:tblPr>
               <a:tblGrid>
-                <a:gridCol w="1638300"/>
-                <a:gridCol w="1638300"/>
-                <a:gridCol w="1638300"/>
-                <a:gridCol w="1638300"/>
-                <a:gridCol w="1638300"/>
+                <a:gridCol w="2743200"/>
+                <a:gridCol w="2743200"/>
+                <a:gridCol w="2743200"/>
               </a:tblGrid>
               <a:tr h="0">
                 <a:tc>
@@ -4859,39 +5311,7 @@
                       </a:pPr>
                       <a:r>
                         <a:rPr/>
-                        <a:t>DO_BH</a:t>
-                      </a:r>
-                    </a:p>
-                  </a:txBody>
-                  <a:tcPr/>
-                </a:tc>
-                <a:tc>
-                  <a:txBody>
-                    <a:bodyPr/>
-                    <a:lstStyle/>
-                    <a:p>
-                      <a:pPr lvl="0" indent="0" marL="0">
-                        <a:buNone/>
-                      </a:pPr>
-                      <a:r>
-                        <a:rPr/>
-                        <a:t>HT_TOT</a:t>
-                      </a:r>
-                    </a:p>
-                  </a:txBody>
-                  <a:tcPr/>
-                </a:tc>
-                <a:tc>
-                  <a:txBody>
-                    <a:bodyPr/>
-                    <a:lstStyle/>
-                    <a:p>
-                      <a:pPr lvl="0" indent="0" marL="0">
-                        <a:buNone/>
-                      </a:pPr>
-                      <a:r>
-                        <a:rPr/>
-                        <a:t>TT_DW_CRM</a:t>
+                        <a:t>COMMON_NAME</a:t>
                       </a:r>
                     </a:p>
                   </a:txBody>
@@ -4924,52 +5344,22 @@
                       </a:pPr>
                       <a:r>
                         <a:rPr/>
-                        <a:t>12</a:t>
-                      </a:r>
-                    </a:p>
-                  </a:txBody>
-                </a:tc>
-                <a:tc>
-                  <a:txBody>
-                    <a:bodyPr/>
-                    <a:lstStyle/>
-                    <a:p>
-                      <a:pPr lvl="0" indent="0" marL="0">
-                        <a:buNone/>
-                      </a:pPr>
-                      <a:r>
-                        <a:rPr/>
-                        <a:t>7.5</a:t>
-                      </a:r>
-                    </a:p>
-                  </a:txBody>
-                </a:tc>
-                <a:tc>
-                  <a:txBody>
-                    <a:bodyPr/>
-                    <a:lstStyle/>
-                    <a:p>
-                      <a:pPr lvl="0" indent="0" marL="0">
-                        <a:buNone/>
-                      </a:pPr>
-                      <a:r>
-                        <a:rPr/>
-                        <a:t>45.2</a:t>
-                      </a:r>
-                    </a:p>
-                  </a:txBody>
-                </a:tc>
-                <a:tc>
-                  <a:txBody>
-                    <a:bodyPr/>
-                    <a:lstStyle/>
-                    <a:p>
-                      <a:pPr lvl="0" indent="0" marL="0">
-                        <a:buNone/>
-                      </a:pPr>
-                      <a:r>
-                        <a:rPr/>
-                        <a:t>178.86</a:t>
+                        <a:t>10</a:t>
+                      </a:r>
+                    </a:p>
+                  </a:txBody>
+                </a:tc>
+                <a:tc>
+                  <a:txBody>
+                    <a:bodyPr/>
+                    <a:lstStyle/>
+                    <a:p>
+                      <a:pPr lvl="0" indent="0" marL="0">
+                        <a:buNone/>
+                      </a:pPr>
+                      <a:r>
+                        <a:rPr/>
+                        <a:t>fir spp.</a:t>
                       </a:r>
                     </a:p>
                   </a:txBody>
@@ -5001,52 +5391,22 @@
                       </a:pPr>
                       <a:r>
                         <a:rPr/>
-                        <a:t>12</a:t>
-                      </a:r>
-                    </a:p>
-                  </a:txBody>
-                </a:tc>
-                <a:tc>
-                  <a:txBody>
-                    <a:bodyPr/>
-                    <a:lstStyle/>
-                    <a:p>
-                      <a:pPr lvl="0" indent="0" marL="0">
-                        <a:buNone/>
-                      </a:pPr>
-                      <a:r>
-                        <a:rPr/>
-                        <a:t>9.3</a:t>
-                      </a:r>
-                    </a:p>
-                  </a:txBody>
-                </a:tc>
-                <a:tc>
-                  <a:txBody>
-                    <a:bodyPr/>
-                    <a:lstStyle/>
-                    <a:p>
-                      <a:pPr lvl="0" indent="0" marL="0">
-                        <a:buNone/>
-                      </a:pPr>
-                      <a:r>
-                        <a:rPr/>
-                        <a:t>62.7</a:t>
-                      </a:r>
-                    </a:p>
-                  </a:txBody>
-                </a:tc>
-                <a:tc>
-                  <a:txBody>
-                    <a:bodyPr/>
-                    <a:lstStyle/>
-                    <a:p>
-                      <a:pPr lvl="0" indent="0" marL="0">
-                        <a:buNone/>
-                      </a:pPr>
-                      <a:r>
-                        <a:rPr/>
-                        <a:t>323.46</a:t>
+                        <a:t>11</a:t>
+                      </a:r>
+                    </a:p>
+                  </a:txBody>
+                </a:tc>
+                <a:tc>
+                  <a:txBody>
+                    <a:bodyPr/>
+                    <a:lstStyle/>
+                    <a:p>
+                      <a:pPr lvl="0" indent="0" marL="0">
+                        <a:buNone/>
+                      </a:pPr>
+                      <a:r>
+                        <a:rPr/>
+                        <a:t>Pacific silver fir</a:t>
                       </a:r>
                     </a:p>
                   </a:txBody>
@@ -5093,37 +5453,7 @@
                       </a:pPr>
                       <a:r>
                         <a:rPr/>
-                        <a:t>9.7</a:t>
-                      </a:r>
-                    </a:p>
-                  </a:txBody>
-                </a:tc>
-                <a:tc>
-                  <a:txBody>
-                    <a:bodyPr/>
-                    <a:lstStyle/>
-                    <a:p>
-                      <a:pPr lvl="0" indent="0" marL="0">
-                        <a:buNone/>
-                      </a:pPr>
-                      <a:r>
-                        <a:rPr/>
-                        <a:t>56.7</a:t>
-                      </a:r>
-                    </a:p>
-                  </a:txBody>
-                </a:tc>
-                <a:tc>
-                  <a:txBody>
-                    <a:bodyPr/>
-                    <a:lstStyle/>
-                    <a:p>
-                      <a:pPr lvl="0" indent="0" marL="0">
-                        <a:buNone/>
-                      </a:pPr>
-                      <a:r>
-                        <a:rPr/>
-                        <a:t>342.47</a:t>
+                        <a:t>balsam fir</a:t>
                       </a:r>
                     </a:p>
                   </a:txBody>
@@ -5155,52 +5485,22 @@
                       </a:pPr>
                       <a:r>
                         <a:rPr/>
-                        <a:t>12</a:t>
-                      </a:r>
-                    </a:p>
-                  </a:txBody>
-                </a:tc>
-                <a:tc>
-                  <a:txBody>
-                    <a:bodyPr/>
-                    <a:lstStyle/>
-                    <a:p>
-                      <a:pPr lvl="0" indent="0" marL="0">
-                        <a:buNone/>
-                      </a:pPr>
-                      <a:r>
-                        <a:rPr/>
-                        <a:t>11.4</a:t>
-                      </a:r>
-                    </a:p>
-                  </a:txBody>
-                </a:tc>
-                <a:tc>
-                  <a:txBody>
-                    <a:bodyPr/>
-                    <a:lstStyle/>
-                    <a:p>
-                      <a:pPr lvl="0" indent="0" marL="0">
-                        <a:buNone/>
-                      </a:pPr>
-                      <a:r>
-                        <a:rPr/>
-                        <a:t>66.1</a:t>
-                      </a:r>
-                    </a:p>
-                  </a:txBody>
-                </a:tc>
-                <a:tc>
-                  <a:txBody>
-                    <a:bodyPr/>
-                    <a:lstStyle/>
-                    <a:p>
-                      <a:pPr lvl="0" indent="0" marL="0">
-                        <a:buNone/>
-                      </a:pPr>
-                      <a:r>
-                        <a:rPr/>
-                        <a:t>499.35</a:t>
+                        <a:t>14</a:t>
+                      </a:r>
+                    </a:p>
+                  </a:txBody>
+                </a:tc>
+                <a:tc>
+                  <a:txBody>
+                    <a:bodyPr/>
+                    <a:lstStyle/>
+                    <a:p>
+                      <a:pPr lvl="0" indent="0" marL="0">
+                        <a:buNone/>
+                      </a:pPr>
+                      <a:r>
+                        <a:rPr/>
+                        <a:t>Santa Lucia or bristlecone fir</a:t>
                       </a:r>
                     </a:p>
                   </a:txBody>
@@ -5232,52 +5532,22 @@
                       </a:pPr>
                       <a:r>
                         <a:rPr/>
-                        <a:t>12</a:t>
-                      </a:r>
-                    </a:p>
-                  </a:txBody>
-                </a:tc>
-                <a:tc>
-                  <a:txBody>
-                    <a:bodyPr/>
-                    <a:lstStyle/>
-                    <a:p>
-                      <a:pPr lvl="0" indent="0" marL="0">
-                        <a:buNone/>
-                      </a:pPr>
-                      <a:r>
-                        <a:rPr/>
-                        <a:t>6.4</a:t>
-                      </a:r>
-                    </a:p>
-                  </a:txBody>
-                </a:tc>
-                <a:tc>
-                  <a:txBody>
-                    <a:bodyPr/>
-                    <a:lstStyle/>
-                    <a:p>
-                      <a:pPr lvl="0" indent="0" marL="0">
-                        <a:buNone/>
-                      </a:pPr>
-                      <a:r>
-                        <a:rPr/>
-                        <a:t>51.8</a:t>
-                      </a:r>
-                    </a:p>
-                  </a:txBody>
-                </a:tc>
-                <a:tc>
-                  <a:txBody>
-                    <a:bodyPr/>
-                    <a:lstStyle/>
-                    <a:p>
-                      <a:pPr lvl="0" indent="0" marL="0">
-                        <a:buNone/>
-                      </a:pPr>
-                      <a:r>
-                        <a:rPr/>
-                        <a:t>113.92</a:t>
+                        <a:t>15</a:t>
+                      </a:r>
+                    </a:p>
+                  </a:txBody>
+                </a:tc>
+                <a:tc>
+                  <a:txBody>
+                    <a:bodyPr/>
+                    <a:lstStyle/>
+                    <a:p>
+                      <a:pPr lvl="0" indent="0" marL="0">
+                        <a:buNone/>
+                      </a:pPr>
+                      <a:r>
+                        <a:rPr/>
+                        <a:t>white fir</a:t>
                       </a:r>
                     </a:p>
                   </a:txBody>
@@ -5330,9 +5600,12 @@
                 <a:tableStyleId>{5C22544A-7EE6-4342-B048-85BDC9FD1C3A}</a:tableStyleId>
               </a:tblPr>
               <a:tblGrid>
-                <a:gridCol w="2743200"/>
-                <a:gridCol w="2743200"/>
-                <a:gridCol w="2743200"/>
+                <a:gridCol w="1371600"/>
+                <a:gridCol w="1371600"/>
+                <a:gridCol w="1371600"/>
+                <a:gridCol w="1371600"/>
+                <a:gridCol w="1371600"/>
+                <a:gridCol w="1371600"/>
               </a:tblGrid>
               <a:tr h="0">
                 <a:tc>
@@ -5371,6 +5644,54 @@
                       </a:pPr>
                       <a:r>
                         <a:rPr/>
+                        <a:t>DO_BH</a:t>
+                      </a:r>
+                    </a:p>
+                  </a:txBody>
+                  <a:tcPr/>
+                </a:tc>
+                <a:tc>
+                  <a:txBody>
+                    <a:bodyPr/>
+                    <a:lstStyle/>
+                    <a:p>
+                      <a:pPr lvl="0" indent="0" marL="0">
+                        <a:buNone/>
+                      </a:pPr>
+                      <a:r>
+                        <a:rPr/>
+                        <a:t>HT_TOT</a:t>
+                      </a:r>
+                    </a:p>
+                  </a:txBody>
+                  <a:tcPr/>
+                </a:tc>
+                <a:tc>
+                  <a:txBody>
+                    <a:bodyPr/>
+                    <a:lstStyle/>
+                    <a:p>
+                      <a:pPr lvl="0" indent="0" marL="0">
+                        <a:buNone/>
+                      </a:pPr>
+                      <a:r>
+                        <a:rPr/>
+                        <a:t>TT_DW_CRM</a:t>
+                      </a:r>
+                    </a:p>
+                  </a:txBody>
+                  <a:tcPr/>
+                </a:tc>
+                <a:tc>
+                  <a:txBody>
+                    <a:bodyPr/>
+                    <a:lstStyle/>
+                    <a:p>
+                      <a:pPr lvl="0" indent="0" marL="0">
+                        <a:buNone/>
+                      </a:pPr>
+                      <a:r>
+                        <a:rPr/>
                         <a:t>COMMON_NAME</a:t>
                       </a:r>
                     </a:p>
@@ -5404,22 +5725,67 @@
                       </a:pPr>
                       <a:r>
                         <a:rPr/>
-                        <a:t>10</a:t>
-                      </a:r>
-                    </a:p>
-                  </a:txBody>
-                </a:tc>
-                <a:tc>
-                  <a:txBody>
-                    <a:bodyPr/>
-                    <a:lstStyle/>
-                    <a:p>
-                      <a:pPr lvl="0" indent="0" marL="0">
-                        <a:buNone/>
-                      </a:pPr>
-                      <a:r>
-                        <a:rPr/>
-                        <a:t>fir spp.</a:t>
+                        <a:t>12</a:t>
+                      </a:r>
+                    </a:p>
+                  </a:txBody>
+                </a:tc>
+                <a:tc>
+                  <a:txBody>
+                    <a:bodyPr/>
+                    <a:lstStyle/>
+                    <a:p>
+                      <a:pPr lvl="0" indent="0" marL="0">
+                        <a:buNone/>
+                      </a:pPr>
+                      <a:r>
+                        <a:rPr/>
+                        <a:t>7.5</a:t>
+                      </a:r>
+                    </a:p>
+                  </a:txBody>
+                </a:tc>
+                <a:tc>
+                  <a:txBody>
+                    <a:bodyPr/>
+                    <a:lstStyle/>
+                    <a:p>
+                      <a:pPr lvl="0" indent="0" marL="0">
+                        <a:buNone/>
+                      </a:pPr>
+                      <a:r>
+                        <a:rPr/>
+                        <a:t>45.2</a:t>
+                      </a:r>
+                    </a:p>
+                  </a:txBody>
+                </a:tc>
+                <a:tc>
+                  <a:txBody>
+                    <a:bodyPr/>
+                    <a:lstStyle/>
+                    <a:p>
+                      <a:pPr lvl="0" indent="0" marL="0">
+                        <a:buNone/>
+                      </a:pPr>
+                      <a:r>
+                        <a:rPr/>
+                        <a:t>178.86</a:t>
+                      </a:r>
+                    </a:p>
+                  </a:txBody>
+                </a:tc>
+                <a:tc>
+                  <a:txBody>
+                    <a:bodyPr/>
+                    <a:lstStyle/>
+                    <a:p>
+                      <a:pPr lvl="0" indent="0" marL="0">
+                        <a:buNone/>
+                      </a:pPr>
+                      <a:r>
+                        <a:rPr/>
+                        <a:t>balsam fir</a:t>
                       </a:r>
                     </a:p>
                   </a:txBody>
@@ -5451,22 +5817,67 @@
                       </a:pPr>
                       <a:r>
                         <a:rPr/>
-                        <a:t>11</a:t>
-                      </a:r>
-                    </a:p>
-                  </a:txBody>
-                </a:tc>
-                <a:tc>
-                  <a:txBody>
-                    <a:bodyPr/>
-                    <a:lstStyle/>
-                    <a:p>
-                      <a:pPr lvl="0" indent="0" marL="0">
-                        <a:buNone/>
-                      </a:pPr>
-                      <a:r>
-                        <a:rPr/>
-                        <a:t>Pacific silver fir</a:t>
+                        <a:t>12</a:t>
+                      </a:r>
+                    </a:p>
+                  </a:txBody>
+                </a:tc>
+                <a:tc>
+                  <a:txBody>
+                    <a:bodyPr/>
+                    <a:lstStyle/>
+                    <a:p>
+                      <a:pPr lvl="0" indent="0" marL="0">
+                        <a:buNone/>
+                      </a:pPr>
+                      <a:r>
+                        <a:rPr/>
+                        <a:t>9.3</a:t>
+                      </a:r>
+                    </a:p>
+                  </a:txBody>
+                </a:tc>
+                <a:tc>
+                  <a:txBody>
+                    <a:bodyPr/>
+                    <a:lstStyle/>
+                    <a:p>
+                      <a:pPr lvl="0" indent="0" marL="0">
+                        <a:buNone/>
+                      </a:pPr>
+                      <a:r>
+                        <a:rPr/>
+                        <a:t>62.7</a:t>
+                      </a:r>
+                    </a:p>
+                  </a:txBody>
+                </a:tc>
+                <a:tc>
+                  <a:txBody>
+                    <a:bodyPr/>
+                    <a:lstStyle/>
+                    <a:p>
+                      <a:pPr lvl="0" indent="0" marL="0">
+                        <a:buNone/>
+                      </a:pPr>
+                      <a:r>
+                        <a:rPr/>
+                        <a:t>323.46</a:t>
+                      </a:r>
+                    </a:p>
+                  </a:txBody>
+                </a:tc>
+                <a:tc>
+                  <a:txBody>
+                    <a:bodyPr/>
+                    <a:lstStyle/>
+                    <a:p>
+                      <a:pPr lvl="0" indent="0" marL="0">
+                        <a:buNone/>
+                      </a:pPr>
+                      <a:r>
+                        <a:rPr/>
+                        <a:t>balsam fir</a:t>
                       </a:r>
                     </a:p>
                   </a:txBody>
@@ -5513,6 +5924,51 @@
                       </a:pPr>
                       <a:r>
                         <a:rPr/>
+                        <a:t>9.7</a:t>
+                      </a:r>
+                    </a:p>
+                  </a:txBody>
+                </a:tc>
+                <a:tc>
+                  <a:txBody>
+                    <a:bodyPr/>
+                    <a:lstStyle/>
+                    <a:p>
+                      <a:pPr lvl="0" indent="0" marL="0">
+                        <a:buNone/>
+                      </a:pPr>
+                      <a:r>
+                        <a:rPr/>
+                        <a:t>56.7</a:t>
+                      </a:r>
+                    </a:p>
+                  </a:txBody>
+                </a:tc>
+                <a:tc>
+                  <a:txBody>
+                    <a:bodyPr/>
+                    <a:lstStyle/>
+                    <a:p>
+                      <a:pPr lvl="0" indent="0" marL="0">
+                        <a:buNone/>
+                      </a:pPr>
+                      <a:r>
+                        <a:rPr/>
+                        <a:t>342.47</a:t>
+                      </a:r>
+                    </a:p>
+                  </a:txBody>
+                </a:tc>
+                <a:tc>
+                  <a:txBody>
+                    <a:bodyPr/>
+                    <a:lstStyle/>
+                    <a:p>
+                      <a:pPr lvl="0" indent="0" marL="0">
+                        <a:buNone/>
+                      </a:pPr>
+                      <a:r>
+                        <a:rPr/>
                         <a:t>balsam fir</a:t>
                       </a:r>
                     </a:p>
@@ -5545,22 +6001,67 @@
                       </a:pPr>
                       <a:r>
                         <a:rPr/>
-                        <a:t>14</a:t>
-                      </a:r>
-                    </a:p>
-                  </a:txBody>
-                </a:tc>
-                <a:tc>
-                  <a:txBody>
-                    <a:bodyPr/>
-                    <a:lstStyle/>
-                    <a:p>
-                      <a:pPr lvl="0" indent="0" marL="0">
-                        <a:buNone/>
-                      </a:pPr>
-                      <a:r>
-                        <a:rPr/>
-                        <a:t>Santa Lucia or bristlecone fir</a:t>
+                        <a:t>12</a:t>
+                      </a:r>
+                    </a:p>
+                  </a:txBody>
+                </a:tc>
+                <a:tc>
+                  <a:txBody>
+                    <a:bodyPr/>
+                    <a:lstStyle/>
+                    <a:p>
+                      <a:pPr lvl="0" indent="0" marL="0">
+                        <a:buNone/>
+                      </a:pPr>
+                      <a:r>
+                        <a:rPr/>
+                        <a:t>11.4</a:t>
+                      </a:r>
+                    </a:p>
+                  </a:txBody>
+                </a:tc>
+                <a:tc>
+                  <a:txBody>
+                    <a:bodyPr/>
+                    <a:lstStyle/>
+                    <a:p>
+                      <a:pPr lvl="0" indent="0" marL="0">
+                        <a:buNone/>
+                      </a:pPr>
+                      <a:r>
+                        <a:rPr/>
+                        <a:t>66.1</a:t>
+                      </a:r>
+                    </a:p>
+                  </a:txBody>
+                </a:tc>
+                <a:tc>
+                  <a:txBody>
+                    <a:bodyPr/>
+                    <a:lstStyle/>
+                    <a:p>
+                      <a:pPr lvl="0" indent="0" marL="0">
+                        <a:buNone/>
+                      </a:pPr>
+                      <a:r>
+                        <a:rPr/>
+                        <a:t>499.35</a:t>
+                      </a:r>
+                    </a:p>
+                  </a:txBody>
+                </a:tc>
+                <a:tc>
+                  <a:txBody>
+                    <a:bodyPr/>
+                    <a:lstStyle/>
+                    <a:p>
+                      <a:pPr lvl="0" indent="0" marL="0">
+                        <a:buNone/>
+                      </a:pPr>
+                      <a:r>
+                        <a:rPr/>
+                        <a:t>balsam fir</a:t>
                       </a:r>
                     </a:p>
                   </a:txBody>
@@ -5592,22 +6093,67 @@
                       </a:pPr>
                       <a:r>
                         <a:rPr/>
-                        <a:t>15</a:t>
-                      </a:r>
-                    </a:p>
-                  </a:txBody>
-                </a:tc>
-                <a:tc>
-                  <a:txBody>
-                    <a:bodyPr/>
-                    <a:lstStyle/>
-                    <a:p>
-                      <a:pPr lvl="0" indent="0" marL="0">
-                        <a:buNone/>
-                      </a:pPr>
-                      <a:r>
-                        <a:rPr/>
-                        <a:t>white fir</a:t>
+                        <a:t>12</a:t>
+                      </a:r>
+                    </a:p>
+                  </a:txBody>
+                </a:tc>
+                <a:tc>
+                  <a:txBody>
+                    <a:bodyPr/>
+                    <a:lstStyle/>
+                    <a:p>
+                      <a:pPr lvl="0" indent="0" marL="0">
+                        <a:buNone/>
+                      </a:pPr>
+                      <a:r>
+                        <a:rPr/>
+                        <a:t>6.4</a:t>
+                      </a:r>
+                    </a:p>
+                  </a:txBody>
+                </a:tc>
+                <a:tc>
+                  <a:txBody>
+                    <a:bodyPr/>
+                    <a:lstStyle/>
+                    <a:p>
+                      <a:pPr lvl="0" indent="0" marL="0">
+                        <a:buNone/>
+                      </a:pPr>
+                      <a:r>
+                        <a:rPr/>
+                        <a:t>51.8</a:t>
+                      </a:r>
+                    </a:p>
+                  </a:txBody>
+                </a:tc>
+                <a:tc>
+                  <a:txBody>
+                    <a:bodyPr/>
+                    <a:lstStyle/>
+                    <a:p>
+                      <a:pPr lvl="0" indent="0" marL="0">
+                        <a:buNone/>
+                      </a:pPr>
+                      <a:r>
+                        <a:rPr/>
+                        <a:t>113.92</a:t>
+                      </a:r>
+                    </a:p>
+                  </a:txBody>
+                </a:tc>
+                <a:tc>
+                  <a:txBody>
+                    <a:bodyPr/>
+                    <a:lstStyle/>
+                    <a:p>
+                      <a:pPr lvl="0" indent="0" marL="0">
+                        <a:buNone/>
+                      </a:pPr>
+                      <a:r>
+                        <a:rPr/>
+                        <a:t>balsam fir</a:t>
                       </a:r>
                     </a:p>
                   </a:txBody>
@@ -5623,612 +6169,6 @@
 </file>
 
 <file path=ppt/slides/slide16.xml><?xml version="1.0" encoding="utf-8"?>
-<p:sld xmlns:a="http://schemas.openxmlformats.org/drawingml/2006/main" xmlns:r="http://schemas.openxmlformats.org/officeDocument/2006/relationships" xmlns:p="http://schemas.openxmlformats.org/presentationml/2006/main">
-  <p:cSld>
-    <p:spTree>
-      <p:nvGrpSpPr>
-        <p:cNvPr id="1" name=""/>
-        <p:cNvGrpSpPr/>
-        <p:nvPr/>
-      </p:nvGrpSpPr>
-      <p:grpSpPr>
-        <a:xfrm>
-          <a:off x="0" y="0"/>
-          <a:ext cx="0" cy="0"/>
-          <a:chOff x="0" y="0"/>
-          <a:chExt cx="0" cy="0"/>
-        </a:xfrm>
-      </p:grpSpPr>
-      <p:graphicFrame>
-        <p:nvGraphicFramePr>
-          <p:cNvPr id="6" name="Content Placeholder 5"/>
-          <p:cNvGraphicFramePr>
-            <a:graphicFrameLocks noGrp="1"/>
-          </p:cNvGraphicFramePr>
-          <p:nvPr>
-            <p:ph idx="1"/>
-          </p:nvPr>
-        </p:nvGraphicFramePr>
-        <p:xfrm>
-          <a:off x="457200" y="1193800"/>
-          <a:ext cx="8229600" cy="3390900"/>
-        </p:xfrm>
-        <a:graphic>
-          <a:graphicData uri="http://schemas.openxmlformats.org/drawingml/2006/table">
-            <a:tbl>
-              <a:tblPr firstRow="1" bandRow="1">
-                <a:tableStyleId>{5C22544A-7EE6-4342-B048-85BDC9FD1C3A}</a:tableStyleId>
-              </a:tblPr>
-              <a:tblGrid>
-                <a:gridCol w="1371600"/>
-                <a:gridCol w="1371600"/>
-                <a:gridCol w="1371600"/>
-                <a:gridCol w="1371600"/>
-                <a:gridCol w="1371600"/>
-                <a:gridCol w="1371600"/>
-              </a:tblGrid>
-              <a:tr h="0">
-                <a:tc>
-                  <a:txBody>
-                    <a:bodyPr/>
-                    <a:lstStyle/>
-                    <a:p>
-                      <a:endParaRPr/>
-                    </a:p>
-                  </a:txBody>
-                  <a:tcPr/>
-                </a:tc>
-                <a:tc>
-                  <a:txBody>
-                    <a:bodyPr/>
-                    <a:lstStyle/>
-                    <a:p>
-                      <a:pPr lvl="0" indent="0" marL="0">
-                        <a:buNone/>
-                      </a:pPr>
-                      <a:r>
-                        <a:rPr/>
-                        <a:t>SPCD</a:t>
-                      </a:r>
-                    </a:p>
-                  </a:txBody>
-                  <a:tcPr/>
-                </a:tc>
-                <a:tc>
-                  <a:txBody>
-                    <a:bodyPr/>
-                    <a:lstStyle/>
-                    <a:p>
-                      <a:pPr lvl="0" indent="0" marL="0">
-                        <a:buNone/>
-                      </a:pPr>
-                      <a:r>
-                        <a:rPr/>
-                        <a:t>DO_BH</a:t>
-                      </a:r>
-                    </a:p>
-                  </a:txBody>
-                  <a:tcPr/>
-                </a:tc>
-                <a:tc>
-                  <a:txBody>
-                    <a:bodyPr/>
-                    <a:lstStyle/>
-                    <a:p>
-                      <a:pPr lvl="0" indent="0" marL="0">
-                        <a:buNone/>
-                      </a:pPr>
-                      <a:r>
-                        <a:rPr/>
-                        <a:t>HT_TOT</a:t>
-                      </a:r>
-                    </a:p>
-                  </a:txBody>
-                  <a:tcPr/>
-                </a:tc>
-                <a:tc>
-                  <a:txBody>
-                    <a:bodyPr/>
-                    <a:lstStyle/>
-                    <a:p>
-                      <a:pPr lvl="0" indent="0" marL="0">
-                        <a:buNone/>
-                      </a:pPr>
-                      <a:r>
-                        <a:rPr/>
-                        <a:t>TT_DW_CRM</a:t>
-                      </a:r>
-                    </a:p>
-                  </a:txBody>
-                  <a:tcPr/>
-                </a:tc>
-                <a:tc>
-                  <a:txBody>
-                    <a:bodyPr/>
-                    <a:lstStyle/>
-                    <a:p>
-                      <a:pPr lvl="0" indent="0" marL="0">
-                        <a:buNone/>
-                      </a:pPr>
-                      <a:r>
-                        <a:rPr/>
-                        <a:t>COMMON_NAME</a:t>
-                      </a:r>
-                    </a:p>
-                  </a:txBody>
-                  <a:tcPr/>
-                </a:tc>
-              </a:tr>
-              <a:tr h="0">
-                <a:tc>
-                  <a:txBody>
-                    <a:bodyPr/>
-                    <a:lstStyle/>
-                    <a:p>
-                      <a:pPr lvl="0" indent="0" marL="0">
-                        <a:buNone/>
-                      </a:pPr>
-                      <a:r>
-                        <a:rPr/>
-                        <a:t>0</a:t>
-                      </a:r>
-                    </a:p>
-                  </a:txBody>
-                </a:tc>
-                <a:tc>
-                  <a:txBody>
-                    <a:bodyPr/>
-                    <a:lstStyle/>
-                    <a:p>
-                      <a:pPr lvl="0" indent="0" marL="0">
-                        <a:buNone/>
-                      </a:pPr>
-                      <a:r>
-                        <a:rPr/>
-                        <a:t>12</a:t>
-                      </a:r>
-                    </a:p>
-                  </a:txBody>
-                </a:tc>
-                <a:tc>
-                  <a:txBody>
-                    <a:bodyPr/>
-                    <a:lstStyle/>
-                    <a:p>
-                      <a:pPr lvl="0" indent="0" marL="0">
-                        <a:buNone/>
-                      </a:pPr>
-                      <a:r>
-                        <a:rPr/>
-                        <a:t>7.5</a:t>
-                      </a:r>
-                    </a:p>
-                  </a:txBody>
-                </a:tc>
-                <a:tc>
-                  <a:txBody>
-                    <a:bodyPr/>
-                    <a:lstStyle/>
-                    <a:p>
-                      <a:pPr lvl="0" indent="0" marL="0">
-                        <a:buNone/>
-                      </a:pPr>
-                      <a:r>
-                        <a:rPr/>
-                        <a:t>45.2</a:t>
-                      </a:r>
-                    </a:p>
-                  </a:txBody>
-                </a:tc>
-                <a:tc>
-                  <a:txBody>
-                    <a:bodyPr/>
-                    <a:lstStyle/>
-                    <a:p>
-                      <a:pPr lvl="0" indent="0" marL="0">
-                        <a:buNone/>
-                      </a:pPr>
-                      <a:r>
-                        <a:rPr/>
-                        <a:t>178.86</a:t>
-                      </a:r>
-                    </a:p>
-                  </a:txBody>
-                </a:tc>
-                <a:tc>
-                  <a:txBody>
-                    <a:bodyPr/>
-                    <a:lstStyle/>
-                    <a:p>
-                      <a:pPr lvl="0" indent="0" marL="0">
-                        <a:buNone/>
-                      </a:pPr>
-                      <a:r>
-                        <a:rPr/>
-                        <a:t>balsam fir</a:t>
-                      </a:r>
-                    </a:p>
-                  </a:txBody>
-                </a:tc>
-              </a:tr>
-              <a:tr h="0">
-                <a:tc>
-                  <a:txBody>
-                    <a:bodyPr/>
-                    <a:lstStyle/>
-                    <a:p>
-                      <a:pPr lvl="0" indent="0" marL="0">
-                        <a:buNone/>
-                      </a:pPr>
-                      <a:r>
-                        <a:rPr/>
-                        <a:t>1</a:t>
-                      </a:r>
-                    </a:p>
-                  </a:txBody>
-                </a:tc>
-                <a:tc>
-                  <a:txBody>
-                    <a:bodyPr/>
-                    <a:lstStyle/>
-                    <a:p>
-                      <a:pPr lvl="0" indent="0" marL="0">
-                        <a:buNone/>
-                      </a:pPr>
-                      <a:r>
-                        <a:rPr/>
-                        <a:t>12</a:t>
-                      </a:r>
-                    </a:p>
-                  </a:txBody>
-                </a:tc>
-                <a:tc>
-                  <a:txBody>
-                    <a:bodyPr/>
-                    <a:lstStyle/>
-                    <a:p>
-                      <a:pPr lvl="0" indent="0" marL="0">
-                        <a:buNone/>
-                      </a:pPr>
-                      <a:r>
-                        <a:rPr/>
-                        <a:t>9.3</a:t>
-                      </a:r>
-                    </a:p>
-                  </a:txBody>
-                </a:tc>
-                <a:tc>
-                  <a:txBody>
-                    <a:bodyPr/>
-                    <a:lstStyle/>
-                    <a:p>
-                      <a:pPr lvl="0" indent="0" marL="0">
-                        <a:buNone/>
-                      </a:pPr>
-                      <a:r>
-                        <a:rPr/>
-                        <a:t>62.7</a:t>
-                      </a:r>
-                    </a:p>
-                  </a:txBody>
-                </a:tc>
-                <a:tc>
-                  <a:txBody>
-                    <a:bodyPr/>
-                    <a:lstStyle/>
-                    <a:p>
-                      <a:pPr lvl="0" indent="0" marL="0">
-                        <a:buNone/>
-                      </a:pPr>
-                      <a:r>
-                        <a:rPr/>
-                        <a:t>323.46</a:t>
-                      </a:r>
-                    </a:p>
-                  </a:txBody>
-                </a:tc>
-                <a:tc>
-                  <a:txBody>
-                    <a:bodyPr/>
-                    <a:lstStyle/>
-                    <a:p>
-                      <a:pPr lvl="0" indent="0" marL="0">
-                        <a:buNone/>
-                      </a:pPr>
-                      <a:r>
-                        <a:rPr/>
-                        <a:t>balsam fir</a:t>
-                      </a:r>
-                    </a:p>
-                  </a:txBody>
-                </a:tc>
-              </a:tr>
-              <a:tr h="0">
-                <a:tc>
-                  <a:txBody>
-                    <a:bodyPr/>
-                    <a:lstStyle/>
-                    <a:p>
-                      <a:pPr lvl="0" indent="0" marL="0">
-                        <a:buNone/>
-                      </a:pPr>
-                      <a:r>
-                        <a:rPr/>
-                        <a:t>2</a:t>
-                      </a:r>
-                    </a:p>
-                  </a:txBody>
-                </a:tc>
-                <a:tc>
-                  <a:txBody>
-                    <a:bodyPr/>
-                    <a:lstStyle/>
-                    <a:p>
-                      <a:pPr lvl="0" indent="0" marL="0">
-                        <a:buNone/>
-                      </a:pPr>
-                      <a:r>
-                        <a:rPr/>
-                        <a:t>12</a:t>
-                      </a:r>
-                    </a:p>
-                  </a:txBody>
-                </a:tc>
-                <a:tc>
-                  <a:txBody>
-                    <a:bodyPr/>
-                    <a:lstStyle/>
-                    <a:p>
-                      <a:pPr lvl="0" indent="0" marL="0">
-                        <a:buNone/>
-                      </a:pPr>
-                      <a:r>
-                        <a:rPr/>
-                        <a:t>9.7</a:t>
-                      </a:r>
-                    </a:p>
-                  </a:txBody>
-                </a:tc>
-                <a:tc>
-                  <a:txBody>
-                    <a:bodyPr/>
-                    <a:lstStyle/>
-                    <a:p>
-                      <a:pPr lvl="0" indent="0" marL="0">
-                        <a:buNone/>
-                      </a:pPr>
-                      <a:r>
-                        <a:rPr/>
-                        <a:t>56.7</a:t>
-                      </a:r>
-                    </a:p>
-                  </a:txBody>
-                </a:tc>
-                <a:tc>
-                  <a:txBody>
-                    <a:bodyPr/>
-                    <a:lstStyle/>
-                    <a:p>
-                      <a:pPr lvl="0" indent="0" marL="0">
-                        <a:buNone/>
-                      </a:pPr>
-                      <a:r>
-                        <a:rPr/>
-                        <a:t>342.47</a:t>
-                      </a:r>
-                    </a:p>
-                  </a:txBody>
-                </a:tc>
-                <a:tc>
-                  <a:txBody>
-                    <a:bodyPr/>
-                    <a:lstStyle/>
-                    <a:p>
-                      <a:pPr lvl="0" indent="0" marL="0">
-                        <a:buNone/>
-                      </a:pPr>
-                      <a:r>
-                        <a:rPr/>
-                        <a:t>balsam fir</a:t>
-                      </a:r>
-                    </a:p>
-                  </a:txBody>
-                </a:tc>
-              </a:tr>
-              <a:tr h="0">
-                <a:tc>
-                  <a:txBody>
-                    <a:bodyPr/>
-                    <a:lstStyle/>
-                    <a:p>
-                      <a:pPr lvl="0" indent="0" marL="0">
-                        <a:buNone/>
-                      </a:pPr>
-                      <a:r>
-                        <a:rPr/>
-                        <a:t>3</a:t>
-                      </a:r>
-                    </a:p>
-                  </a:txBody>
-                </a:tc>
-                <a:tc>
-                  <a:txBody>
-                    <a:bodyPr/>
-                    <a:lstStyle/>
-                    <a:p>
-                      <a:pPr lvl="0" indent="0" marL="0">
-                        <a:buNone/>
-                      </a:pPr>
-                      <a:r>
-                        <a:rPr/>
-                        <a:t>12</a:t>
-                      </a:r>
-                    </a:p>
-                  </a:txBody>
-                </a:tc>
-                <a:tc>
-                  <a:txBody>
-                    <a:bodyPr/>
-                    <a:lstStyle/>
-                    <a:p>
-                      <a:pPr lvl="0" indent="0" marL="0">
-                        <a:buNone/>
-                      </a:pPr>
-                      <a:r>
-                        <a:rPr/>
-                        <a:t>11.4</a:t>
-                      </a:r>
-                    </a:p>
-                  </a:txBody>
-                </a:tc>
-                <a:tc>
-                  <a:txBody>
-                    <a:bodyPr/>
-                    <a:lstStyle/>
-                    <a:p>
-                      <a:pPr lvl="0" indent="0" marL="0">
-                        <a:buNone/>
-                      </a:pPr>
-                      <a:r>
-                        <a:rPr/>
-                        <a:t>66.1</a:t>
-                      </a:r>
-                    </a:p>
-                  </a:txBody>
-                </a:tc>
-                <a:tc>
-                  <a:txBody>
-                    <a:bodyPr/>
-                    <a:lstStyle/>
-                    <a:p>
-                      <a:pPr lvl="0" indent="0" marL="0">
-                        <a:buNone/>
-                      </a:pPr>
-                      <a:r>
-                        <a:rPr/>
-                        <a:t>499.35</a:t>
-                      </a:r>
-                    </a:p>
-                  </a:txBody>
-                </a:tc>
-                <a:tc>
-                  <a:txBody>
-                    <a:bodyPr/>
-                    <a:lstStyle/>
-                    <a:p>
-                      <a:pPr lvl="0" indent="0" marL="0">
-                        <a:buNone/>
-                      </a:pPr>
-                      <a:r>
-                        <a:rPr/>
-                        <a:t>balsam fir</a:t>
-                      </a:r>
-                    </a:p>
-                  </a:txBody>
-                </a:tc>
-              </a:tr>
-              <a:tr h="0">
-                <a:tc>
-                  <a:txBody>
-                    <a:bodyPr/>
-                    <a:lstStyle/>
-                    <a:p>
-                      <a:pPr lvl="0" indent="0" marL="0">
-                        <a:buNone/>
-                      </a:pPr>
-                      <a:r>
-                        <a:rPr/>
-                        <a:t>4</a:t>
-                      </a:r>
-                    </a:p>
-                  </a:txBody>
-                </a:tc>
-                <a:tc>
-                  <a:txBody>
-                    <a:bodyPr/>
-                    <a:lstStyle/>
-                    <a:p>
-                      <a:pPr lvl="0" indent="0" marL="0">
-                        <a:buNone/>
-                      </a:pPr>
-                      <a:r>
-                        <a:rPr/>
-                        <a:t>12</a:t>
-                      </a:r>
-                    </a:p>
-                  </a:txBody>
-                </a:tc>
-                <a:tc>
-                  <a:txBody>
-                    <a:bodyPr/>
-                    <a:lstStyle/>
-                    <a:p>
-                      <a:pPr lvl="0" indent="0" marL="0">
-                        <a:buNone/>
-                      </a:pPr>
-                      <a:r>
-                        <a:rPr/>
-                        <a:t>6.4</a:t>
-                      </a:r>
-                    </a:p>
-                  </a:txBody>
-                </a:tc>
-                <a:tc>
-                  <a:txBody>
-                    <a:bodyPr/>
-                    <a:lstStyle/>
-                    <a:p>
-                      <a:pPr lvl="0" indent="0" marL="0">
-                        <a:buNone/>
-                      </a:pPr>
-                      <a:r>
-                        <a:rPr/>
-                        <a:t>51.8</a:t>
-                      </a:r>
-                    </a:p>
-                  </a:txBody>
-                </a:tc>
-                <a:tc>
-                  <a:txBody>
-                    <a:bodyPr/>
-                    <a:lstStyle/>
-                    <a:p>
-                      <a:pPr lvl="0" indent="0" marL="0">
-                        <a:buNone/>
-                      </a:pPr>
-                      <a:r>
-                        <a:rPr/>
-                        <a:t>113.92</a:t>
-                      </a:r>
-                    </a:p>
-                  </a:txBody>
-                </a:tc>
-                <a:tc>
-                  <a:txBody>
-                    <a:bodyPr/>
-                    <a:lstStyle/>
-                    <a:p>
-                      <a:pPr lvl="0" indent="0" marL="0">
-                        <a:buNone/>
-                      </a:pPr>
-                      <a:r>
-                        <a:rPr/>
-                        <a:t>balsam fir</a:t>
-                      </a:r>
-                    </a:p>
-                  </a:txBody>
-                </a:tc>
-              </a:tr>
-            </a:tbl>
-          </a:graphicData>
-        </a:graphic>
-      </p:graphicFrame>
-    </p:spTree>
-  </p:cSld>
-</p:sld>
-</file>
-
-<file path=ppt/slides/slide17.xml><?xml version="1.0" encoding="utf-8"?>
 <p:sld xmlns:a="http://schemas.openxmlformats.org/drawingml/2006/main" xmlns:r="http://schemas.openxmlformats.org/officeDocument/2006/relationships" xmlns:p="http://schemas.openxmlformats.org/presentationml/2006/main">
   <p:cSld>
     <p:spTree>
@@ -7587,7 +7527,7 @@
             </a:pPr>
             <a:r>
               <a:rPr/>
-              <a:t>Model General Information</a:t>
+              <a:t>Model Domain Information</a:t>
             </a:r>
           </a:p>
         </p:txBody>
@@ -7626,7 +7566,7 @@
             </a:r>
             <a:r>
               <a:rPr/>
-              <a:t> FIA species code (categorical). Valid species only include species in the dataset with a count greater than 100.</a:t>
+              <a:t> FIA species code (categorical). Only includes species in the full dataset with a count greater than 100.</a:t>
             </a:r>
           </a:p>
           <a:p>
@@ -7637,7 +7577,7 @@
             </a:r>
             <a:r>
               <a:rPr/>
-              <a:t> Diameter at breast height, measured in </a:t>
+              <a:t> Diameter, measured in </a:t>
             </a:r>
             <a:r>
               <a:rPr b="1"/>
@@ -7645,7 +7585,7 @@
             </a:r>
             <a:r>
               <a:rPr/>
-              <a:t>. Valid Range: 1.0-255.9 inches (based on training data)</a:t>
+              <a:t>. Valid Range: 1.0-255.9 inches (based on training data mins and maxes)</a:t>
             </a:r>
           </a:p>
           <a:p>
@@ -7656,7 +7596,7 @@
             </a:r>
             <a:r>
               <a:rPr/>
-              <a:t> Total tree height, measured in </a:t>
+              <a:t> Height, measured in </a:t>
             </a:r>
             <a:r>
               <a:rPr b="1"/>

</xml_diff>

<commit_message>
fixing slide display issues
</commit_message>
<xml_diff>
--- a/Project-3/individual-models/data/presentation.pptx
+++ b/Project-3/individual-models/data/presentation.pptx
@@ -6439,14 +6439,22 @@
             <a:pPr lvl="0"/>
             <a:r>
               <a:rPr/>
-              <a:t>SPCD (Species Code): A numeric code which unqiuely identifies each tree species as specifed by the FIA (Forest Inventory and Analysis) species coding system. Each FIA species code corresponds uniquely to a scientific and common name. (Official definition: FIA species code.)</a:t>
+              <a:t>SPCD (FIA Species Code): A numeric code which unqiuely identifies each tree species and corresponds to a scientific and common name for the tree as specified by the FIA (Forest Inventory and Analysis) species coding system.</a:t>
             </a:r>
           </a:p>
           <a:p>
             <a:pPr lvl="0"/>
             <a:r>
               <a:rPr/>
-              <a:t>DO_BH (Diameter at Breast Height [Outside Bark]): Diameter of the tree stem measured at breast height (4.5 feet or 1.37 meters above ground) including bark. This is the standard foresty measurement “DBH (outside bark)” and is the primary size variable used in nearly all allometric biomass models. This is measured in inches.</a:t>
+              <a:t>DO_BH (Diameter at Breast Height): Diameter of the tree stem measured at breast height (4.5 feet or 1.37 meters above ground) including bark. This is the standard foresty measurement “DBH (outside bark)” and is the primary size variable used in nearly all allometric biomass models. This is measured in </a:t>
+            </a:r>
+            <a:r>
+              <a:rPr b="1"/>
+              <a:t>inches</a:t>
+            </a:r>
+            <a:r>
+              <a:rPr/>
+              <a:t>.</a:t>
             </a:r>
           </a:p>
         </p:txBody>
@@ -6516,14 +6524,30 @@
             <a:pPr lvl="0"/>
             <a:r>
               <a:rPr/>
-              <a:t>HT_TOT (Total Tree Height): The total height of the tree measured from ground level to the top of the crown. Used as a second size metric in volume and biomass modeling.This is measured in feet.</a:t>
+              <a:t>HT_TOT (Total Tree Height): The total height of the tree measured from ground level to the top of the crown. Used as a second size metric in volume and biomass modeling. This is measured in </a:t>
+            </a:r>
+            <a:r>
+              <a:rPr b="1"/>
+              <a:t>feet</a:t>
+            </a:r>
+            <a:r>
+              <a:rPr/>
+              <a:t>.</a:t>
             </a:r>
           </a:p>
           <a:p>
             <a:pPr lvl="0"/>
             <a:r>
               <a:rPr/>
-              <a:t>TT_DW_CRM (Total Tree Dry Biomass): The total above-ground dry weight of the tree (includes stem wood, stem bark, branches, folliage). This value comes from destructive sampling: the tree was felled, seperated into componenets, oven-dried, and weighed. This variable serves as the response variable (“target”) from biomass prediction. This is measured in kilograms.</a:t>
+              <a:t>TT_DW_CRM (Total Tree Dry Biomass): The total above-ground dry weight of the tree (includes stem wood, stem bark, branches, folliage). The value comes from destructive sampling: the tree was felled, separated into componenets, oven-dried, and weighed. This variable serves as the target variable from biomass prediction. Measured in </a:t>
+            </a:r>
+            <a:r>
+              <a:rPr b="1"/>
+              <a:t>kilograms</a:t>
+            </a:r>
+            <a:r>
+              <a:rPr/>
+              <a:t>.</a:t>
             </a:r>
           </a:p>
         </p:txBody>

</xml_diff>